<commit_message>
Naklady predelany do excelu upravena prezentace
</commit_message>
<xml_diff>
--- a/Docs/TrainLoop_prezentace.pptx
+++ b/Docs/TrainLoop_prezentace.pptx
@@ -4,6 +4,9 @@
   <p:sldMasterIdLst>
     <p:sldMasterId id="2147483648" r:id="rId1"/>
   </p:sldMasterIdLst>
+  <p:notesMasterIdLst>
+    <p:notesMasterId r:id="rId12"/>
+  </p:notesMasterIdLst>
   <p:sldIdLst>
     <p:sldId id="256" r:id="rId2"/>
     <p:sldId id="257" r:id="rId3"/>
@@ -15,13 +18,8 @@
     <p:sldId id="263" r:id="rId9"/>
     <p:sldId id="264" r:id="rId10"/>
     <p:sldId id="265" r:id="rId11"/>
-    <p:sldId id="266" r:id="rId12"/>
-    <p:sldId id="267" r:id="rId13"/>
   </p:sldIdLst>
-  <p:notesMasterIdLst>
-    <p:notesMasterId r:id="rId14"/>
-  </p:notesMasterIdLst>
-  <p:sldSz cx="9144000" cy="5143500"/>
+  <p:sldSz cx="9144000" cy="5143500" type="screen16x9"/>
   <p:notesSz cx="5143500" cy="9144000"/>
   <p:defaultTextStyle>
     <a:lvl1pPr marL="0" algn="l" defTabSz="914400" rtl="0" eaLnBrk="1" latinLnBrk="0" hangingPunct="1">
@@ -118,23 +116,23 @@
   <p:extLst>
     <p:ext uri="{521415D9-36F7-43E2-AB2F-B90AF26B5E84}">
       <p14:sectionLst xmlns:p14="http://schemas.microsoft.com/office/powerpoint/2010/main">
-        <p14:section name="Úvod" id="{4158f83b-d457-c380-ba14-89921a8ea703}">
+        <p14:section name="Úvod" id="{4158F83B-D457-C380-BA14-89921A8EA703}">
           <p14:sldIdLst>
             <p14:sldId id="256"/>
             <p14:sldId id="257"/>
           </p14:sldIdLst>
         </p14:section>
-        <p14:section name="Lean Canvas" id="{42dde070-6149-d673-50ed-8c1bd64ac784}">
+        <p14:section name="Lean Canvas" id="{42DDE070-6149-D673-50ED-8C1BD64AC784}">
           <p14:sldIdLst>
             <p14:sldId id="258"/>
           </p14:sldIdLst>
         </p14:section>
-        <p14:section name="Feature breakdown" id="{fcb245bc-88f0-8361-58da-0203f0449886}">
+        <p14:section name="Feature breakdown" id="{FCB245BC-88F0-8361-58DA-0203F0449886}">
           <p14:sldIdLst>
             <p14:sldId id="259"/>
           </p14:sldIdLst>
         </p14:section>
-        <p14:section name="Rozhovor" id="{fae15b04-544d-8bf1-cf2d-89b31624a8b6}">
+        <p14:section name="Rozhovor" id="{FAE15B04-544D-8BF1-CF2D-89B31624A8B6}">
           <p14:sldIdLst>
             <p14:sldId id="260"/>
             <p14:sldId id="261"/>
@@ -142,16 +140,14 @@
             <p14:sldId id="263"/>
           </p14:sldIdLst>
         </p14:section>
-        <p14:section name="Product Backlog" id="{f645c0ff-2684-3f17-df68-32d364c3ac5a}">
+        <p14:section name="Product Backlog" id="{F645C0FF-2684-3F17-DF68-32D364C3AC5A}">
           <p14:sldIdLst>
             <p14:sldId id="264"/>
           </p14:sldIdLst>
         </p14:section>
-        <p14:section name="Design" id="{6b88deac-68da-2e02-cf89-aada430156f1}">
+        <p14:section name="Design" id="{6B88DEAC-68DA-2E02-CF89-AADA430156F1}">
           <p14:sldIdLst>
             <p14:sldId id="265"/>
-            <p14:sldId id="266"/>
-            <p14:sldId id="267"/>
           </p14:sldIdLst>
         </p14:section>
       </p14:sectionLst>
@@ -185,234 +181,10 @@
           <a:chExt cx="0" cy="0"/>
         </a:xfrm>
       </p:grpSpPr>
-      <p:sp>
-        <p:nvSpPr>
-          <p:cNvPr id="2" name="Header Placeholder 1"/>
-          <p:cNvSpPr>
-            <a:spLocks noGrp="1"/>
-          </p:cNvSpPr>
-          <p:nvPr>
-            <p:ph type="hdr" sz="quarter"/>
-          </p:nvPr>
-        </p:nvSpPr>
-        <p:spPr>
-          <a:xfrm>
-            <a:off x="0" y="0"/>
-            <a:ext cx="2971800" cy="458788"/>
-          </a:xfrm>
-          <a:prstGeom prst="rect">
-            <a:avLst/>
-          </a:prstGeom>
-        </p:spPr>
-        <p:txBody>
-          <a:bodyPr vert="horz" lIns="91440" tIns="45720" rIns="91440" bIns="45720" rtlCol="0"/>
-          <a:lstStyle>
-            <a:lvl1pPr algn="l">
-              <a:defRPr sz="1200"/>
-            </a:lvl1pPr>
-          </a:lstStyle>
-          <a:p>
-            <a:endParaRPr lang="en-US"/>
-          </a:p>
-        </p:txBody>
-      </p:sp>
-      <p:sp>
-        <p:nvSpPr>
-          <p:cNvPr id="3" name="Date Placeholder 2"/>
-          <p:cNvSpPr>
-            <a:spLocks noGrp="1"/>
-          </p:cNvSpPr>
-          <p:nvPr>
-            <p:ph type="dt" idx="1"/>
-          </p:nvPr>
-        </p:nvSpPr>
-        <p:spPr>
-          <a:xfrm>
-            <a:off x="3884613" y="0"/>
-            <a:ext cx="2971800" cy="458788"/>
-          </a:xfrm>
-          <a:prstGeom prst="rect">
-            <a:avLst/>
-          </a:prstGeom>
-        </p:spPr>
-        <p:txBody>
-          <a:bodyPr vert="horz" lIns="91440" tIns="45720" rIns="91440" bIns="45720" rtlCol="0"/>
-          <a:lstStyle>
-            <a:lvl1pPr algn="r">
-              <a:defRPr sz="1200"/>
-            </a:lvl1pPr>
-          </a:lstStyle>
-          <a:p>
-            <a:fld id="{5282F153-3F37-0F45-9E97-73ACFA13230C}" type="datetimeFigureOut">
-              <a:rPr lang="en-US"/>
-              <a:t>7/23/19</a:t>
-            </a:fld>
-            <a:endParaRPr lang="en-US"/>
-          </a:p>
-        </p:txBody>
-      </p:sp>
-      <p:sp>
-        <p:nvSpPr>
-          <p:cNvPr id="4" name="Slide Image Placeholder 3"/>
-          <p:cNvSpPr>
-            <a:spLocks noGrp="1" noRot="1" noChangeAspect="1"/>
-          </p:cNvSpPr>
-          <p:nvPr>
-            <p:ph type="sldImg" idx="2"/>
-          </p:nvPr>
-        </p:nvSpPr>
-        <p:spPr>
-          <a:xfrm>
-            <a:off x="685800" y="1143000"/>
-            <a:ext cx="5486400" cy="3086100"/>
-          </a:xfrm>
-          <a:prstGeom prst="rect">
-            <a:avLst/>
-          </a:prstGeom>
-          <a:noFill/>
-          <a:ln w="12700">
-            <a:solidFill>
-              <a:prstClr val="black"/>
-            </a:solidFill>
-          </a:ln>
-        </p:spPr>
-        <p:txBody>
-          <a:bodyPr vert="horz" lIns="91440" tIns="45720" rIns="91440" bIns="45720" rtlCol="0" anchor="ctr"/>
-          <a:lstStyle/>
-          <a:p>
-            <a:endParaRPr lang="en-US"/>
-          </a:p>
-        </p:txBody>
-      </p:sp>
-      <p:sp>
-        <p:nvSpPr>
-          <p:cNvPr id="5" name="Notes Placeholder 4"/>
-          <p:cNvSpPr>
-            <a:spLocks noGrp="1"/>
-          </p:cNvSpPr>
-          <p:nvPr>
-            <p:ph type="body" sz="quarter" idx="3"/>
-          </p:nvPr>
-        </p:nvSpPr>
-        <p:spPr>
-          <a:xfrm>
-            <a:off x="685800" y="4400550"/>
-            <a:ext cx="5486400" cy="3600450"/>
-          </a:xfrm>
-          <a:prstGeom prst="rect">
-            <a:avLst/>
-          </a:prstGeom>
-        </p:spPr>
-        <p:txBody>
-          <a:bodyPr vert="horz" lIns="91440" tIns="45720" rIns="91440" bIns="45720" rtlCol="0"/>
-          <a:lstStyle/>
-          <a:p>
-            <a:pPr lvl="0"/>
-            <a:r>
-              <a:rPr lang="en-US"/>
-              <a:t>Click to edit Master text styles</a:t>
-            </a:r>
-          </a:p>
-          <a:p>
-            <a:pPr lvl="1"/>
-            <a:r>
-              <a:rPr lang="en-US"/>
-              <a:t>Second level</a:t>
-            </a:r>
-          </a:p>
-          <a:p>
-            <a:pPr lvl="2"/>
-            <a:r>
-              <a:rPr lang="en-US"/>
-              <a:t>Third level</a:t>
-            </a:r>
-          </a:p>
-          <a:p>
-            <a:pPr lvl="3"/>
-            <a:r>
-              <a:rPr lang="en-US"/>
-              <a:t>Fourth level</a:t>
-            </a:r>
-          </a:p>
-          <a:p>
-            <a:pPr lvl="4"/>
-            <a:r>
-              <a:rPr lang="en-US"/>
-              <a:t>Fifth level</a:t>
-            </a:r>
-          </a:p>
-        </p:txBody>
-      </p:sp>
-      <p:sp>
-        <p:nvSpPr>
-          <p:cNvPr id="6" name="Footer Placeholder 5"/>
-          <p:cNvSpPr>
-            <a:spLocks noGrp="1"/>
-          </p:cNvSpPr>
-          <p:nvPr>
-            <p:ph type="ftr" sz="quarter" idx="4"/>
-          </p:nvPr>
-        </p:nvSpPr>
-        <p:spPr>
-          <a:xfrm>
-            <a:off x="0" y="8685213"/>
-            <a:ext cx="2971800" cy="458787"/>
-          </a:xfrm>
-          <a:prstGeom prst="rect">
-            <a:avLst/>
-          </a:prstGeom>
-        </p:spPr>
-        <p:txBody>
-          <a:bodyPr vert="horz" lIns="91440" tIns="45720" rIns="91440" bIns="45720" rtlCol="0" anchor="b"/>
-          <a:lstStyle>
-            <a:lvl1pPr algn="l">
-              <a:defRPr sz="1200"/>
-            </a:lvl1pPr>
-          </a:lstStyle>
-          <a:p>
-            <a:endParaRPr lang="en-US"/>
-          </a:p>
-        </p:txBody>
-      </p:sp>
-      <p:sp>
-        <p:nvSpPr>
-          <p:cNvPr id="7" name="Slide Number Placeholder 6"/>
-          <p:cNvSpPr>
-            <a:spLocks noGrp="1"/>
-          </p:cNvSpPr>
-          <p:nvPr>
-            <p:ph type="sldNum" sz="quarter" idx="5"/>
-          </p:nvPr>
-        </p:nvSpPr>
-        <p:spPr>
-          <a:xfrm>
-            <a:off x="3884613" y="8685213"/>
-            <a:ext cx="2971800" cy="458787"/>
-          </a:xfrm>
-          <a:prstGeom prst="rect">
-            <a:avLst/>
-          </a:prstGeom>
-        </p:spPr>
-        <p:txBody>
-          <a:bodyPr vert="horz" lIns="91440" tIns="45720" rIns="91440" bIns="45720" rtlCol="0" anchor="b"/>
-          <a:lstStyle>
-            <a:lvl1pPr algn="r">
-              <a:defRPr sz="1200"/>
-            </a:lvl1pPr>
-          </a:lstStyle>
-          <a:p>
-            <a:fld id="{CE5E9CC1-C706-0F49-92D6-E571CC5EEA8F}" type="slidenum">
-              <a:rPr lang="en-US"/>
-              <a:t>‹#›</a:t>
-            </a:fld>
-            <a:endParaRPr lang="en-US"/>
-          </a:p>
-        </p:txBody>
-      </p:sp>
     </p:spTree>
     <p:extLst>
       <p:ext uri="{BB962C8B-B14F-4D97-AF65-F5344CB8AC3E}">
-        <p14:creationId xmlns:p14="http://schemas.microsoft.com/office/powerpoint/2010/main" val="1024086991"/>
+        <p14:creationId xmlns:p14="http://schemas.microsoft.com/office/powerpoint/2010/main" val="1214270952"/>
       </p:ext>
     </p:extLst>
   </p:cSld>
@@ -556,10 +328,6 @@
           <a:bodyPr/>
           <a:lstStyle/>
           <a:p>
-            <a:r>
-              <a:rPr lang="en-US" dirty="0"/>
-              <a:t/>
-            </a:r>
             <a:endParaRPr lang="en-US" dirty="0"/>
           </a:p>
         </p:txBody>
@@ -644,10 +412,6 @@
           <a:bodyPr/>
           <a:lstStyle/>
           <a:p>
-            <a:r>
-              <a:rPr lang="en-US" dirty="0"/>
-              <a:t/>
-            </a:r>
             <a:endParaRPr lang="en-US" dirty="0"/>
           </a:p>
         </p:txBody>
@@ -670,182 +434,6 @@
             <a:fld id="{F7021451-1387-4CA6-816F-3879F97B5CBC}" type="slidenum">
               <a:rPr lang="en-US"/>
               <a:t>10</a:t>
-            </a:fld>
-            <a:endParaRPr lang="en-US"/>
-          </a:p>
-        </p:txBody>
-      </p:sp>
-    </p:spTree>
-    <p:extLst>
-      <p:ext uri="{BB962C8B-B14F-4D97-AF65-F5344CB8AC3E}">
-        <p14:creationId xmlns:p14="http://schemas.microsoft.com/office/powerpoint/2010/main" val="1024086991"/>
-      </p:ext>
-    </p:extLst>
-  </p:cSld>
-  <p:clrMapOvr>
-    <a:masterClrMapping/>
-  </p:clrMapOvr>
-</p:notes>
-</file>
-
-<file path=ppt/notesSlides/notesSlide11.xml><?xml version="1.0" encoding="utf-8"?>
-<p:notes xmlns:a="http://schemas.openxmlformats.org/drawingml/2006/main" xmlns:r="http://schemas.openxmlformats.org/officeDocument/2006/relationships" xmlns:p="http://schemas.openxmlformats.org/presentationml/2006/main">
-  <p:cSld>
-    <p:spTree>
-      <p:nvGrpSpPr>
-        <p:cNvPr id="1" name=""/>
-        <p:cNvGrpSpPr/>
-        <p:nvPr/>
-      </p:nvGrpSpPr>
-      <p:grpSpPr>
-        <a:xfrm>
-          <a:off x="0" y="0"/>
-          <a:ext cx="0" cy="0"/>
-          <a:chOff x="0" y="0"/>
-          <a:chExt cx="0" cy="0"/>
-        </a:xfrm>
-      </p:grpSpPr>
-      <p:sp>
-        <p:nvSpPr>
-          <p:cNvPr id="2" name="Slide Image Placeholder 1"/>
-          <p:cNvSpPr>
-            <a:spLocks noGrp="1" noRot="1" noChangeAspect="1"/>
-          </p:cNvSpPr>
-          <p:nvPr>
-            <p:ph type="sldImg"/>
-          </p:nvPr>
-        </p:nvSpPr>
-        <p:spPr/>
-      </p:sp>
-      <p:sp>
-        <p:nvSpPr>
-          <p:cNvPr id="3" name="Notes Placeholder 2"/>
-          <p:cNvSpPr>
-            <a:spLocks noGrp="1"/>
-          </p:cNvSpPr>
-          <p:nvPr>
-            <p:ph type="body" idx="1"/>
-          </p:nvPr>
-        </p:nvSpPr>
-        <p:spPr/>
-        <p:txBody>
-          <a:bodyPr/>
-          <a:lstStyle/>
-          <a:p>
-            <a:r>
-              <a:rPr lang="en-US" dirty="0"/>
-              <a:t/>
-            </a:r>
-            <a:endParaRPr lang="en-US" dirty="0"/>
-          </a:p>
-        </p:txBody>
-      </p:sp>
-      <p:sp>
-        <p:nvSpPr>
-          <p:cNvPr id="4" name="Slide Number Placeholder 3"/>
-          <p:cNvSpPr>
-            <a:spLocks noGrp="1"/>
-          </p:cNvSpPr>
-          <p:nvPr>
-            <p:ph type="sldNum" sz="quarter" idx="10"/>
-          </p:nvPr>
-        </p:nvSpPr>
-        <p:spPr/>
-        <p:txBody>
-          <a:bodyPr/>
-          <a:lstStyle/>
-          <a:p>
-            <a:fld id="{F7021451-1387-4CA6-816F-3879F97B5CBC}" type="slidenum">
-              <a:rPr lang="en-US"/>
-              <a:t>11</a:t>
-            </a:fld>
-            <a:endParaRPr lang="en-US"/>
-          </a:p>
-        </p:txBody>
-      </p:sp>
-    </p:spTree>
-    <p:extLst>
-      <p:ext uri="{BB962C8B-B14F-4D97-AF65-F5344CB8AC3E}">
-        <p14:creationId xmlns:p14="http://schemas.microsoft.com/office/powerpoint/2010/main" val="1024086991"/>
-      </p:ext>
-    </p:extLst>
-  </p:cSld>
-  <p:clrMapOvr>
-    <a:masterClrMapping/>
-  </p:clrMapOvr>
-</p:notes>
-</file>
-
-<file path=ppt/notesSlides/notesSlide12.xml><?xml version="1.0" encoding="utf-8"?>
-<p:notes xmlns:a="http://schemas.openxmlformats.org/drawingml/2006/main" xmlns:r="http://schemas.openxmlformats.org/officeDocument/2006/relationships" xmlns:p="http://schemas.openxmlformats.org/presentationml/2006/main">
-  <p:cSld>
-    <p:spTree>
-      <p:nvGrpSpPr>
-        <p:cNvPr id="1" name=""/>
-        <p:cNvGrpSpPr/>
-        <p:nvPr/>
-      </p:nvGrpSpPr>
-      <p:grpSpPr>
-        <a:xfrm>
-          <a:off x="0" y="0"/>
-          <a:ext cx="0" cy="0"/>
-          <a:chOff x="0" y="0"/>
-          <a:chExt cx="0" cy="0"/>
-        </a:xfrm>
-      </p:grpSpPr>
-      <p:sp>
-        <p:nvSpPr>
-          <p:cNvPr id="2" name="Slide Image Placeholder 1"/>
-          <p:cNvSpPr>
-            <a:spLocks noGrp="1" noRot="1" noChangeAspect="1"/>
-          </p:cNvSpPr>
-          <p:nvPr>
-            <p:ph type="sldImg"/>
-          </p:nvPr>
-        </p:nvSpPr>
-        <p:spPr/>
-      </p:sp>
-      <p:sp>
-        <p:nvSpPr>
-          <p:cNvPr id="3" name="Notes Placeholder 2"/>
-          <p:cNvSpPr>
-            <a:spLocks noGrp="1"/>
-          </p:cNvSpPr>
-          <p:nvPr>
-            <p:ph type="body" idx="1"/>
-          </p:nvPr>
-        </p:nvSpPr>
-        <p:spPr/>
-        <p:txBody>
-          <a:bodyPr/>
-          <a:lstStyle/>
-          <a:p>
-            <a:r>
-              <a:rPr lang="en-US" dirty="0"/>
-              <a:t/>
-            </a:r>
-            <a:endParaRPr lang="en-US" dirty="0"/>
-          </a:p>
-        </p:txBody>
-      </p:sp>
-      <p:sp>
-        <p:nvSpPr>
-          <p:cNvPr id="4" name="Slide Number Placeholder 3"/>
-          <p:cNvSpPr>
-            <a:spLocks noGrp="1"/>
-          </p:cNvSpPr>
-          <p:nvPr>
-            <p:ph type="sldNum" sz="quarter" idx="10"/>
-          </p:nvPr>
-        </p:nvSpPr>
-        <p:spPr/>
-        <p:txBody>
-          <a:bodyPr/>
-          <a:lstStyle/>
-          <a:p>
-            <a:fld id="{F7021451-1387-4CA6-816F-3879F97B5CBC}" type="slidenum">
-              <a:rPr lang="en-US"/>
-              <a:t>12</a:t>
             </a:fld>
             <a:endParaRPr lang="en-US"/>
           </a:p>
@@ -908,10 +496,6 @@
           <a:bodyPr/>
           <a:lstStyle/>
           <a:p>
-            <a:r>
-              <a:rPr lang="en-US" dirty="0"/>
-              <a:t/>
-            </a:r>
             <a:endParaRPr lang="en-US" dirty="0"/>
           </a:p>
         </p:txBody>
@@ -996,10 +580,6 @@
           <a:bodyPr/>
           <a:lstStyle/>
           <a:p>
-            <a:r>
-              <a:rPr lang="en-US" dirty="0"/>
-              <a:t/>
-            </a:r>
             <a:endParaRPr lang="en-US" dirty="0"/>
           </a:p>
         </p:txBody>
@@ -1084,10 +664,6 @@
           <a:bodyPr/>
           <a:lstStyle/>
           <a:p>
-            <a:r>
-              <a:rPr lang="en-US" dirty="0"/>
-              <a:t/>
-            </a:r>
             <a:endParaRPr lang="en-US" dirty="0"/>
           </a:p>
         </p:txBody>
@@ -1172,10 +748,6 @@
           <a:bodyPr/>
           <a:lstStyle/>
           <a:p>
-            <a:r>
-              <a:rPr lang="en-US" dirty="0"/>
-              <a:t/>
-            </a:r>
             <a:endParaRPr lang="en-US" dirty="0"/>
           </a:p>
         </p:txBody>
@@ -1260,10 +832,6 @@
           <a:bodyPr/>
           <a:lstStyle/>
           <a:p>
-            <a:r>
-              <a:rPr lang="en-US" dirty="0"/>
-              <a:t/>
-            </a:r>
             <a:endParaRPr lang="en-US" dirty="0"/>
           </a:p>
         </p:txBody>
@@ -1348,10 +916,6 @@
           <a:bodyPr/>
           <a:lstStyle/>
           <a:p>
-            <a:r>
-              <a:rPr lang="en-US" dirty="0"/>
-              <a:t/>
-            </a:r>
             <a:endParaRPr lang="en-US" dirty="0"/>
           </a:p>
         </p:txBody>
@@ -1436,10 +1000,6 @@
           <a:bodyPr/>
           <a:lstStyle/>
           <a:p>
-            <a:r>
-              <a:rPr lang="en-US" dirty="0"/>
-              <a:t/>
-            </a:r>
             <a:endParaRPr lang="en-US" dirty="0"/>
           </a:p>
         </p:txBody>
@@ -1524,10 +1084,6 @@
           <a:bodyPr/>
           <a:lstStyle/>
           <a:p>
-            <a:r>
-              <a:rPr lang="en-US" dirty="0"/>
-              <a:t/>
-            </a:r>
             <a:endParaRPr lang="en-US" dirty="0"/>
           </a:p>
         </p:txBody>
@@ -1606,6 +1162,7 @@
         <a:solidFill>
           <a:schemeClr val="tx2"/>
         </a:solidFill>
+        <a:effectLst/>
       </p:bgPr>
     </p:bg>
     <p:spTree>
@@ -1625,9 +1182,11 @@
       <p:sp>
         <p:nvSpPr>
           <p:cNvPr id="2" name="Text 0"/>
-          <p:cNvSpPr/>
+          <p:cNvSpPr>
+            <a:spLocks noGrp="1"/>
+          </p:cNvSpPr>
           <p:nvPr>
-            <p:ph idx="100" type="title" hasCustomPrompt="1"/>
+            <p:ph type="title" idx="100" hasCustomPrompt="1"/>
           </p:nvPr>
         </p:nvSpPr>
         <p:spPr>
@@ -1644,7 +1203,7 @@
         <p:txBody>
           <a:bodyPr wrap="square" rtlCol="0"/>
           <a:lstStyle>
-            <a:lvl1pPr indent="0" marL="0">
+            <a:lvl1pPr marL="0" indent="0">
               <a:buNone/>
               <a:defRPr lang="en-US" sz="5400" b="1" dirty="0">
                 <a:solidFill>
@@ -1654,7 +1213,7 @@
             </a:lvl1pPr>
           </a:lstStyle>
           <a:p>
-            <a:pPr indent="0" marL="0">
+            <a:pPr marL="0" indent="0">
               <a:buNone/>
             </a:pPr>
             <a:endParaRPr lang="en-US" sz="5400" dirty="0"/>
@@ -1664,9 +1223,11 @@
       <p:sp>
         <p:nvSpPr>
           <p:cNvPr id="3" name="Text 0"/>
-          <p:cNvSpPr/>
+          <p:cNvSpPr>
+            <a:spLocks noGrp="1"/>
+          </p:cNvSpPr>
           <p:nvPr>
-            <p:ph idx="101" type="body" hasCustomPrompt="1"/>
+            <p:ph type="body" idx="101" hasCustomPrompt="1"/>
           </p:nvPr>
         </p:nvSpPr>
         <p:spPr>
@@ -1683,7 +1244,7 @@
         <p:txBody>
           <a:bodyPr wrap="square" rtlCol="0"/>
           <a:lstStyle>
-            <a:lvl1pPr indent="0" marL="0">
+            <a:lvl1pPr marL="0" indent="0">
               <a:buNone/>
               <a:defRPr lang="en-US" sz="2000" dirty="0">
                 <a:solidFill>
@@ -1693,7 +1254,7 @@
             </a:lvl1pPr>
           </a:lstStyle>
           <a:p>
-            <a:pPr indent="0" marL="0">
+            <a:pPr marL="0" indent="0">
               <a:buNone/>
             </a:pPr>
             <a:endParaRPr lang="en-US" sz="2000" dirty="0"/>
@@ -1716,6 +1277,7 @@
         <a:solidFill>
           <a:schemeClr val="bg1"/>
         </a:solidFill>
+        <a:effectLst/>
       </p:bgPr>
     </p:bg>
     <p:spTree>
@@ -1753,7 +1315,7 @@
           <a:bodyPr wrap="square" lIns="0" tIns="0" rIns="0" bIns="0" rtlCol="0" anchor="ctr"/>
           <a:lstStyle/>
           <a:p>
-            <a:pPr indent="0" marL="0">
+            <a:pPr marL="0" indent="0">
               <a:buNone/>
             </a:pPr>
             <a:r>
@@ -1771,9 +1333,11 @@
       <p:sp>
         <p:nvSpPr>
           <p:cNvPr id="3" name="Text 1"/>
-          <p:cNvSpPr/>
+          <p:cNvSpPr>
+            <a:spLocks noGrp="1"/>
+          </p:cNvSpPr>
           <p:nvPr>
-            <p:ph idx="101" type="title" hasCustomPrompt="1"/>
+            <p:ph type="title" idx="101" hasCustomPrompt="1"/>
           </p:nvPr>
         </p:nvSpPr>
         <p:spPr>
@@ -1790,7 +1354,7 @@
         <p:txBody>
           <a:bodyPr wrap="square" rtlCol="0"/>
           <a:lstStyle>
-            <a:lvl1pPr indent="0" marL="0">
+            <a:lvl1pPr marL="0" indent="0">
               <a:buNone/>
               <a:defRPr lang="en-US" sz="3200" b="1" dirty="0">
                 <a:solidFill>
@@ -1800,7 +1364,7 @@
             </a:lvl1pPr>
           </a:lstStyle>
           <a:p>
-            <a:pPr indent="0" marL="0">
+            <a:pPr marL="0" indent="0">
               <a:buNone/>
             </a:pPr>
             <a:endParaRPr lang="en-US" sz="3200" dirty="0"/>
@@ -1827,7 +1391,7 @@
           </a:prstGeom>
           <a:extLst>
             <a:ext uri="{C572A759-6A51-4108-AA02-DFA0A04FC94B}">
-              <ma14:wrappingTextBoxFlag xmlns:ma14="http://schemas.microsoft.com/office/mac/drawingml/2011/main" val="0"/>
+              <ma14:wrappingTextBoxFlag xmlns:ma14="http://schemas.microsoft.com/office/mac/drawingml/2011/main" xmlns="" val="0"/>
             </a:ext>
           </a:extLst>
         </p:spPr>
@@ -1845,8 +1409,8 @@
           <a:p>
             <a:pPr algn="r"/>
             <a:fld id="{F7021451-1387-4CA6-816F-3879F97B5CBC}" type="slidenum">
-              <a:rPr b="0" lang="en-US"/>
-              <a:t>1003</a:t>
+              <a:rPr lang="en-US" b="0"/>
+              <a:t>‹#›</a:t>
             </a:fld>
             <a:endParaRPr lang="en-US"/>
           </a:p>
@@ -1868,6 +1432,7 @@
         <a:solidFill>
           <a:schemeClr val="bg1"/>
         </a:solidFill>
+        <a:effectLst/>
       </p:bgPr>
     </p:bg>
     <p:spTree>
@@ -1905,7 +1470,7 @@
           <a:bodyPr wrap="square" lIns="0" tIns="0" rIns="0" bIns="0" rtlCol="0" anchor="ctr"/>
           <a:lstStyle/>
           <a:p>
-            <a:pPr indent="0" marL="0">
+            <a:pPr marL="0" indent="0">
               <a:buNone/>
             </a:pPr>
             <a:r>
@@ -1923,9 +1488,11 @@
       <p:sp>
         <p:nvSpPr>
           <p:cNvPr id="3" name="Text 1"/>
-          <p:cNvSpPr/>
+          <p:cNvSpPr>
+            <a:spLocks noGrp="1"/>
+          </p:cNvSpPr>
           <p:nvPr>
-            <p:ph idx="101" type="title" hasCustomPrompt="1"/>
+            <p:ph type="title" idx="101" hasCustomPrompt="1"/>
           </p:nvPr>
         </p:nvSpPr>
         <p:spPr>
@@ -1942,7 +1509,7 @@
         <p:txBody>
           <a:bodyPr wrap="square" rtlCol="0"/>
           <a:lstStyle>
-            <a:lvl1pPr indent="0" marL="0">
+            <a:lvl1pPr marL="0" indent="0">
               <a:buNone/>
               <a:defRPr lang="en-US" sz="3200" b="1" dirty="0">
                 <a:solidFill>
@@ -1952,7 +1519,7 @@
             </a:lvl1pPr>
           </a:lstStyle>
           <a:p>
-            <a:pPr indent="0" marL="0">
+            <a:pPr marL="0" indent="0">
               <a:buNone/>
             </a:pPr>
             <a:endParaRPr lang="en-US" sz="3200" dirty="0"/>
@@ -1962,7 +1529,9 @@
       <p:sp>
         <p:nvSpPr>
           <p:cNvPr id="4" name="Text 1"/>
-          <p:cNvSpPr/>
+          <p:cNvSpPr>
+            <a:spLocks noGrp="1"/>
+          </p:cNvSpPr>
           <p:nvPr>
             <p:ph idx="102" hasCustomPrompt="1"/>
           </p:nvPr>
@@ -1981,7 +1550,7 @@
         <p:txBody>
           <a:bodyPr wrap="square" rtlCol="0"/>
           <a:lstStyle>
-            <a:lvl1pPr indent="0" marL="0">
+            <a:lvl1pPr marL="0" indent="0">
               <a:buNone/>
               <a:defRPr lang="en-US" sz="1400" dirty="0">
                 <a:solidFill>
@@ -1991,7 +1560,7 @@
             </a:lvl1pPr>
           </a:lstStyle>
           <a:p>
-            <a:pPr indent="0" marL="0">
+            <a:pPr marL="0" indent="0">
               <a:buNone/>
             </a:pPr>
             <a:r>
@@ -2026,7 +1595,7 @@
           </a:prstGeom>
           <a:extLst>
             <a:ext uri="{C572A759-6A51-4108-AA02-DFA0A04FC94B}">
-              <ma14:wrappingTextBoxFlag xmlns:ma14="http://schemas.microsoft.com/office/mac/drawingml/2011/main" val="0"/>
+              <ma14:wrappingTextBoxFlag xmlns:ma14="http://schemas.microsoft.com/office/mac/drawingml/2011/main" xmlns="" val="0"/>
             </a:ext>
           </a:extLst>
         </p:spPr>
@@ -2044,8 +1613,8 @@
           <a:p>
             <a:pPr algn="r"/>
             <a:fld id="{F7021451-1387-4CA6-816F-3879F97B5CBC}" type="slidenum">
-              <a:rPr b="0" lang="en-US"/>
-              <a:t>1004</a:t>
+              <a:rPr lang="en-US" b="0"/>
+              <a:t>‹#›</a:t>
             </a:fld>
             <a:endParaRPr lang="en-US"/>
           </a:p>
@@ -2062,6 +1631,11 @@
 <file path=ppt/slideMasters/slideMaster1.xml><?xml version="1.0" encoding="utf-8"?>
 <p:sldMaster xmlns:a="http://schemas.openxmlformats.org/drawingml/2006/main" xmlns:r="http://schemas.openxmlformats.org/officeDocument/2006/relationships" xmlns:p="http://schemas.openxmlformats.org/presentationml/2006/main">
   <p:cSld>
+    <p:bg>
+      <p:bgRef idx="1001">
+        <a:schemeClr val="bg1"/>
+      </p:bgRef>
+    </p:bg>
     <p:spTree>
       <p:nvGrpSpPr>
         <p:cNvPr id="1" name=""/>
@@ -2096,7 +1670,7 @@
           </a:prstGeom>
           <a:extLst>
             <a:ext uri="{C572A759-6A51-4108-AA02-DFA0A04FC94B}">
-              <ma14:wrappingTextBoxFlag xmlns:ma14="http://schemas.microsoft.com/office/mac/drawingml/2011/main" val="0"/>
+              <ma14:wrappingTextBoxFlag xmlns:ma14="http://schemas.microsoft.com/office/mac/drawingml/2011/main" xmlns="" val="0"/>
             </a:ext>
           </a:extLst>
         </p:spPr>
@@ -2114,8 +1688,8 @@
           <a:p>
             <a:pPr algn="r"/>
             <a:fld id="{F7021451-1387-4CA6-816F-3879F97B5CBC}" type="slidenum">
-              <a:rPr b="0" lang="en-US"/>
-              <a:t>null</a:t>
+              <a:rPr lang="en-US" b="0"/>
+              <a:t>‹#›</a:t>
             </a:fld>
             <a:endParaRPr lang="en-US"/>
           </a:p>
@@ -2404,9 +1978,11 @@
       <p:sp>
         <p:nvSpPr>
           <p:cNvPr id="2" name="Text 0"/>
-          <p:cNvSpPr/>
+          <p:cNvSpPr>
+            <a:spLocks noGrp="1"/>
+          </p:cNvSpPr>
           <p:nvPr>
-            <p:ph idx="100" type="title" hasCustomPrompt="1"/>
+            <p:ph type="title" idx="100" hasCustomPrompt="1"/>
           </p:nvPr>
         </p:nvSpPr>
         <p:spPr>
@@ -2424,7 +2000,7 @@
           <a:bodyPr wrap="square" lIns="0" tIns="0" rIns="0" bIns="0" rtlCol="0" anchor="b"/>
           <a:lstStyle/>
           <a:p>
-            <a:pPr indent="0" marL="0">
+            <a:pPr marL="0" indent="0">
               <a:buNone/>
             </a:pPr>
             <a:r>
@@ -2442,9 +2018,11 @@
       <p:sp>
         <p:nvSpPr>
           <p:cNvPr id="3" name="Text 0"/>
-          <p:cNvSpPr/>
+          <p:cNvSpPr>
+            <a:spLocks noGrp="1"/>
+          </p:cNvSpPr>
           <p:nvPr>
-            <p:ph idx="101" type="body" hasCustomPrompt="1"/>
+            <p:ph type="body" idx="101" hasCustomPrompt="1"/>
           </p:nvPr>
         </p:nvSpPr>
         <p:spPr>
@@ -2462,7 +2040,7 @@
           <a:bodyPr wrap="square" lIns="0" tIns="0" rIns="0" bIns="0" rtlCol="0" anchor="t"/>
           <a:lstStyle/>
           <a:p>
-            <a:pPr indent="0" marL="0">
+            <a:pPr marL="0" indent="0">
               <a:buNone/>
             </a:pPr>
             <a:r>
@@ -2505,9 +2083,11 @@
       <p:sp>
         <p:nvSpPr>
           <p:cNvPr id="2" name="Text 1"/>
-          <p:cNvSpPr/>
+          <p:cNvSpPr>
+            <a:spLocks noGrp="1"/>
+          </p:cNvSpPr>
           <p:nvPr>
-            <p:ph idx="101" type="title" hasCustomPrompt="1"/>
+            <p:ph type="title" idx="101" hasCustomPrompt="1"/>
           </p:nvPr>
         </p:nvSpPr>
         <p:spPr>
@@ -2525,16 +2105,12 @@
           <a:bodyPr wrap="square" lIns="0" tIns="0" rIns="0" bIns="0" rtlCol="0" anchor="ctr"/>
           <a:lstStyle/>
           <a:p>
-            <a:pPr indent="0" marL="0">
+            <a:pPr marL="0" indent="0">
               <a:buNone/>
             </a:pPr>
             <a:r>
-              <a:rPr lang="en-US" sz="3200" b="1" dirty="0">
-                <a:solidFill>
-                  <a:schemeClr val="tx1"/>
-                </a:solidFill>
-              </a:rPr>
-              <a:t>Sitemapa</a:t>
+              <a:rPr lang="cs-CZ" sz="3200" dirty="0"/>
+              <a:t>Design</a:t>
             </a:r>
             <a:endParaRPr lang="en-US" sz="3200" dirty="0"/>
           </a:p>
@@ -2543,7 +2119,9 @@
       <p:sp>
         <p:nvSpPr>
           <p:cNvPr id="3" name="Text 1"/>
-          <p:cNvSpPr/>
+          <p:cNvSpPr>
+            <a:spLocks noGrp="1"/>
+          </p:cNvSpPr>
           <p:nvPr>
             <p:ph idx="102" hasCustomPrompt="1"/>
           </p:nvPr>
@@ -2563,7 +2141,7 @@
           <a:bodyPr wrap="square" rtlCol="0"/>
           <a:lstStyle/>
           <a:p>
-            <a:pPr indent="0" marL="0">
+            <a:pPr marL="0" indent="0">
               <a:buNone/>
             </a:pPr>
             <a:endParaRPr lang="en-US" sz="1400" dirty="0"/>
@@ -2590,7 +2168,7 @@
           </a:prstGeom>
           <a:extLst>
             <a:ext uri="{C572A759-6A51-4108-AA02-DFA0A04FC94B}">
-              <ma14:wrappingTextBoxFlag xmlns:ma14="http://schemas.microsoft.com/office/mac/drawingml/2011/main" val="0"/>
+              <ma14:wrappingTextBoxFlag xmlns:ma14="http://schemas.microsoft.com/office/mac/drawingml/2011/main" xmlns="" val="0"/>
             </a:ext>
           </a:extLst>
         </p:spPr>
@@ -2608,284 +2186,8 @@
           <a:p>
             <a:pPr algn="r"/>
             <a:fld id="{F7021451-1387-4CA6-816F-3879F97B5CBC}" type="slidenum">
-              <a:rPr b="0" lang="en-US"/>
+              <a:rPr lang="en-US" b="0"/>
               <a:t>10</a:t>
-            </a:fld>
-            <a:endParaRPr lang="en-US"/>
-          </a:p>
-        </p:txBody>
-      </p:sp>
-    </p:spTree>
-  </p:cSld>
-  <p:clrMapOvr>
-    <a:masterClrMapping/>
-  </p:clrMapOvr>
-</p:sld>
-</file>
-
-<file path=ppt/slides/slide11.xml><?xml version="1.0" encoding="utf-8"?>
-<p:sld xmlns:a="http://schemas.openxmlformats.org/drawingml/2006/main" xmlns:r="http://schemas.openxmlformats.org/officeDocument/2006/relationships" xmlns:p="http://schemas.openxmlformats.org/presentationml/2006/main">
-  <p:cSld name="Slide 11">
-    <p:spTree>
-      <p:nvGrpSpPr>
-        <p:cNvPr id="1" name=""/>
-        <p:cNvGrpSpPr/>
-        <p:nvPr/>
-      </p:nvGrpSpPr>
-      <p:grpSpPr>
-        <a:xfrm>
-          <a:off x="0" y="0"/>
-          <a:ext cx="0" cy="0"/>
-          <a:chOff x="0" y="0"/>
-          <a:chExt cx="0" cy="0"/>
-        </a:xfrm>
-      </p:grpSpPr>
-      <p:sp>
-        <p:nvSpPr>
-          <p:cNvPr id="2" name="Text 1"/>
-          <p:cNvSpPr/>
-          <p:nvPr>
-            <p:ph idx="101" type="title" hasCustomPrompt="1"/>
-          </p:nvPr>
-        </p:nvSpPr>
-        <p:spPr>
-          <a:xfrm>
-            <a:off x="548640" y="365760"/>
-            <a:ext cx="8046720" cy="640080"/>
-          </a:xfrm>
-          <a:prstGeom prst="rect">
-            <a:avLst/>
-          </a:prstGeom>
-          <a:noFill/>
-          <a:ln/>
-        </p:spPr>
-        <p:txBody>
-          <a:bodyPr wrap="square" lIns="0" tIns="0" rIns="0" bIns="0" rtlCol="0" anchor="ctr"/>
-          <a:lstStyle/>
-          <a:p>
-            <a:pPr indent="0" marL="0">
-              <a:buNone/>
-            </a:pPr>
-            <a:r>
-              <a:rPr lang="en-US" sz="3200" b="1" dirty="0">
-                <a:solidFill>
-                  <a:schemeClr val="tx1"/>
-                </a:solidFill>
-              </a:rPr>
-              <a:t>Wireframy</a:t>
-            </a:r>
-            <a:endParaRPr lang="en-US" sz="3200" dirty="0"/>
-          </a:p>
-        </p:txBody>
-      </p:sp>
-      <p:sp>
-        <p:nvSpPr>
-          <p:cNvPr id="3" name="Text 1"/>
-          <p:cNvSpPr/>
-          <p:nvPr>
-            <p:ph idx="102" hasCustomPrompt="1"/>
-          </p:nvPr>
-        </p:nvSpPr>
-        <p:spPr>
-          <a:xfrm>
-            <a:off x="548640" y="1188720"/>
-            <a:ext cx="8046720" cy="3291840"/>
-          </a:xfrm>
-          <a:prstGeom prst="rect">
-            <a:avLst/>
-          </a:prstGeom>
-          <a:noFill/>
-          <a:ln/>
-        </p:spPr>
-        <p:txBody>
-          <a:bodyPr wrap="square" rtlCol="0"/>
-          <a:lstStyle/>
-          <a:p>
-            <a:pPr indent="0" marL="0">
-              <a:buNone/>
-            </a:pPr>
-            <a:endParaRPr lang="en-US" sz="1400" dirty="0"/>
-          </a:p>
-        </p:txBody>
-      </p:sp>
-      <p:sp>
-        <p:nvSpPr>
-          <p:cNvPr id="25" name="Slide Number Placeholder 0"/>
-          <p:cNvSpPr>
-            <a:spLocks noGrp="1"/>
-          </p:cNvSpPr>
-          <p:nvPr>
-            <p:ph type="sldNum" sz="quarter" idx="4294967295"/>
-          </p:nvPr>
-        </p:nvSpPr>
-        <p:spPr>
-          <a:xfrm>
-            <a:off x="8229600" y="4663440"/>
-            <a:ext cx="365760" cy="274320"/>
-          </a:xfrm>
-          <a:prstGeom prst="rect">
-            <a:avLst/>
-          </a:prstGeom>
-          <a:extLst>
-            <a:ext uri="{C572A759-6A51-4108-AA02-DFA0A04FC94B}">
-              <ma14:wrappingTextBoxFlag xmlns:ma14="http://schemas.microsoft.com/office/mac/drawingml/2011/main" val="0"/>
-            </a:ext>
-          </a:extLst>
-        </p:spPr>
-        <p:txBody>
-          <a:bodyPr lIns="0" tIns="0" rIns="0" bIns="0"/>
-          <a:lstStyle>
-            <a:lvl1pPr>
-              <a:defRPr sz="1000">
-                <a:solidFill>
-                  <a:schemeClr val="accent4"/>
-                </a:solidFill>
-              </a:defRPr>
-            </a:lvl1pPr>
-          </a:lstStyle>
-          <a:p>
-            <a:pPr algn="r"/>
-            <a:fld id="{F7021451-1387-4CA6-816F-3879F97B5CBC}" type="slidenum">
-              <a:rPr b="0" lang="en-US"/>
-              <a:t>11</a:t>
-            </a:fld>
-            <a:endParaRPr lang="en-US"/>
-          </a:p>
-        </p:txBody>
-      </p:sp>
-    </p:spTree>
-  </p:cSld>
-  <p:clrMapOvr>
-    <a:masterClrMapping/>
-  </p:clrMapOvr>
-</p:sld>
-</file>
-
-<file path=ppt/slides/slide12.xml><?xml version="1.0" encoding="utf-8"?>
-<p:sld xmlns:a="http://schemas.openxmlformats.org/drawingml/2006/main" xmlns:r="http://schemas.openxmlformats.org/officeDocument/2006/relationships" xmlns:p="http://schemas.openxmlformats.org/presentationml/2006/main">
-  <p:cSld name="Slide 12">
-    <p:spTree>
-      <p:nvGrpSpPr>
-        <p:cNvPr id="1" name=""/>
-        <p:cNvGrpSpPr/>
-        <p:nvPr/>
-      </p:nvGrpSpPr>
-      <p:grpSpPr>
-        <a:xfrm>
-          <a:off x="0" y="0"/>
-          <a:ext cx="0" cy="0"/>
-          <a:chOff x="0" y="0"/>
-          <a:chExt cx="0" cy="0"/>
-        </a:xfrm>
-      </p:grpSpPr>
-      <p:sp>
-        <p:nvSpPr>
-          <p:cNvPr id="2" name="Text 1"/>
-          <p:cNvSpPr/>
-          <p:nvPr>
-            <p:ph idx="101" type="title" hasCustomPrompt="1"/>
-          </p:nvPr>
-        </p:nvSpPr>
-        <p:spPr>
-          <a:xfrm>
-            <a:off x="548640" y="365760"/>
-            <a:ext cx="8046720" cy="640080"/>
-          </a:xfrm>
-          <a:prstGeom prst="rect">
-            <a:avLst/>
-          </a:prstGeom>
-          <a:noFill/>
-          <a:ln/>
-        </p:spPr>
-        <p:txBody>
-          <a:bodyPr wrap="square" lIns="0" tIns="0" rIns="0" bIns="0" rtlCol="0" anchor="ctr"/>
-          <a:lstStyle/>
-          <a:p>
-            <a:pPr indent="0" marL="0">
-              <a:buNone/>
-            </a:pPr>
-            <a:r>
-              <a:rPr lang="en-US" sz="3200" b="1" dirty="0">
-                <a:solidFill>
-                  <a:schemeClr val="tx1"/>
-                </a:solidFill>
-              </a:rPr>
-              <a:t>První verze designu</a:t>
-            </a:r>
-            <a:endParaRPr lang="en-US" sz="3200" dirty="0"/>
-          </a:p>
-        </p:txBody>
-      </p:sp>
-      <p:sp>
-        <p:nvSpPr>
-          <p:cNvPr id="3" name="Text 1"/>
-          <p:cNvSpPr/>
-          <p:nvPr>
-            <p:ph idx="102" hasCustomPrompt="1"/>
-          </p:nvPr>
-        </p:nvSpPr>
-        <p:spPr>
-          <a:xfrm>
-            <a:off x="548640" y="1188720"/>
-            <a:ext cx="8046720" cy="3291840"/>
-          </a:xfrm>
-          <a:prstGeom prst="rect">
-            <a:avLst/>
-          </a:prstGeom>
-          <a:noFill/>
-          <a:ln/>
-        </p:spPr>
-        <p:txBody>
-          <a:bodyPr wrap="square" rtlCol="0"/>
-          <a:lstStyle/>
-          <a:p>
-            <a:pPr indent="0" marL="0">
-              <a:buNone/>
-            </a:pPr>
-            <a:endParaRPr lang="en-US" sz="1400" dirty="0"/>
-          </a:p>
-        </p:txBody>
-      </p:sp>
-      <p:sp>
-        <p:nvSpPr>
-          <p:cNvPr id="25" name="Slide Number Placeholder 0"/>
-          <p:cNvSpPr>
-            <a:spLocks noGrp="1"/>
-          </p:cNvSpPr>
-          <p:nvPr>
-            <p:ph type="sldNum" sz="quarter" idx="4294967295"/>
-          </p:nvPr>
-        </p:nvSpPr>
-        <p:spPr>
-          <a:xfrm>
-            <a:off x="8229600" y="4663440"/>
-            <a:ext cx="365760" cy="274320"/>
-          </a:xfrm>
-          <a:prstGeom prst="rect">
-            <a:avLst/>
-          </a:prstGeom>
-          <a:extLst>
-            <a:ext uri="{C572A759-6A51-4108-AA02-DFA0A04FC94B}">
-              <ma14:wrappingTextBoxFlag xmlns:ma14="http://schemas.microsoft.com/office/mac/drawingml/2011/main" val="0"/>
-            </a:ext>
-          </a:extLst>
-        </p:spPr>
-        <p:txBody>
-          <a:bodyPr lIns="0" tIns="0" rIns="0" bIns="0"/>
-          <a:lstStyle>
-            <a:lvl1pPr>
-              <a:defRPr sz="1000">
-                <a:solidFill>
-                  <a:schemeClr val="accent4"/>
-                </a:solidFill>
-              </a:defRPr>
-            </a:lvl1pPr>
-          </a:lstStyle>
-          <a:p>
-            <a:pPr algn="r"/>
-            <a:fld id="{F7021451-1387-4CA6-816F-3879F97B5CBC}" type="slidenum">
-              <a:rPr b="0" lang="en-US"/>
-              <a:t>12</a:t>
             </a:fld>
             <a:endParaRPr lang="en-US"/>
           </a:p>
@@ -2919,9 +2221,11 @@
       <p:sp>
         <p:nvSpPr>
           <p:cNvPr id="2" name="Text 1"/>
-          <p:cNvSpPr/>
+          <p:cNvSpPr>
+            <a:spLocks noGrp="1"/>
+          </p:cNvSpPr>
           <p:nvPr>
-            <p:ph idx="101" type="title" hasCustomPrompt="1"/>
+            <p:ph type="title" idx="101" hasCustomPrompt="1"/>
           </p:nvPr>
         </p:nvSpPr>
         <p:spPr>
@@ -2939,7 +2243,7 @@
           <a:bodyPr wrap="square" lIns="0" tIns="0" rIns="0" bIns="0" rtlCol="0" anchor="ctr"/>
           <a:lstStyle/>
           <a:p>
-            <a:pPr indent="0" marL="0">
+            <a:pPr marL="0" indent="0">
               <a:buNone/>
             </a:pPr>
             <a:r>
@@ -2975,6 +2279,13 @@
           </a:solidFill>
           <a:ln/>
         </p:spPr>
+        <p:txBody>
+          <a:bodyPr/>
+          <a:lstStyle/>
+          <a:p>
+            <a:endParaRPr lang="cs-CZ"/>
+          </a:p>
+        </p:txBody>
       </p:sp>
       <p:sp>
         <p:nvSpPr>
@@ -2997,7 +2308,7 @@
           <a:bodyPr wrap="square" lIns="0" tIns="0" rIns="0" bIns="0" rtlCol="0" anchor="ctr"/>
           <a:lstStyle/>
           <a:p>
-            <a:pPr indent="0" marL="0">
+            <a:pPr marL="0" indent="0">
               <a:buNone/>
             </a:pPr>
             <a:r>
@@ -3033,7 +2344,7 @@
           <a:bodyPr wrap="square" lIns="0" tIns="0" rIns="0" bIns="0" rtlCol="0" anchor="t"/>
           <a:lstStyle/>
           <a:p>
-            <a:pPr indent="0" marL="0">
+            <a:pPr marL="0" indent="0">
               <a:buNone/>
             </a:pPr>
             <a:r>
@@ -3069,6 +2380,13 @@
           </a:solidFill>
           <a:ln/>
         </p:spPr>
+        <p:txBody>
+          <a:bodyPr/>
+          <a:lstStyle/>
+          <a:p>
+            <a:endParaRPr lang="cs-CZ"/>
+          </a:p>
+        </p:txBody>
       </p:sp>
       <p:sp>
         <p:nvSpPr>
@@ -3091,7 +2409,7 @@
           <a:bodyPr wrap="square" lIns="0" tIns="0" rIns="0" bIns="0" rtlCol="0" anchor="ctr"/>
           <a:lstStyle/>
           <a:p>
-            <a:pPr indent="0" marL="0">
+            <a:pPr marL="0" indent="0">
               <a:buNone/>
             </a:pPr>
             <a:r>
@@ -3127,7 +2445,7 @@
           <a:bodyPr wrap="square" lIns="0" tIns="0" rIns="0" bIns="0" rtlCol="0" anchor="t"/>
           <a:lstStyle/>
           <a:p>
-            <a:pPr indent="0" marL="0">
+            <a:pPr marL="0" indent="0">
               <a:buNone/>
             </a:pPr>
             <a:r>
@@ -3163,6 +2481,13 @@
           </a:solidFill>
           <a:ln/>
         </p:spPr>
+        <p:txBody>
+          <a:bodyPr/>
+          <a:lstStyle/>
+          <a:p>
+            <a:endParaRPr lang="cs-CZ"/>
+          </a:p>
+        </p:txBody>
       </p:sp>
       <p:sp>
         <p:nvSpPr>
@@ -3185,7 +2510,7 @@
           <a:bodyPr wrap="square" lIns="0" tIns="0" rIns="0" bIns="0" rtlCol="0" anchor="ctr"/>
           <a:lstStyle/>
           <a:p>
-            <a:pPr indent="0" marL="0">
+            <a:pPr marL="0" indent="0">
               <a:buNone/>
             </a:pPr>
             <a:r>
@@ -3221,7 +2546,7 @@
           <a:bodyPr wrap="square" lIns="0" tIns="0" rIns="0" bIns="0" rtlCol="0" anchor="t"/>
           <a:lstStyle/>
           <a:p>
-            <a:pPr indent="0" marL="0">
+            <a:pPr marL="0" indent="0">
               <a:buNone/>
             </a:pPr>
             <a:r>
@@ -3257,6 +2582,13 @@
           </a:solidFill>
           <a:ln/>
         </p:spPr>
+        <p:txBody>
+          <a:bodyPr/>
+          <a:lstStyle/>
+          <a:p>
+            <a:endParaRPr lang="cs-CZ"/>
+          </a:p>
+        </p:txBody>
       </p:sp>
       <p:sp>
         <p:nvSpPr>
@@ -3279,7 +2611,7 @@
           <a:bodyPr wrap="square" lIns="0" tIns="0" rIns="0" bIns="0" rtlCol="0" anchor="ctr"/>
           <a:lstStyle/>
           <a:p>
-            <a:pPr indent="0" marL="0">
+            <a:pPr marL="0" indent="0">
               <a:buNone/>
             </a:pPr>
             <a:r>
@@ -3315,7 +2647,7 @@
           <a:bodyPr wrap="square" lIns="0" tIns="0" rIns="0" bIns="0" rtlCol="0" anchor="t"/>
           <a:lstStyle/>
           <a:p>
-            <a:pPr indent="0" marL="0">
+            <a:pPr marL="0" indent="0">
               <a:buNone/>
             </a:pPr>
             <a:r>
@@ -3351,6 +2683,13 @@
           </a:solidFill>
           <a:ln/>
         </p:spPr>
+        <p:txBody>
+          <a:bodyPr/>
+          <a:lstStyle/>
+          <a:p>
+            <a:endParaRPr lang="cs-CZ"/>
+          </a:p>
+        </p:txBody>
       </p:sp>
       <p:sp>
         <p:nvSpPr>
@@ -3373,7 +2712,7 @@
           <a:bodyPr wrap="square" lIns="0" tIns="0" rIns="0" bIns="0" rtlCol="0" anchor="ctr"/>
           <a:lstStyle/>
           <a:p>
-            <a:pPr indent="0" marL="0">
+            <a:pPr marL="0" indent="0">
               <a:buNone/>
             </a:pPr>
             <a:r>
@@ -3409,7 +2748,7 @@
           <a:bodyPr wrap="square" lIns="0" tIns="0" rIns="0" bIns="0" rtlCol="0" anchor="t"/>
           <a:lstStyle/>
           <a:p>
-            <a:pPr indent="0" marL="0">
+            <a:pPr marL="0" indent="0">
               <a:buNone/>
             </a:pPr>
             <a:r>
@@ -3445,6 +2784,13 @@
           </a:solidFill>
           <a:ln/>
         </p:spPr>
+        <p:txBody>
+          <a:bodyPr/>
+          <a:lstStyle/>
+          <a:p>
+            <a:endParaRPr lang="cs-CZ"/>
+          </a:p>
+        </p:txBody>
       </p:sp>
       <p:sp>
         <p:nvSpPr>
@@ -3467,7 +2813,7 @@
           <a:bodyPr wrap="square" lIns="0" tIns="0" rIns="0" bIns="0" rtlCol="0" anchor="ctr"/>
           <a:lstStyle/>
           <a:p>
-            <a:pPr indent="0" marL="0">
+            <a:pPr marL="0" indent="0">
               <a:buNone/>
             </a:pPr>
             <a:r>
@@ -3503,7 +2849,7 @@
           <a:bodyPr wrap="square" lIns="0" tIns="0" rIns="0" bIns="0" rtlCol="0" anchor="t"/>
           <a:lstStyle/>
           <a:p>
-            <a:pPr indent="0" marL="0">
+            <a:pPr marL="0" indent="0">
               <a:buNone/>
             </a:pPr>
             <a:r>
@@ -3538,7 +2884,7 @@
           </a:prstGeom>
           <a:extLst>
             <a:ext uri="{C572A759-6A51-4108-AA02-DFA0A04FC94B}">
-              <ma14:wrappingTextBoxFlag xmlns:ma14="http://schemas.microsoft.com/office/mac/drawingml/2011/main" val="0"/>
+              <ma14:wrappingTextBoxFlag xmlns:ma14="http://schemas.microsoft.com/office/mac/drawingml/2011/main" xmlns="" val="0"/>
             </a:ext>
           </a:extLst>
         </p:spPr>
@@ -3556,7 +2902,7 @@
           <a:p>
             <a:pPr algn="r"/>
             <a:fld id="{F7021451-1387-4CA6-816F-3879F97B5CBC}" type="slidenum">
-              <a:rPr b="0" lang="en-US"/>
+              <a:rPr lang="en-US" b="0"/>
               <a:t>2</a:t>
             </a:fld>
             <a:endParaRPr lang="en-US"/>
@@ -3591,9 +2937,11 @@
       <p:sp>
         <p:nvSpPr>
           <p:cNvPr id="2" name="Text 1"/>
-          <p:cNvSpPr/>
+          <p:cNvSpPr>
+            <a:spLocks noGrp="1"/>
+          </p:cNvSpPr>
           <p:nvPr>
-            <p:ph idx="101" type="title" hasCustomPrompt="1"/>
+            <p:ph type="title" idx="101" hasCustomPrompt="1"/>
           </p:nvPr>
         </p:nvSpPr>
         <p:spPr>
@@ -3611,7 +2959,7 @@
           <a:bodyPr wrap="square" lIns="0" tIns="0" rIns="0" bIns="0" rtlCol="0" anchor="ctr"/>
           <a:lstStyle/>
           <a:p>
-            <a:pPr indent="0" marL="0">
+            <a:pPr marL="0" indent="0">
               <a:buNone/>
             </a:pPr>
             <a:r>
@@ -3629,7 +2977,9 @@
       <p:sp>
         <p:nvSpPr>
           <p:cNvPr id="3" name="Text 1"/>
-          <p:cNvSpPr/>
+          <p:cNvSpPr>
+            <a:spLocks noGrp="1"/>
+          </p:cNvSpPr>
           <p:nvPr>
             <p:ph idx="102" hasCustomPrompt="1"/>
           </p:nvPr>
@@ -3649,7 +2999,7 @@
           <a:bodyPr wrap="square" rtlCol="0"/>
           <a:lstStyle/>
           <a:p>
-            <a:pPr indent="0" marL="0">
+            <a:pPr marL="0" indent="0">
               <a:buNone/>
             </a:pPr>
             <a:endParaRPr lang="en-US" sz="1400" dirty="0"/>
@@ -3676,7 +3026,7 @@
           </a:prstGeom>
           <a:extLst>
             <a:ext uri="{C572A759-6A51-4108-AA02-DFA0A04FC94B}">
-              <ma14:wrappingTextBoxFlag xmlns:ma14="http://schemas.microsoft.com/office/mac/drawingml/2011/main" val="0"/>
+              <ma14:wrappingTextBoxFlag xmlns:ma14="http://schemas.microsoft.com/office/mac/drawingml/2011/main" xmlns="" val="0"/>
             </a:ext>
           </a:extLst>
         </p:spPr>
@@ -3694,7 +3044,7 @@
           <a:p>
             <a:pPr algn="r"/>
             <a:fld id="{F7021451-1387-4CA6-816F-3879F97B5CBC}" type="slidenum">
-              <a:rPr b="0" lang="en-US"/>
+              <a:rPr lang="en-US" b="0"/>
               <a:t>3</a:t>
             </a:fld>
             <a:endParaRPr lang="en-US"/>
@@ -3729,9 +3079,11 @@
       <p:sp>
         <p:nvSpPr>
           <p:cNvPr id="2" name="Text 1"/>
-          <p:cNvSpPr/>
+          <p:cNvSpPr>
+            <a:spLocks noGrp="1"/>
+          </p:cNvSpPr>
           <p:nvPr>
-            <p:ph idx="101" type="title" hasCustomPrompt="1"/>
+            <p:ph type="title" idx="101" hasCustomPrompt="1"/>
           </p:nvPr>
         </p:nvSpPr>
         <p:spPr>
@@ -3749,7 +3101,7 @@
           <a:bodyPr wrap="square" lIns="0" tIns="0" rIns="0" bIns="0" rtlCol="0" anchor="ctr"/>
           <a:lstStyle/>
           <a:p>
-            <a:pPr indent="0" marL="0">
+            <a:pPr marL="0" indent="0">
               <a:buNone/>
             </a:pPr>
             <a:r>
@@ -3784,7 +3136,7 @@
           </a:prstGeom>
           <a:extLst>
             <a:ext uri="{C572A759-6A51-4108-AA02-DFA0A04FC94B}">
-              <ma14:wrappingTextBoxFlag xmlns:ma14="http://schemas.microsoft.com/office/mac/drawingml/2011/main" val="0"/>
+              <ma14:wrappingTextBoxFlag xmlns:ma14="http://schemas.microsoft.com/office/mac/drawingml/2011/main" xmlns="" val="0"/>
             </a:ext>
           </a:extLst>
         </p:spPr>
@@ -3802,7 +3154,7 @@
           <a:p>
             <a:pPr algn="r"/>
             <a:fld id="{F7021451-1387-4CA6-816F-3879F97B5CBC}" type="slidenum">
-              <a:rPr b="0" lang="en-US"/>
+              <a:rPr lang="en-US" b="0"/>
               <a:t>4</a:t>
             </a:fld>
             <a:endParaRPr lang="en-US"/>
@@ -3837,9 +3189,11 @@
       <p:sp>
         <p:nvSpPr>
           <p:cNvPr id="2" name="Text 1"/>
-          <p:cNvSpPr/>
+          <p:cNvSpPr>
+            <a:spLocks noGrp="1"/>
+          </p:cNvSpPr>
           <p:nvPr>
-            <p:ph idx="101" type="title" hasCustomPrompt="1"/>
+            <p:ph type="title" idx="101" hasCustomPrompt="1"/>
           </p:nvPr>
         </p:nvSpPr>
         <p:spPr>
@@ -3857,7 +3211,7 @@
           <a:bodyPr wrap="square" lIns="0" tIns="0" rIns="0" bIns="0" rtlCol="0" anchor="ctr"/>
           <a:lstStyle/>
           <a:p>
-            <a:pPr indent="0" marL="0">
+            <a:pPr marL="0" indent="0">
               <a:buNone/>
             </a:pPr>
             <a:r>
@@ -3893,6 +3247,13 @@
           </a:solidFill>
           <a:ln/>
         </p:spPr>
+        <p:txBody>
+          <a:bodyPr/>
+          <a:lstStyle/>
+          <a:p>
+            <a:endParaRPr lang="cs-CZ"/>
+          </a:p>
+        </p:txBody>
       </p:sp>
       <p:sp>
         <p:nvSpPr>
@@ -3913,17 +3274,24 @@
           </a:solidFill>
           <a:ln/>
         </p:spPr>
+        <p:txBody>
+          <a:bodyPr/>
+          <a:lstStyle/>
+          <a:p>
+            <a:endParaRPr lang="cs-CZ"/>
+          </a:p>
+        </p:txBody>
       </p:sp>
       <p:pic>
         <p:nvPicPr>
-          <p:cNvPr id="5" name="trenérka, cvičí i vlastní psy icon" descr="trenérka, cvičí i vlastní psy">    </p:cNvPr>
+          <p:cNvPr id="5" name="trenérka, cvičí i vlastní psy icon" descr="trenérka, cvičí i vlastní psy"/>
           <p:cNvPicPr>
             <a:picLocks noChangeAspect="1"/>
           </p:cNvPicPr>
           <p:nvPr/>
         </p:nvPicPr>
         <p:blipFill>
-          <a:blip r:embed="rId1"/>
+          <a:blip r:embed="rId3"/>
           <a:stretch>
             <a:fillRect/>
           </a:stretch>
@@ -3959,7 +3327,7 @@
           <a:bodyPr wrap="square" lIns="0" tIns="0" rIns="0" bIns="0" rtlCol="0" anchor="ctr"/>
           <a:lstStyle/>
           <a:p>
-            <a:pPr indent="0" marL="0">
+            <a:pPr marL="0" indent="0">
               <a:buNone/>
             </a:pPr>
             <a:r>
@@ -3995,7 +3363,7 @@
           <a:bodyPr wrap="square" lIns="0" tIns="0" rIns="0" bIns="0" rtlCol="0" anchor="t"/>
           <a:lstStyle/>
           <a:p>
-            <a:pPr indent="0" marL="0">
+            <a:pPr marL="0" indent="0">
               <a:buNone/>
             </a:pPr>
             <a:r>
@@ -4031,6 +3399,13 @@
           </a:solidFill>
           <a:ln/>
         </p:spPr>
+        <p:txBody>
+          <a:bodyPr/>
+          <a:lstStyle/>
+          <a:p>
+            <a:endParaRPr lang="cs-CZ"/>
+          </a:p>
+        </p:txBody>
       </p:sp>
       <p:sp>
         <p:nvSpPr>
@@ -4051,17 +3426,24 @@
           </a:solidFill>
           <a:ln/>
         </p:spPr>
+        <p:txBody>
+          <a:bodyPr/>
+          <a:lstStyle/>
+          <a:p>
+            <a:endParaRPr lang="cs-CZ"/>
+          </a:p>
+        </p:txBody>
       </p:sp>
       <p:pic>
         <p:nvPicPr>
-          <p:cNvPr id="10" name="polostrukturovaný rozhovor icon" descr="polostrukturovaný rozhovor">    </p:cNvPr>
+          <p:cNvPr id="10" name="polostrukturovaný rozhovor icon" descr="polostrukturovaný rozhovor"/>
           <p:cNvPicPr>
             <a:picLocks noChangeAspect="1"/>
           </p:cNvPicPr>
           <p:nvPr/>
         </p:nvPicPr>
         <p:blipFill>
-          <a:blip r:embed="rId2"/>
+          <a:blip r:embed="rId4"/>
           <a:stretch>
             <a:fillRect/>
           </a:stretch>
@@ -4097,7 +3479,7 @@
           <a:bodyPr wrap="square" lIns="0" tIns="0" rIns="0" bIns="0" rtlCol="0" anchor="ctr"/>
           <a:lstStyle/>
           <a:p>
-            <a:pPr indent="0" marL="0">
+            <a:pPr marL="0" indent="0">
               <a:buNone/>
             </a:pPr>
             <a:r>
@@ -4133,7 +3515,7 @@
           <a:bodyPr wrap="square" lIns="0" tIns="0" rIns="0" bIns="0" rtlCol="0" anchor="t"/>
           <a:lstStyle/>
           <a:p>
-            <a:pPr indent="0" marL="0">
+            <a:pPr marL="0" indent="0">
               <a:buNone/>
             </a:pPr>
             <a:r>
@@ -4169,6 +3551,13 @@
           </a:solidFill>
           <a:ln/>
         </p:spPr>
+        <p:txBody>
+          <a:bodyPr/>
+          <a:lstStyle/>
+          <a:p>
+            <a:endParaRPr lang="cs-CZ"/>
+          </a:p>
+        </p:txBody>
       </p:sp>
       <p:sp>
         <p:nvSpPr>
@@ -4189,17 +3578,24 @@
           </a:solidFill>
           <a:ln/>
         </p:spPr>
+        <p:txBody>
+          <a:bodyPr/>
+          <a:lstStyle/>
+          <a:p>
+            <a:endParaRPr lang="cs-CZ"/>
+          </a:p>
+        </p:txBody>
       </p:sp>
       <p:pic>
         <p:nvPicPr>
-          <p:cNvPr id="15" name="výzkumných cílů icon" descr="výzkumných cílů">    </p:cNvPr>
+          <p:cNvPr id="15" name="výzkumných cílů icon" descr="výzkumných cílů"/>
           <p:cNvPicPr>
             <a:picLocks noChangeAspect="1"/>
           </p:cNvPicPr>
           <p:nvPr/>
         </p:nvPicPr>
         <p:blipFill>
-          <a:blip r:embed="rId3"/>
+          <a:blip r:embed="rId5"/>
           <a:stretch>
             <a:fillRect/>
           </a:stretch>
@@ -4235,7 +3631,7 @@
           <a:bodyPr wrap="square" lIns="0" tIns="0" rIns="0" bIns="0" rtlCol="0" anchor="ctr"/>
           <a:lstStyle/>
           <a:p>
-            <a:pPr indent="0" marL="0">
+            <a:pPr marL="0" indent="0">
               <a:buNone/>
             </a:pPr>
             <a:r>
@@ -4271,7 +3667,7 @@
           <a:bodyPr wrap="square" lIns="0" tIns="0" rIns="0" bIns="0" rtlCol="0" anchor="t"/>
           <a:lstStyle/>
           <a:p>
-            <a:pPr indent="0" marL="0">
+            <a:pPr marL="0" indent="0">
               <a:buNone/>
             </a:pPr>
             <a:r>
@@ -4307,6 +3703,13 @@
           </a:solidFill>
           <a:ln/>
         </p:spPr>
+        <p:txBody>
+          <a:bodyPr/>
+          <a:lstStyle/>
+          <a:p>
+            <a:endParaRPr lang="cs-CZ"/>
+          </a:p>
+        </p:txBody>
       </p:sp>
       <p:sp>
         <p:nvSpPr>
@@ -4327,17 +3730,24 @@
           </a:solidFill>
           <a:ln/>
         </p:spPr>
+        <p:txBody>
+          <a:bodyPr/>
+          <a:lstStyle/>
+          <a:p>
+            <a:endParaRPr lang="cs-CZ"/>
+          </a:p>
+        </p:txBody>
       </p:sp>
       <p:pic>
         <p:nvPicPr>
-          <p:cNvPr id="20" name="hypotéz icon" descr="hypotéz">    </p:cNvPr>
+          <p:cNvPr id="20" name="hypotéz icon" descr="hypotéz"/>
           <p:cNvPicPr>
             <a:picLocks noChangeAspect="1"/>
           </p:cNvPicPr>
           <p:nvPr/>
         </p:nvPicPr>
         <p:blipFill>
-          <a:blip r:embed="rId4"/>
+          <a:blip r:embed="rId6"/>
           <a:stretch>
             <a:fillRect/>
           </a:stretch>
@@ -4373,7 +3783,7 @@
           <a:bodyPr wrap="square" lIns="0" tIns="0" rIns="0" bIns="0" rtlCol="0" anchor="ctr"/>
           <a:lstStyle/>
           <a:p>
-            <a:pPr indent="0" marL="0">
+            <a:pPr marL="0" indent="0">
               <a:buNone/>
             </a:pPr>
             <a:r>
@@ -4409,7 +3819,7 @@
           <a:bodyPr wrap="square" lIns="0" tIns="0" rIns="0" bIns="0" rtlCol="0" anchor="t"/>
           <a:lstStyle/>
           <a:p>
-            <a:pPr indent="0" marL="0">
+            <a:pPr marL="0" indent="0">
               <a:buNone/>
             </a:pPr>
             <a:r>
@@ -4444,7 +3854,7 @@
           </a:prstGeom>
           <a:extLst>
             <a:ext uri="{C572A759-6A51-4108-AA02-DFA0A04FC94B}">
-              <ma14:wrappingTextBoxFlag xmlns:ma14="http://schemas.microsoft.com/office/mac/drawingml/2011/main" val="0"/>
+              <ma14:wrappingTextBoxFlag xmlns:ma14="http://schemas.microsoft.com/office/mac/drawingml/2011/main" xmlns="" val="0"/>
             </a:ext>
           </a:extLst>
         </p:spPr>
@@ -4462,7 +3872,7 @@
           <a:p>
             <a:pPr algn="r"/>
             <a:fld id="{F7021451-1387-4CA6-816F-3879F97B5CBC}" type="slidenum">
-              <a:rPr b="0" lang="en-US"/>
+              <a:rPr lang="en-US" b="0"/>
               <a:t>5</a:t>
             </a:fld>
             <a:endParaRPr lang="en-US"/>
@@ -4497,9 +3907,11 @@
       <p:sp>
         <p:nvSpPr>
           <p:cNvPr id="2" name="Text 1"/>
-          <p:cNvSpPr/>
+          <p:cNvSpPr>
+            <a:spLocks noGrp="1"/>
+          </p:cNvSpPr>
           <p:nvPr>
-            <p:ph idx="101" type="title" hasCustomPrompt="1"/>
+            <p:ph type="title" idx="101" hasCustomPrompt="1"/>
           </p:nvPr>
         </p:nvSpPr>
         <p:spPr>
@@ -4517,7 +3929,7 @@
           <a:bodyPr wrap="square" lIns="0" tIns="0" rIns="0" bIns="0" rtlCol="0" anchor="ctr"/>
           <a:lstStyle/>
           <a:p>
-            <a:pPr indent="0" marL="0">
+            <a:pPr marL="0" indent="0">
               <a:buNone/>
             </a:pPr>
             <a:r>
@@ -4548,16 +3960,34 @@
         </p:nvGraphicFramePr>
         <p:xfrm>
           <a:off x="548640" y="1188720"/>
-          <a:ext cx="8046720" cy="914400"/>
+          <a:ext cx="8046720" cy="3072384"/>
         </p:xfrm>
         <a:graphic>
           <a:graphicData uri="http://schemas.openxmlformats.org/drawingml/2006/table">
             <a:tbl>
               <a:tblPr/>
               <a:tblGrid>
-                <a:gridCol w="640080"/>
-                <a:gridCol w="2743200"/>
-                <a:gridCol w="4663440"/>
+                <a:gridCol w="640080">
+                  <a:extLst>
+                    <a:ext uri="{9D8B030D-6E8A-4147-A177-3AD203B41FA5}">
+                      <a16:colId xmlns:a16="http://schemas.microsoft.com/office/drawing/2014/main" val="20000"/>
+                    </a:ext>
+                  </a:extLst>
+                </a:gridCol>
+                <a:gridCol w="2743200">
+                  <a:extLst>
+                    <a:ext uri="{9D8B030D-6E8A-4147-A177-3AD203B41FA5}">
+                      <a16:colId xmlns:a16="http://schemas.microsoft.com/office/drawing/2014/main" val="20001"/>
+                    </a:ext>
+                  </a:extLst>
+                </a:gridCol>
+                <a:gridCol w="4663440">
+                  <a:extLst>
+                    <a:ext uri="{9D8B030D-6E8A-4147-A177-3AD203B41FA5}">
+                      <a16:colId xmlns:a16="http://schemas.microsoft.com/office/drawing/2014/main" val="20002"/>
+                    </a:ext>
+                  </a:extLst>
+                </a:gridCol>
               </a:tblGrid>
               <a:tr h="384048">
                 <a:tc>
@@ -4565,7 +3995,7 @@
                     <a:bodyPr/>
                     <a:lstStyle/>
                     <a:p>
-                      <a:pPr algn="l" indent="0" marL="0">
+                      <a:pPr marL="0" indent="0" algn="l">
                         <a:buNone/>
                       </a:pPr>
                       <a:r>
@@ -4579,7 +4009,7 @@
                       <a:endParaRPr lang="en-US" sz="1400" dirty="0"/>
                     </a:p>
                   </a:txBody>
-                  <a:tcPr marL="137160" marR="137160" marT="45720" marB="45720" anchor="ctr">
+                  <a:tcPr marL="137160" marR="137160" anchor="ctr">
                     <a:lnL w="0" cap="flat" cmpd="sng" algn="ctr">
                       <a:noFill/>
                     </a:lnL>
@@ -4614,7 +4044,7 @@
                     <a:bodyPr/>
                     <a:lstStyle/>
                     <a:p>
-                      <a:pPr algn="l" indent="0" marL="0">
+                      <a:pPr marL="0" indent="0" algn="l">
                         <a:buNone/>
                       </a:pPr>
                       <a:r>
@@ -4628,7 +4058,7 @@
                       <a:endParaRPr lang="en-US" sz="1400" dirty="0"/>
                     </a:p>
                   </a:txBody>
-                  <a:tcPr marL="137160" marR="137160" marT="45720" marB="45720" anchor="ctr">
+                  <a:tcPr marL="137160" marR="137160" anchor="ctr">
                     <a:lnL w="0" cap="flat" cmpd="sng" algn="ctr">
                       <a:noFill/>
                     </a:lnL>
@@ -4663,7 +4093,7 @@
                     <a:bodyPr/>
                     <a:lstStyle/>
                     <a:p>
-                      <a:pPr algn="l" indent="0" marL="0">
+                      <a:pPr marL="0" indent="0" algn="l">
                         <a:buNone/>
                       </a:pPr>
                       <a:r>
@@ -4677,7 +4107,7 @@
                       <a:endParaRPr lang="en-US" sz="1400" dirty="0"/>
                     </a:p>
                   </a:txBody>
-                  <a:tcPr marL="137160" marR="137160" marT="45720" marB="45720" anchor="ctr">
+                  <a:tcPr marL="137160" marR="137160" anchor="ctr">
                     <a:lnL w="0" cap="flat" cmpd="sng" algn="ctr">
                       <a:noFill/>
                     </a:lnL>
@@ -4707,6 +4137,11 @@
                     </a:solidFill>
                   </a:tcPr>
                 </a:tc>
+                <a:extLst>
+                  <a:ext uri="{0D108BD9-81ED-4DB2-BD59-A6C34878D82A}">
+                    <a16:rowId xmlns:a16="http://schemas.microsoft.com/office/drawing/2014/main" val="10000"/>
+                  </a:ext>
+                </a:extLst>
               </a:tr>
               <a:tr h="384048">
                 <a:tc>
@@ -4714,7 +4149,7 @@
                     <a:bodyPr/>
                     <a:lstStyle/>
                     <a:p>
-                      <a:pPr indent="0" marL="0">
+                      <a:pPr marL="0" indent="0">
                         <a:buNone/>
                       </a:pPr>
                       <a:r>
@@ -4728,7 +4163,7 @@
                       <a:endParaRPr lang="en-US" sz="1400" dirty="0"/>
                     </a:p>
                   </a:txBody>
-                  <a:tcPr marL="137160" marR="137160" marT="45720" marB="45720" anchor="ctr">
+                  <a:tcPr marL="137160" marR="137160" anchor="ctr">
                     <a:lnL w="0" cap="flat" cmpd="sng" algn="ctr">
                       <a:noFill/>
                     </a:lnL>
@@ -4763,7 +4198,7 @@
                     <a:bodyPr/>
                     <a:lstStyle/>
                     <a:p>
-                      <a:pPr indent="0" marL="0">
+                      <a:pPr marL="0" indent="0">
                         <a:buNone/>
                       </a:pPr>
                       <a:r>
@@ -4777,7 +4212,7 @@
                       <a:endParaRPr lang="en-US" sz="1400" dirty="0"/>
                     </a:p>
                   </a:txBody>
-                  <a:tcPr marL="137160" marR="137160" marT="45720" marB="45720" anchor="ctr">
+                  <a:tcPr marL="137160" marR="137160" anchor="ctr">
                     <a:lnL w="0" cap="flat" cmpd="sng" algn="ctr">
                       <a:noFill/>
                     </a:lnL>
@@ -4812,7 +4247,7 @@
                     <a:bodyPr/>
                     <a:lstStyle/>
                     <a:p>
-                      <a:pPr indent="0" marL="0">
+                      <a:pPr marL="0" indent="0">
                         <a:buNone/>
                       </a:pPr>
                       <a:r>
@@ -4826,7 +4261,7 @@
                       <a:endParaRPr lang="en-US" sz="1400" dirty="0"/>
                     </a:p>
                   </a:txBody>
-                  <a:tcPr marL="137160" marR="137160" marT="45720" marB="45720" anchor="ctr">
+                  <a:tcPr marL="137160" marR="137160" anchor="ctr">
                     <a:lnL w="0" cap="flat" cmpd="sng" algn="ctr">
                       <a:noFill/>
                     </a:lnL>
@@ -4856,6 +4291,11 @@
                     </a:solidFill>
                   </a:tcPr>
                 </a:tc>
+                <a:extLst>
+                  <a:ext uri="{0D108BD9-81ED-4DB2-BD59-A6C34878D82A}">
+                    <a16:rowId xmlns:a16="http://schemas.microsoft.com/office/drawing/2014/main" val="10001"/>
+                  </a:ext>
+                </a:extLst>
               </a:tr>
               <a:tr h="384048">
                 <a:tc>
@@ -4863,7 +4303,7 @@
                     <a:bodyPr/>
                     <a:lstStyle/>
                     <a:p>
-                      <a:pPr indent="0" marL="0">
+                      <a:pPr marL="0" indent="0">
                         <a:buNone/>
                       </a:pPr>
                       <a:r>
@@ -4877,7 +4317,7 @@
                       <a:endParaRPr lang="en-US" sz="1400" dirty="0"/>
                     </a:p>
                   </a:txBody>
-                  <a:tcPr marL="137160" marR="137160" marT="45720" marB="45720" anchor="ctr">
+                  <a:tcPr marL="137160" marR="137160" anchor="ctr">
                     <a:lnL w="0" cap="flat" cmpd="sng" algn="ctr">
                       <a:noFill/>
                     </a:lnL>
@@ -4912,7 +4352,7 @@
                     <a:bodyPr/>
                     <a:lstStyle/>
                     <a:p>
-                      <a:pPr indent="0" marL="0">
+                      <a:pPr marL="0" indent="0">
                         <a:buNone/>
                       </a:pPr>
                       <a:r>
@@ -4926,7 +4366,7 @@
                       <a:endParaRPr lang="en-US" sz="1400" dirty="0"/>
                     </a:p>
                   </a:txBody>
-                  <a:tcPr marL="137160" marR="137160" marT="45720" marB="45720" anchor="ctr">
+                  <a:tcPr marL="137160" marR="137160" anchor="ctr">
                     <a:lnL w="0" cap="flat" cmpd="sng" algn="ctr">
                       <a:noFill/>
                     </a:lnL>
@@ -4961,7 +4401,7 @@
                     <a:bodyPr/>
                     <a:lstStyle/>
                     <a:p>
-                      <a:pPr indent="0" marL="0">
+                      <a:pPr marL="0" indent="0">
                         <a:buNone/>
                       </a:pPr>
                       <a:r>
@@ -4975,7 +4415,7 @@
                       <a:endParaRPr lang="en-US" sz="1400" dirty="0"/>
                     </a:p>
                   </a:txBody>
-                  <a:tcPr marL="137160" marR="137160" marT="45720" marB="45720" anchor="ctr">
+                  <a:tcPr marL="137160" marR="137160" anchor="ctr">
                     <a:lnL w="0" cap="flat" cmpd="sng" algn="ctr">
                       <a:noFill/>
                     </a:lnL>
@@ -5005,6 +4445,11 @@
                     </a:solidFill>
                   </a:tcPr>
                 </a:tc>
+                <a:extLst>
+                  <a:ext uri="{0D108BD9-81ED-4DB2-BD59-A6C34878D82A}">
+                    <a16:rowId xmlns:a16="http://schemas.microsoft.com/office/drawing/2014/main" val="10002"/>
+                  </a:ext>
+                </a:extLst>
               </a:tr>
               <a:tr h="384048">
                 <a:tc>
@@ -5012,7 +4457,7 @@
                     <a:bodyPr/>
                     <a:lstStyle/>
                     <a:p>
-                      <a:pPr indent="0" marL="0">
+                      <a:pPr marL="0" indent="0">
                         <a:buNone/>
                       </a:pPr>
                       <a:r>
@@ -5026,7 +4471,7 @@
                       <a:endParaRPr lang="en-US" sz="1400" dirty="0"/>
                     </a:p>
                   </a:txBody>
-                  <a:tcPr marL="137160" marR="137160" marT="45720" marB="45720" anchor="ctr">
+                  <a:tcPr marL="137160" marR="137160" anchor="ctr">
                     <a:lnL w="0" cap="flat" cmpd="sng" algn="ctr">
                       <a:noFill/>
                     </a:lnL>
@@ -5061,7 +4506,7 @@
                     <a:bodyPr/>
                     <a:lstStyle/>
                     <a:p>
-                      <a:pPr indent="0" marL="0">
+                      <a:pPr marL="0" indent="0">
                         <a:buNone/>
                       </a:pPr>
                       <a:r>
@@ -5075,7 +4520,7 @@
                       <a:endParaRPr lang="en-US" sz="1400" dirty="0"/>
                     </a:p>
                   </a:txBody>
-                  <a:tcPr marL="137160" marR="137160" marT="45720" marB="45720" anchor="ctr">
+                  <a:tcPr marL="137160" marR="137160" anchor="ctr">
                     <a:lnL w="0" cap="flat" cmpd="sng" algn="ctr">
                       <a:noFill/>
                     </a:lnL>
@@ -5110,7 +4555,7 @@
                     <a:bodyPr/>
                     <a:lstStyle/>
                     <a:p>
-                      <a:pPr indent="0" marL="0">
+                      <a:pPr marL="0" indent="0">
                         <a:buNone/>
                       </a:pPr>
                       <a:r>
@@ -5124,7 +4569,7 @@
                       <a:endParaRPr lang="en-US" sz="1400" dirty="0"/>
                     </a:p>
                   </a:txBody>
-                  <a:tcPr marL="137160" marR="137160" marT="45720" marB="45720" anchor="ctr">
+                  <a:tcPr marL="137160" marR="137160" anchor="ctr">
                     <a:lnL w="0" cap="flat" cmpd="sng" algn="ctr">
                       <a:noFill/>
                     </a:lnL>
@@ -5154,6 +4599,11 @@
                     </a:solidFill>
                   </a:tcPr>
                 </a:tc>
+                <a:extLst>
+                  <a:ext uri="{0D108BD9-81ED-4DB2-BD59-A6C34878D82A}">
+                    <a16:rowId xmlns:a16="http://schemas.microsoft.com/office/drawing/2014/main" val="10003"/>
+                  </a:ext>
+                </a:extLst>
               </a:tr>
               <a:tr h="384048">
                 <a:tc>
@@ -5161,7 +4611,7 @@
                     <a:bodyPr/>
                     <a:lstStyle/>
                     <a:p>
-                      <a:pPr indent="0" marL="0">
+                      <a:pPr marL="0" indent="0">
                         <a:buNone/>
                       </a:pPr>
                       <a:r>
@@ -5175,7 +4625,7 @@
                       <a:endParaRPr lang="en-US" sz="1400" dirty="0"/>
                     </a:p>
                   </a:txBody>
-                  <a:tcPr marL="137160" marR="137160" marT="45720" marB="45720" anchor="ctr">
+                  <a:tcPr marL="137160" marR="137160" anchor="ctr">
                     <a:lnL w="0" cap="flat" cmpd="sng" algn="ctr">
                       <a:noFill/>
                     </a:lnL>
@@ -5210,7 +4660,7 @@
                     <a:bodyPr/>
                     <a:lstStyle/>
                     <a:p>
-                      <a:pPr indent="0" marL="0">
+                      <a:pPr marL="0" indent="0">
                         <a:buNone/>
                       </a:pPr>
                       <a:r>
@@ -5224,7 +4674,7 @@
                       <a:endParaRPr lang="en-US" sz="1400" dirty="0"/>
                     </a:p>
                   </a:txBody>
-                  <a:tcPr marL="137160" marR="137160" marT="45720" marB="45720" anchor="ctr">
+                  <a:tcPr marL="137160" marR="137160" anchor="ctr">
                     <a:lnL w="0" cap="flat" cmpd="sng" algn="ctr">
                       <a:noFill/>
                     </a:lnL>
@@ -5259,7 +4709,7 @@
                     <a:bodyPr/>
                     <a:lstStyle/>
                     <a:p>
-                      <a:pPr indent="0" marL="0">
+                      <a:pPr marL="0" indent="0">
                         <a:buNone/>
                       </a:pPr>
                       <a:r>
@@ -5273,7 +4723,7 @@
                       <a:endParaRPr lang="en-US" sz="1400" dirty="0"/>
                     </a:p>
                   </a:txBody>
-                  <a:tcPr marL="137160" marR="137160" marT="45720" marB="45720" anchor="ctr">
+                  <a:tcPr marL="137160" marR="137160" anchor="ctr">
                     <a:lnL w="0" cap="flat" cmpd="sng" algn="ctr">
                       <a:noFill/>
                     </a:lnL>
@@ -5303,6 +4753,11 @@
                     </a:solidFill>
                   </a:tcPr>
                 </a:tc>
+                <a:extLst>
+                  <a:ext uri="{0D108BD9-81ED-4DB2-BD59-A6C34878D82A}">
+                    <a16:rowId xmlns:a16="http://schemas.microsoft.com/office/drawing/2014/main" val="10004"/>
+                  </a:ext>
+                </a:extLst>
               </a:tr>
               <a:tr h="384048">
                 <a:tc>
@@ -5310,7 +4765,7 @@
                     <a:bodyPr/>
                     <a:lstStyle/>
                     <a:p>
-                      <a:pPr indent="0" marL="0">
+                      <a:pPr marL="0" indent="0">
                         <a:buNone/>
                       </a:pPr>
                       <a:r>
@@ -5324,7 +4779,7 @@
                       <a:endParaRPr lang="en-US" sz="1400" dirty="0"/>
                     </a:p>
                   </a:txBody>
-                  <a:tcPr marL="137160" marR="137160" marT="45720" marB="45720" anchor="ctr">
+                  <a:tcPr marL="137160" marR="137160" anchor="ctr">
                     <a:lnL w="0" cap="flat" cmpd="sng" algn="ctr">
                       <a:noFill/>
                     </a:lnL>
@@ -5359,7 +4814,7 @@
                     <a:bodyPr/>
                     <a:lstStyle/>
                     <a:p>
-                      <a:pPr indent="0" marL="0">
+                      <a:pPr marL="0" indent="0">
                         <a:buNone/>
                       </a:pPr>
                       <a:r>
@@ -5373,7 +4828,7 @@
                       <a:endParaRPr lang="en-US" sz="1400" dirty="0"/>
                     </a:p>
                   </a:txBody>
-                  <a:tcPr marL="137160" marR="137160" marT="45720" marB="45720" anchor="ctr">
+                  <a:tcPr marL="137160" marR="137160" anchor="ctr">
                     <a:lnL w="0" cap="flat" cmpd="sng" algn="ctr">
                       <a:noFill/>
                     </a:lnL>
@@ -5408,7 +4863,7 @@
                     <a:bodyPr/>
                     <a:lstStyle/>
                     <a:p>
-                      <a:pPr indent="0" marL="0">
+                      <a:pPr marL="0" indent="0">
                         <a:buNone/>
                       </a:pPr>
                       <a:r>
@@ -5422,7 +4877,7 @@
                       <a:endParaRPr lang="en-US" sz="1400" dirty="0"/>
                     </a:p>
                   </a:txBody>
-                  <a:tcPr marL="137160" marR="137160" marT="45720" marB="45720" anchor="ctr">
+                  <a:tcPr marL="137160" marR="137160" anchor="ctr">
                     <a:lnL w="0" cap="flat" cmpd="sng" algn="ctr">
                       <a:noFill/>
                     </a:lnL>
@@ -5452,6 +4907,11 @@
                     </a:solidFill>
                   </a:tcPr>
                 </a:tc>
+                <a:extLst>
+                  <a:ext uri="{0D108BD9-81ED-4DB2-BD59-A6C34878D82A}">
+                    <a16:rowId xmlns:a16="http://schemas.microsoft.com/office/drawing/2014/main" val="10005"/>
+                  </a:ext>
+                </a:extLst>
               </a:tr>
               <a:tr h="384048">
                 <a:tc>
@@ -5459,7 +4919,7 @@
                     <a:bodyPr/>
                     <a:lstStyle/>
                     <a:p>
-                      <a:pPr indent="0" marL="0">
+                      <a:pPr marL="0" indent="0">
                         <a:buNone/>
                       </a:pPr>
                       <a:r>
@@ -5473,7 +4933,7 @@
                       <a:endParaRPr lang="en-US" sz="1400" dirty="0"/>
                     </a:p>
                   </a:txBody>
-                  <a:tcPr marL="137160" marR="137160" marT="45720" marB="45720" anchor="ctr">
+                  <a:tcPr marL="137160" marR="137160" anchor="ctr">
                     <a:lnL w="0" cap="flat" cmpd="sng" algn="ctr">
                       <a:noFill/>
                     </a:lnL>
@@ -5508,7 +4968,7 @@
                     <a:bodyPr/>
                     <a:lstStyle/>
                     <a:p>
-                      <a:pPr indent="0" marL="0">
+                      <a:pPr marL="0" indent="0">
                         <a:buNone/>
                       </a:pPr>
                       <a:r>
@@ -5522,7 +4982,7 @@
                       <a:endParaRPr lang="en-US" sz="1400" dirty="0"/>
                     </a:p>
                   </a:txBody>
-                  <a:tcPr marL="137160" marR="137160" marT="45720" marB="45720" anchor="ctr">
+                  <a:tcPr marL="137160" marR="137160" anchor="ctr">
                     <a:lnL w="0" cap="flat" cmpd="sng" algn="ctr">
                       <a:noFill/>
                     </a:lnL>
@@ -5557,7 +5017,7 @@
                     <a:bodyPr/>
                     <a:lstStyle/>
                     <a:p>
-                      <a:pPr indent="0" marL="0">
+                      <a:pPr marL="0" indent="0">
                         <a:buNone/>
                       </a:pPr>
                       <a:r>
@@ -5571,7 +5031,7 @@
                       <a:endParaRPr lang="en-US" sz="1400" dirty="0"/>
                     </a:p>
                   </a:txBody>
-                  <a:tcPr marL="137160" marR="137160" marT="45720" marB="45720" anchor="ctr">
+                  <a:tcPr marL="137160" marR="137160" anchor="ctr">
                     <a:lnL w="0" cap="flat" cmpd="sng" algn="ctr">
                       <a:noFill/>
                     </a:lnL>
@@ -5601,6 +5061,11 @@
                     </a:solidFill>
                   </a:tcPr>
                 </a:tc>
+                <a:extLst>
+                  <a:ext uri="{0D108BD9-81ED-4DB2-BD59-A6C34878D82A}">
+                    <a16:rowId xmlns:a16="http://schemas.microsoft.com/office/drawing/2014/main" val="10006"/>
+                  </a:ext>
+                </a:extLst>
               </a:tr>
               <a:tr h="384048">
                 <a:tc>
@@ -5608,7 +5073,7 @@
                     <a:bodyPr/>
                     <a:lstStyle/>
                     <a:p>
-                      <a:pPr indent="0" marL="0">
+                      <a:pPr marL="0" indent="0">
                         <a:buNone/>
                       </a:pPr>
                       <a:r>
@@ -5622,7 +5087,7 @@
                       <a:endParaRPr lang="en-US" sz="1400" dirty="0"/>
                     </a:p>
                   </a:txBody>
-                  <a:tcPr marL="137160" marR="137160" marT="45720" marB="45720" anchor="ctr">
+                  <a:tcPr marL="137160" marR="137160" anchor="ctr">
                     <a:lnL w="0" cap="flat" cmpd="sng" algn="ctr">
                       <a:noFill/>
                     </a:lnL>
@@ -5657,7 +5122,7 @@
                     <a:bodyPr/>
                     <a:lstStyle/>
                     <a:p>
-                      <a:pPr indent="0" marL="0">
+                      <a:pPr marL="0" indent="0">
                         <a:buNone/>
                       </a:pPr>
                       <a:r>
@@ -5671,7 +5136,7 @@
                       <a:endParaRPr lang="en-US" sz="1400" dirty="0"/>
                     </a:p>
                   </a:txBody>
-                  <a:tcPr marL="137160" marR="137160" marT="45720" marB="45720" anchor="ctr">
+                  <a:tcPr marL="137160" marR="137160" anchor="ctr">
                     <a:lnL w="0" cap="flat" cmpd="sng" algn="ctr">
                       <a:noFill/>
                     </a:lnL>
@@ -5706,7 +5171,7 @@
                     <a:bodyPr/>
                     <a:lstStyle/>
                     <a:p>
-                      <a:pPr indent="0" marL="0">
+                      <a:pPr marL="0" indent="0">
                         <a:buNone/>
                       </a:pPr>
                       <a:r>
@@ -5720,7 +5185,7 @@
                       <a:endParaRPr lang="en-US" sz="1400" dirty="0"/>
                     </a:p>
                   </a:txBody>
-                  <a:tcPr marL="137160" marR="137160" marT="45720" marB="45720" anchor="ctr">
+                  <a:tcPr marL="137160" marR="137160" anchor="ctr">
                     <a:lnL w="0" cap="flat" cmpd="sng" algn="ctr">
                       <a:noFill/>
                     </a:lnL>
@@ -5750,6 +5215,11 @@
                     </a:solidFill>
                   </a:tcPr>
                 </a:tc>
+                <a:extLst>
+                  <a:ext uri="{0D108BD9-81ED-4DB2-BD59-A6C34878D82A}">
+                    <a16:rowId xmlns:a16="http://schemas.microsoft.com/office/drawing/2014/main" val="10007"/>
+                  </a:ext>
+                </a:extLst>
               </a:tr>
             </a:tbl>
           </a:graphicData>
@@ -5775,7 +5245,7 @@
           </a:prstGeom>
           <a:extLst>
             <a:ext uri="{C572A759-6A51-4108-AA02-DFA0A04FC94B}">
-              <ma14:wrappingTextBoxFlag xmlns:ma14="http://schemas.microsoft.com/office/mac/drawingml/2011/main" val="0"/>
+              <ma14:wrappingTextBoxFlag xmlns:ma14="http://schemas.microsoft.com/office/mac/drawingml/2011/main" xmlns="" val="0"/>
             </a:ext>
           </a:extLst>
         </p:spPr>
@@ -5793,7 +5263,7 @@
           <a:p>
             <a:pPr algn="r"/>
             <a:fld id="{F7021451-1387-4CA6-816F-3879F97B5CBC}" type="slidenum">
-              <a:rPr b="0" lang="en-US"/>
+              <a:rPr lang="en-US" b="0"/>
               <a:t>6</a:t>
             </a:fld>
             <a:endParaRPr lang="en-US"/>
@@ -5828,9 +5298,11 @@
       <p:sp>
         <p:nvSpPr>
           <p:cNvPr id="2" name="Text 1"/>
-          <p:cNvSpPr/>
+          <p:cNvSpPr>
+            <a:spLocks noGrp="1"/>
+          </p:cNvSpPr>
           <p:nvPr>
-            <p:ph idx="101" type="title" hasCustomPrompt="1"/>
+            <p:ph type="title" idx="101" hasCustomPrompt="1"/>
           </p:nvPr>
         </p:nvSpPr>
         <p:spPr>
@@ -5848,7 +5320,7 @@
           <a:bodyPr wrap="square" lIns="0" tIns="0" rIns="0" bIns="0" rtlCol="0" anchor="ctr"/>
           <a:lstStyle/>
           <a:p>
-            <a:pPr indent="0" marL="0">
+            <a:pPr marL="0" indent="0">
               <a:buNone/>
             </a:pPr>
             <a:r>
@@ -5879,16 +5351,34 @@
         </p:nvGraphicFramePr>
         <p:xfrm>
           <a:off x="548640" y="1188720"/>
-          <a:ext cx="8046720" cy="914400"/>
+          <a:ext cx="8046720" cy="3291840"/>
         </p:xfrm>
         <a:graphic>
           <a:graphicData uri="http://schemas.openxmlformats.org/drawingml/2006/table">
             <a:tbl>
               <a:tblPr/>
               <a:tblGrid>
-                <a:gridCol w="640080"/>
-                <a:gridCol w="5486400"/>
-                <a:gridCol w="1920240"/>
+                <a:gridCol w="640080">
+                  <a:extLst>
+                    <a:ext uri="{9D8B030D-6E8A-4147-A177-3AD203B41FA5}">
+                      <a16:colId xmlns:a16="http://schemas.microsoft.com/office/drawing/2014/main" val="20000"/>
+                    </a:ext>
+                  </a:extLst>
+                </a:gridCol>
+                <a:gridCol w="5486400">
+                  <a:extLst>
+                    <a:ext uri="{9D8B030D-6E8A-4147-A177-3AD203B41FA5}">
+                      <a16:colId xmlns:a16="http://schemas.microsoft.com/office/drawing/2014/main" val="20001"/>
+                    </a:ext>
+                  </a:extLst>
+                </a:gridCol>
+                <a:gridCol w="1920240">
+                  <a:extLst>
+                    <a:ext uri="{9D8B030D-6E8A-4147-A177-3AD203B41FA5}">
+                      <a16:colId xmlns:a16="http://schemas.microsoft.com/office/drawing/2014/main" val="20002"/>
+                    </a:ext>
+                  </a:extLst>
+                </a:gridCol>
               </a:tblGrid>
               <a:tr h="365760">
                 <a:tc>
@@ -5896,7 +5386,7 @@
                     <a:bodyPr/>
                     <a:lstStyle/>
                     <a:p>
-                      <a:pPr algn="l" indent="0" marL="0">
+                      <a:pPr marL="0" indent="0" algn="l">
                         <a:buNone/>
                       </a:pPr>
                       <a:r>
@@ -5910,7 +5400,7 @@
                       <a:endParaRPr lang="en-US" sz="1400" dirty="0"/>
                     </a:p>
                   </a:txBody>
-                  <a:tcPr marL="137160" marR="137160" marT="45720" marB="45720" anchor="ctr">
+                  <a:tcPr marL="137160" marR="137160" anchor="ctr">
                     <a:lnL w="0" cap="flat" cmpd="sng" algn="ctr">
                       <a:noFill/>
                     </a:lnL>
@@ -5945,7 +5435,7 @@
                     <a:bodyPr/>
                     <a:lstStyle/>
                     <a:p>
-                      <a:pPr algn="l" indent="0" marL="0">
+                      <a:pPr marL="0" indent="0" algn="l">
                         <a:buNone/>
                       </a:pPr>
                       <a:r>
@@ -5959,7 +5449,7 @@
                       <a:endParaRPr lang="en-US" sz="1400" dirty="0"/>
                     </a:p>
                   </a:txBody>
-                  <a:tcPr marL="137160" marR="137160" marT="45720" marB="45720" anchor="ctr">
+                  <a:tcPr marL="137160" marR="137160" anchor="ctr">
                     <a:lnL w="0" cap="flat" cmpd="sng" algn="ctr">
                       <a:noFill/>
                     </a:lnL>
@@ -5994,7 +5484,7 @@
                     <a:bodyPr/>
                     <a:lstStyle/>
                     <a:p>
-                      <a:pPr algn="ctr" indent="0" marL="0">
+                      <a:pPr marL="0" indent="0" algn="ctr">
                         <a:buNone/>
                       </a:pPr>
                       <a:r>
@@ -6008,7 +5498,7 @@
                       <a:endParaRPr lang="en-US" sz="1400" dirty="0"/>
                     </a:p>
                   </a:txBody>
-                  <a:tcPr marL="137160" marR="137160" marT="45720" marB="45720" anchor="ctr">
+                  <a:tcPr marL="137160" marR="137160" anchor="ctr">
                     <a:lnL w="0" cap="flat" cmpd="sng" algn="ctr">
                       <a:noFill/>
                     </a:lnL>
@@ -6038,6 +5528,11 @@
                     </a:solidFill>
                   </a:tcPr>
                 </a:tc>
+                <a:extLst>
+                  <a:ext uri="{0D108BD9-81ED-4DB2-BD59-A6C34878D82A}">
+                    <a16:rowId xmlns:a16="http://schemas.microsoft.com/office/drawing/2014/main" val="10000"/>
+                  </a:ext>
+                </a:extLst>
               </a:tr>
               <a:tr h="365760">
                 <a:tc>
@@ -6045,7 +5540,7 @@
                     <a:bodyPr/>
                     <a:lstStyle/>
                     <a:p>
-                      <a:pPr indent="0" marL="0">
+                      <a:pPr marL="0" indent="0">
                         <a:buNone/>
                       </a:pPr>
                       <a:r>
@@ -6059,7 +5554,7 @@
                       <a:endParaRPr lang="en-US" sz="1400" dirty="0"/>
                     </a:p>
                   </a:txBody>
-                  <a:tcPr marL="137160" marR="137160" marT="45720" marB="45720" anchor="ctr">
+                  <a:tcPr marL="137160" marR="137160" anchor="ctr">
                     <a:lnL w="0" cap="flat" cmpd="sng" algn="ctr">
                       <a:noFill/>
                     </a:lnL>
@@ -6094,7 +5589,7 @@
                     <a:bodyPr/>
                     <a:lstStyle/>
                     <a:p>
-                      <a:pPr indent="0" marL="0">
+                      <a:pPr marL="0" indent="0">
                         <a:buNone/>
                       </a:pPr>
                       <a:r>
@@ -6108,7 +5603,7 @@
                       <a:endParaRPr lang="en-US" sz="1400" dirty="0"/>
                     </a:p>
                   </a:txBody>
-                  <a:tcPr marL="137160" marR="137160" marT="45720" marB="45720" anchor="ctr">
+                  <a:tcPr marL="137160" marR="137160" anchor="ctr">
                     <a:lnL w="0" cap="flat" cmpd="sng" algn="ctr">
                       <a:noFill/>
                     </a:lnL>
@@ -6143,7 +5638,7 @@
                     <a:bodyPr/>
                     <a:lstStyle/>
                     <a:p>
-                      <a:pPr algn="ctr" indent="0" marL="0">
+                      <a:pPr marL="0" indent="0" algn="ctr">
                         <a:buNone/>
                       </a:pPr>
                       <a:r>
@@ -6157,7 +5652,7 @@
                       <a:endParaRPr lang="en-US" sz="1400" dirty="0"/>
                     </a:p>
                   </a:txBody>
-                  <a:tcPr marL="137160" marR="137160" marT="45720" marB="45720" anchor="ctr">
+                  <a:tcPr marL="137160" marR="137160" anchor="ctr">
                     <a:lnL w="0" cap="flat" cmpd="sng" algn="ctr">
                       <a:noFill/>
                     </a:lnL>
@@ -6187,6 +5682,11 @@
                     </a:solidFill>
                   </a:tcPr>
                 </a:tc>
+                <a:extLst>
+                  <a:ext uri="{0D108BD9-81ED-4DB2-BD59-A6C34878D82A}">
+                    <a16:rowId xmlns:a16="http://schemas.microsoft.com/office/drawing/2014/main" val="10001"/>
+                  </a:ext>
+                </a:extLst>
               </a:tr>
               <a:tr h="365760">
                 <a:tc>
@@ -6194,7 +5694,7 @@
                     <a:bodyPr/>
                     <a:lstStyle/>
                     <a:p>
-                      <a:pPr indent="0" marL="0">
+                      <a:pPr marL="0" indent="0">
                         <a:buNone/>
                       </a:pPr>
                       <a:r>
@@ -6208,7 +5708,7 @@
                       <a:endParaRPr lang="en-US" sz="1400" dirty="0"/>
                     </a:p>
                   </a:txBody>
-                  <a:tcPr marL="137160" marR="137160" marT="45720" marB="45720" anchor="ctr">
+                  <a:tcPr marL="137160" marR="137160" anchor="ctr">
                     <a:lnL w="0" cap="flat" cmpd="sng" algn="ctr">
                       <a:noFill/>
                     </a:lnL>
@@ -6243,7 +5743,7 @@
                     <a:bodyPr/>
                     <a:lstStyle/>
                     <a:p>
-                      <a:pPr indent="0" marL="0">
+                      <a:pPr marL="0" indent="0">
                         <a:buNone/>
                       </a:pPr>
                       <a:r>
@@ -6257,7 +5757,7 @@
                       <a:endParaRPr lang="en-US" sz="1400" dirty="0"/>
                     </a:p>
                   </a:txBody>
-                  <a:tcPr marL="137160" marR="137160" marT="45720" marB="45720" anchor="ctr">
+                  <a:tcPr marL="137160" marR="137160" anchor="ctr">
                     <a:lnL w="0" cap="flat" cmpd="sng" algn="ctr">
                       <a:noFill/>
                     </a:lnL>
@@ -6292,7 +5792,7 @@
                     <a:bodyPr/>
                     <a:lstStyle/>
                     <a:p>
-                      <a:pPr algn="ctr" indent="0" marL="0">
+                      <a:pPr marL="0" indent="0" algn="ctr">
                         <a:buNone/>
                       </a:pPr>
                       <a:r>
@@ -6306,7 +5806,7 @@
                       <a:endParaRPr lang="en-US" sz="1400" dirty="0"/>
                     </a:p>
                   </a:txBody>
-                  <a:tcPr marL="137160" marR="137160" marT="45720" marB="45720" anchor="ctr">
+                  <a:tcPr marL="137160" marR="137160" anchor="ctr">
                     <a:lnL w="0" cap="flat" cmpd="sng" algn="ctr">
                       <a:noFill/>
                     </a:lnL>
@@ -6336,6 +5836,11 @@
                     </a:solidFill>
                   </a:tcPr>
                 </a:tc>
+                <a:extLst>
+                  <a:ext uri="{0D108BD9-81ED-4DB2-BD59-A6C34878D82A}">
+                    <a16:rowId xmlns:a16="http://schemas.microsoft.com/office/drawing/2014/main" val="10002"/>
+                  </a:ext>
+                </a:extLst>
               </a:tr>
               <a:tr h="365760">
                 <a:tc>
@@ -6343,7 +5848,7 @@
                     <a:bodyPr/>
                     <a:lstStyle/>
                     <a:p>
-                      <a:pPr indent="0" marL="0">
+                      <a:pPr marL="0" indent="0">
                         <a:buNone/>
                       </a:pPr>
                       <a:r>
@@ -6357,7 +5862,7 @@
                       <a:endParaRPr lang="en-US" sz="1400" dirty="0"/>
                     </a:p>
                   </a:txBody>
-                  <a:tcPr marL="137160" marR="137160" marT="45720" marB="45720" anchor="ctr">
+                  <a:tcPr marL="137160" marR="137160" anchor="ctr">
                     <a:lnL w="0" cap="flat" cmpd="sng" algn="ctr">
                       <a:noFill/>
                     </a:lnL>
@@ -6392,7 +5897,7 @@
                     <a:bodyPr/>
                     <a:lstStyle/>
                     <a:p>
-                      <a:pPr indent="0" marL="0">
+                      <a:pPr marL="0" indent="0">
                         <a:buNone/>
                       </a:pPr>
                       <a:r>
@@ -6406,7 +5911,7 @@
                       <a:endParaRPr lang="en-US" sz="1400" dirty="0"/>
                     </a:p>
                   </a:txBody>
-                  <a:tcPr marL="137160" marR="137160" marT="45720" marB="45720" anchor="ctr">
+                  <a:tcPr marL="137160" marR="137160" anchor="ctr">
                     <a:lnL w="0" cap="flat" cmpd="sng" algn="ctr">
                       <a:noFill/>
                     </a:lnL>
@@ -6441,7 +5946,7 @@
                     <a:bodyPr/>
                     <a:lstStyle/>
                     <a:p>
-                      <a:pPr algn="ctr" indent="0" marL="0">
+                      <a:pPr marL="0" indent="0" algn="ctr">
                         <a:buNone/>
                       </a:pPr>
                       <a:r>
@@ -6455,7 +5960,7 @@
                       <a:endParaRPr lang="en-US" sz="1400" dirty="0"/>
                     </a:p>
                   </a:txBody>
-                  <a:tcPr marL="137160" marR="137160" marT="45720" marB="45720" anchor="ctr">
+                  <a:tcPr marL="137160" marR="137160" anchor="ctr">
                     <a:lnL w="0" cap="flat" cmpd="sng" algn="ctr">
                       <a:noFill/>
                     </a:lnL>
@@ -6485,6 +5990,11 @@
                     </a:solidFill>
                   </a:tcPr>
                 </a:tc>
+                <a:extLst>
+                  <a:ext uri="{0D108BD9-81ED-4DB2-BD59-A6C34878D82A}">
+                    <a16:rowId xmlns:a16="http://schemas.microsoft.com/office/drawing/2014/main" val="10003"/>
+                  </a:ext>
+                </a:extLst>
               </a:tr>
               <a:tr h="365760">
                 <a:tc>
@@ -6492,7 +6002,7 @@
                     <a:bodyPr/>
                     <a:lstStyle/>
                     <a:p>
-                      <a:pPr indent="0" marL="0">
+                      <a:pPr marL="0" indent="0">
                         <a:buNone/>
                       </a:pPr>
                       <a:r>
@@ -6506,7 +6016,7 @@
                       <a:endParaRPr lang="en-US" sz="1400" dirty="0"/>
                     </a:p>
                   </a:txBody>
-                  <a:tcPr marL="137160" marR="137160" marT="45720" marB="45720" anchor="ctr">
+                  <a:tcPr marL="137160" marR="137160" anchor="ctr">
                     <a:lnL w="0" cap="flat" cmpd="sng" algn="ctr">
                       <a:noFill/>
                     </a:lnL>
@@ -6541,7 +6051,7 @@
                     <a:bodyPr/>
                     <a:lstStyle/>
                     <a:p>
-                      <a:pPr indent="0" marL="0">
+                      <a:pPr marL="0" indent="0">
                         <a:buNone/>
                       </a:pPr>
                       <a:r>
@@ -6555,7 +6065,7 @@
                       <a:endParaRPr lang="en-US" sz="1400" dirty="0"/>
                     </a:p>
                   </a:txBody>
-                  <a:tcPr marL="137160" marR="137160" marT="45720" marB="45720" anchor="ctr">
+                  <a:tcPr marL="137160" marR="137160" anchor="ctr">
                     <a:lnL w="0" cap="flat" cmpd="sng" algn="ctr">
                       <a:noFill/>
                     </a:lnL>
@@ -6590,7 +6100,7 @@
                     <a:bodyPr/>
                     <a:lstStyle/>
                     <a:p>
-                      <a:pPr algn="ctr" indent="0" marL="0">
+                      <a:pPr marL="0" indent="0" algn="ctr">
                         <a:buNone/>
                       </a:pPr>
                       <a:r>
@@ -6604,7 +6114,7 @@
                       <a:endParaRPr lang="en-US" sz="1400" dirty="0"/>
                     </a:p>
                   </a:txBody>
-                  <a:tcPr marL="137160" marR="137160" marT="45720" marB="45720" anchor="ctr">
+                  <a:tcPr marL="137160" marR="137160" anchor="ctr">
                     <a:lnL w="0" cap="flat" cmpd="sng" algn="ctr">
                       <a:noFill/>
                     </a:lnL>
@@ -6634,6 +6144,11 @@
                     </a:solidFill>
                   </a:tcPr>
                 </a:tc>
+                <a:extLst>
+                  <a:ext uri="{0D108BD9-81ED-4DB2-BD59-A6C34878D82A}">
+                    <a16:rowId xmlns:a16="http://schemas.microsoft.com/office/drawing/2014/main" val="10004"/>
+                  </a:ext>
+                </a:extLst>
               </a:tr>
               <a:tr h="365760">
                 <a:tc>
@@ -6641,7 +6156,7 @@
                     <a:bodyPr/>
                     <a:lstStyle/>
                     <a:p>
-                      <a:pPr indent="0" marL="0">
+                      <a:pPr marL="0" indent="0">
                         <a:buNone/>
                       </a:pPr>
                       <a:r>
@@ -6655,7 +6170,7 @@
                       <a:endParaRPr lang="en-US" sz="1400" dirty="0"/>
                     </a:p>
                   </a:txBody>
-                  <a:tcPr marL="137160" marR="137160" marT="45720" marB="45720" anchor="ctr">
+                  <a:tcPr marL="137160" marR="137160" anchor="ctr">
                     <a:lnL w="0" cap="flat" cmpd="sng" algn="ctr">
                       <a:noFill/>
                     </a:lnL>
@@ -6690,7 +6205,7 @@
                     <a:bodyPr/>
                     <a:lstStyle/>
                     <a:p>
-                      <a:pPr indent="0" marL="0">
+                      <a:pPr marL="0" indent="0">
                         <a:buNone/>
                       </a:pPr>
                       <a:r>
@@ -6704,7 +6219,7 @@
                       <a:endParaRPr lang="en-US" sz="1400" dirty="0"/>
                     </a:p>
                   </a:txBody>
-                  <a:tcPr marL="137160" marR="137160" marT="45720" marB="45720" anchor="ctr">
+                  <a:tcPr marL="137160" marR="137160" anchor="ctr">
                     <a:lnL w="0" cap="flat" cmpd="sng" algn="ctr">
                       <a:noFill/>
                     </a:lnL>
@@ -6739,7 +6254,7 @@
                     <a:bodyPr/>
                     <a:lstStyle/>
                     <a:p>
-                      <a:pPr algn="ctr" indent="0" marL="0">
+                      <a:pPr marL="0" indent="0" algn="ctr">
                         <a:buNone/>
                       </a:pPr>
                       <a:r>
@@ -6753,7 +6268,7 @@
                       <a:endParaRPr lang="en-US" sz="1400" dirty="0"/>
                     </a:p>
                   </a:txBody>
-                  <a:tcPr marL="137160" marR="137160" marT="45720" marB="45720" anchor="ctr">
+                  <a:tcPr marL="137160" marR="137160" anchor="ctr">
                     <a:lnL w="0" cap="flat" cmpd="sng" algn="ctr">
                       <a:noFill/>
                     </a:lnL>
@@ -6783,6 +6298,11 @@
                     </a:solidFill>
                   </a:tcPr>
                 </a:tc>
+                <a:extLst>
+                  <a:ext uri="{0D108BD9-81ED-4DB2-BD59-A6C34878D82A}">
+                    <a16:rowId xmlns:a16="http://schemas.microsoft.com/office/drawing/2014/main" val="10005"/>
+                  </a:ext>
+                </a:extLst>
               </a:tr>
               <a:tr h="365760">
                 <a:tc>
@@ -6790,7 +6310,7 @@
                     <a:bodyPr/>
                     <a:lstStyle/>
                     <a:p>
-                      <a:pPr indent="0" marL="0">
+                      <a:pPr marL="0" indent="0">
                         <a:buNone/>
                       </a:pPr>
                       <a:r>
@@ -6804,7 +6324,7 @@
                       <a:endParaRPr lang="en-US" sz="1400" dirty="0"/>
                     </a:p>
                   </a:txBody>
-                  <a:tcPr marL="137160" marR="137160" marT="45720" marB="45720" anchor="ctr">
+                  <a:tcPr marL="137160" marR="137160" anchor="ctr">
                     <a:lnL w="0" cap="flat" cmpd="sng" algn="ctr">
                       <a:noFill/>
                     </a:lnL>
@@ -6839,7 +6359,7 @@
                     <a:bodyPr/>
                     <a:lstStyle/>
                     <a:p>
-                      <a:pPr indent="0" marL="0">
+                      <a:pPr marL="0" indent="0">
                         <a:buNone/>
                       </a:pPr>
                       <a:r>
@@ -6853,7 +6373,7 @@
                       <a:endParaRPr lang="en-US" sz="1400" dirty="0"/>
                     </a:p>
                   </a:txBody>
-                  <a:tcPr marL="137160" marR="137160" marT="45720" marB="45720" anchor="ctr">
+                  <a:tcPr marL="137160" marR="137160" anchor="ctr">
                     <a:lnL w="0" cap="flat" cmpd="sng" algn="ctr">
                       <a:noFill/>
                     </a:lnL>
@@ -6888,7 +6408,7 @@
                     <a:bodyPr/>
                     <a:lstStyle/>
                     <a:p>
-                      <a:pPr algn="ctr" indent="0" marL="0">
+                      <a:pPr marL="0" indent="0" algn="ctr">
                         <a:buNone/>
                       </a:pPr>
                       <a:r>
@@ -6902,7 +6422,7 @@
                       <a:endParaRPr lang="en-US" sz="1400" dirty="0"/>
                     </a:p>
                   </a:txBody>
-                  <a:tcPr marL="137160" marR="137160" marT="45720" marB="45720" anchor="ctr">
+                  <a:tcPr marL="137160" marR="137160" anchor="ctr">
                     <a:lnL w="0" cap="flat" cmpd="sng" algn="ctr">
                       <a:noFill/>
                     </a:lnL>
@@ -6932,6 +6452,11 @@
                     </a:solidFill>
                   </a:tcPr>
                 </a:tc>
+                <a:extLst>
+                  <a:ext uri="{0D108BD9-81ED-4DB2-BD59-A6C34878D82A}">
+                    <a16:rowId xmlns:a16="http://schemas.microsoft.com/office/drawing/2014/main" val="10006"/>
+                  </a:ext>
+                </a:extLst>
               </a:tr>
               <a:tr h="365760">
                 <a:tc>
@@ -6939,7 +6464,7 @@
                     <a:bodyPr/>
                     <a:lstStyle/>
                     <a:p>
-                      <a:pPr indent="0" marL="0">
+                      <a:pPr marL="0" indent="0">
                         <a:buNone/>
                       </a:pPr>
                       <a:r>
@@ -6953,7 +6478,7 @@
                       <a:endParaRPr lang="en-US" sz="1400" dirty="0"/>
                     </a:p>
                   </a:txBody>
-                  <a:tcPr marL="137160" marR="137160" marT="45720" marB="45720" anchor="ctr">
+                  <a:tcPr marL="137160" marR="137160" anchor="ctr">
                     <a:lnL w="0" cap="flat" cmpd="sng" algn="ctr">
                       <a:noFill/>
                     </a:lnL>
@@ -6988,7 +6513,7 @@
                     <a:bodyPr/>
                     <a:lstStyle/>
                     <a:p>
-                      <a:pPr indent="0" marL="0">
+                      <a:pPr marL="0" indent="0">
                         <a:buNone/>
                       </a:pPr>
                       <a:r>
@@ -7002,7 +6527,7 @@
                       <a:endParaRPr lang="en-US" sz="1400" dirty="0"/>
                     </a:p>
                   </a:txBody>
-                  <a:tcPr marL="137160" marR="137160" marT="45720" marB="45720" anchor="ctr">
+                  <a:tcPr marL="137160" marR="137160" anchor="ctr">
                     <a:lnL w="0" cap="flat" cmpd="sng" algn="ctr">
                       <a:noFill/>
                     </a:lnL>
@@ -7037,7 +6562,7 @@
                     <a:bodyPr/>
                     <a:lstStyle/>
                     <a:p>
-                      <a:pPr algn="ctr" indent="0" marL="0">
+                      <a:pPr marL="0" indent="0" algn="ctr">
                         <a:buNone/>
                       </a:pPr>
                       <a:r>
@@ -7051,7 +6576,7 @@
                       <a:endParaRPr lang="en-US" sz="1400" dirty="0"/>
                     </a:p>
                   </a:txBody>
-                  <a:tcPr marL="137160" marR="137160" marT="45720" marB="45720" anchor="ctr">
+                  <a:tcPr marL="137160" marR="137160" anchor="ctr">
                     <a:lnL w="0" cap="flat" cmpd="sng" algn="ctr">
                       <a:noFill/>
                     </a:lnL>
@@ -7081,6 +6606,11 @@
                     </a:solidFill>
                   </a:tcPr>
                 </a:tc>
+                <a:extLst>
+                  <a:ext uri="{0D108BD9-81ED-4DB2-BD59-A6C34878D82A}">
+                    <a16:rowId xmlns:a16="http://schemas.microsoft.com/office/drawing/2014/main" val="10007"/>
+                  </a:ext>
+                </a:extLst>
               </a:tr>
               <a:tr h="365760">
                 <a:tc>
@@ -7088,7 +6618,7 @@
                     <a:bodyPr/>
                     <a:lstStyle/>
                     <a:p>
-                      <a:pPr indent="0" marL="0">
+                      <a:pPr marL="0" indent="0">
                         <a:buNone/>
                       </a:pPr>
                       <a:r>
@@ -7102,7 +6632,7 @@
                       <a:endParaRPr lang="en-US" sz="1400" dirty="0"/>
                     </a:p>
                   </a:txBody>
-                  <a:tcPr marL="137160" marR="137160" marT="45720" marB="45720" anchor="ctr">
+                  <a:tcPr marL="137160" marR="137160" anchor="ctr">
                     <a:lnL w="0" cap="flat" cmpd="sng" algn="ctr">
                       <a:noFill/>
                     </a:lnL>
@@ -7137,7 +6667,7 @@
                     <a:bodyPr/>
                     <a:lstStyle/>
                     <a:p>
-                      <a:pPr indent="0" marL="0">
+                      <a:pPr marL="0" indent="0">
                         <a:buNone/>
                       </a:pPr>
                       <a:r>
@@ -7151,7 +6681,7 @@
                       <a:endParaRPr lang="en-US" sz="1400" dirty="0"/>
                     </a:p>
                   </a:txBody>
-                  <a:tcPr marL="137160" marR="137160" marT="45720" marB="45720" anchor="ctr">
+                  <a:tcPr marL="137160" marR="137160" anchor="ctr">
                     <a:lnL w="0" cap="flat" cmpd="sng" algn="ctr">
                       <a:noFill/>
                     </a:lnL>
@@ -7186,7 +6716,7 @@
                     <a:bodyPr/>
                     <a:lstStyle/>
                     <a:p>
-                      <a:pPr algn="ctr" indent="0" marL="0">
+                      <a:pPr marL="0" indent="0" algn="ctr">
                         <a:buNone/>
                       </a:pPr>
                       <a:r>
@@ -7200,7 +6730,7 @@
                       <a:endParaRPr lang="en-US" sz="1400" dirty="0"/>
                     </a:p>
                   </a:txBody>
-                  <a:tcPr marL="137160" marR="137160" marT="45720" marB="45720" anchor="ctr">
+                  <a:tcPr marL="137160" marR="137160" anchor="ctr">
                     <a:lnL w="0" cap="flat" cmpd="sng" algn="ctr">
                       <a:noFill/>
                     </a:lnL>
@@ -7230,6 +6760,11 @@
                     </a:solidFill>
                   </a:tcPr>
                 </a:tc>
+                <a:extLst>
+                  <a:ext uri="{0D108BD9-81ED-4DB2-BD59-A6C34878D82A}">
+                    <a16:rowId xmlns:a16="http://schemas.microsoft.com/office/drawing/2014/main" val="10008"/>
+                  </a:ext>
+                </a:extLst>
               </a:tr>
             </a:tbl>
           </a:graphicData>
@@ -7255,7 +6790,7 @@
           </a:prstGeom>
           <a:extLst>
             <a:ext uri="{C572A759-6A51-4108-AA02-DFA0A04FC94B}">
-              <ma14:wrappingTextBoxFlag xmlns:ma14="http://schemas.microsoft.com/office/mac/drawingml/2011/main" val="0"/>
+              <ma14:wrappingTextBoxFlag xmlns:ma14="http://schemas.microsoft.com/office/mac/drawingml/2011/main" xmlns="" val="0"/>
             </a:ext>
           </a:extLst>
         </p:spPr>
@@ -7273,7 +6808,7 @@
           <a:p>
             <a:pPr algn="r"/>
             <a:fld id="{F7021451-1387-4CA6-816F-3879F97B5CBC}" type="slidenum">
-              <a:rPr b="0" lang="en-US"/>
+              <a:rPr lang="en-US" b="0"/>
               <a:t>7</a:t>
             </a:fld>
             <a:endParaRPr lang="en-US"/>
@@ -7308,9 +6843,11 @@
       <p:sp>
         <p:nvSpPr>
           <p:cNvPr id="2" name="Text 1"/>
-          <p:cNvSpPr/>
+          <p:cNvSpPr>
+            <a:spLocks noGrp="1"/>
+          </p:cNvSpPr>
           <p:nvPr>
-            <p:ph idx="101" type="title" hasCustomPrompt="1"/>
+            <p:ph type="title" idx="101" hasCustomPrompt="1"/>
           </p:nvPr>
         </p:nvSpPr>
         <p:spPr>
@@ -7328,7 +6865,7 @@
           <a:bodyPr wrap="square" lIns="0" tIns="0" rIns="0" bIns="0" rtlCol="0" anchor="ctr"/>
           <a:lstStyle/>
           <a:p>
-            <a:pPr indent="0" marL="0">
+            <a:pPr marL="0" indent="0">
               <a:buNone/>
             </a:pPr>
             <a:r>
@@ -7364,6 +6901,13 @@
           </a:solidFill>
           <a:ln/>
         </p:spPr>
+        <p:txBody>
+          <a:bodyPr/>
+          <a:lstStyle/>
+          <a:p>
+            <a:endParaRPr lang="cs-CZ"/>
+          </a:p>
+        </p:txBody>
       </p:sp>
       <p:sp>
         <p:nvSpPr>
@@ -7384,17 +6928,24 @@
           </a:solidFill>
           <a:ln/>
         </p:spPr>
+        <p:txBody>
+          <a:bodyPr/>
+          <a:lstStyle/>
+          <a:p>
+            <a:endParaRPr lang="cs-CZ"/>
+          </a:p>
+        </p:txBody>
       </p:sp>
       <p:pic>
         <p:nvPicPr>
-          <p:cNvPr id="5" name="Fotky nepotřebuje icon" descr="Fotky nepotřebuje">    </p:cNvPr>
+          <p:cNvPr id="5" name="Fotky nepotřebuje icon" descr="Fotky nepotřebuje"/>
           <p:cNvPicPr>
             <a:picLocks noChangeAspect="1"/>
           </p:cNvPicPr>
           <p:nvPr/>
         </p:nvPicPr>
         <p:blipFill>
-          <a:blip r:embed="rId1"/>
+          <a:blip r:embed="rId3"/>
           <a:stretch>
             <a:fillRect/>
           </a:stretch>
@@ -7430,7 +6981,7 @@
           <a:bodyPr wrap="square" lIns="0" tIns="0" rIns="0" bIns="0" rtlCol="0" anchor="b"/>
           <a:lstStyle/>
           <a:p>
-            <a:pPr indent="0" marL="0">
+            <a:pPr marL="0" indent="0">
               <a:buNone/>
             </a:pPr>
             <a:r>
@@ -7466,7 +7017,7 @@
           <a:bodyPr wrap="square" lIns="0" tIns="0" rIns="0" bIns="0" rtlCol="0" anchor="t"/>
           <a:lstStyle/>
           <a:p>
-            <a:pPr indent="0" marL="0">
+            <a:pPr marL="0" indent="0">
               <a:buNone/>
             </a:pPr>
             <a:r>
@@ -7502,6 +7053,13 @@
           </a:solidFill>
           <a:ln/>
         </p:spPr>
+        <p:txBody>
+          <a:bodyPr/>
+          <a:lstStyle/>
+          <a:p>
+            <a:endParaRPr lang="cs-CZ"/>
+          </a:p>
+        </p:txBody>
       </p:sp>
       <p:sp>
         <p:nvSpPr>
@@ -7522,17 +7080,24 @@
           </a:solidFill>
           <a:ln/>
         </p:spPr>
+        <p:txBody>
+          <a:bodyPr/>
+          <a:lstStyle/>
+          <a:p>
+            <a:endParaRPr lang="cs-CZ"/>
+          </a:p>
+        </p:txBody>
       </p:sp>
       <p:pic>
         <p:nvPicPr>
-          <p:cNvPr id="10" name="Procenta nezapisuje icon" descr="Procenta nezapisuje">    </p:cNvPr>
+          <p:cNvPr id="10" name="Procenta nezapisuje icon" descr="Procenta nezapisuje"/>
           <p:cNvPicPr>
             <a:picLocks noChangeAspect="1"/>
           </p:cNvPicPr>
           <p:nvPr/>
         </p:nvPicPr>
         <p:blipFill>
-          <a:blip r:embed="rId2"/>
+          <a:blip r:embed="rId4"/>
           <a:stretch>
             <a:fillRect/>
           </a:stretch>
@@ -7568,7 +7133,7 @@
           <a:bodyPr wrap="square" lIns="0" tIns="0" rIns="0" bIns="0" rtlCol="0" anchor="b"/>
           <a:lstStyle/>
           <a:p>
-            <a:pPr indent="0" marL="0">
+            <a:pPr marL="0" indent="0">
               <a:buNone/>
             </a:pPr>
             <a:r>
@@ -7604,7 +7169,7 @@
           <a:bodyPr wrap="square" lIns="0" tIns="0" rIns="0" bIns="0" rtlCol="0" anchor="t"/>
           <a:lstStyle/>
           <a:p>
-            <a:pPr indent="0" marL="0">
+            <a:pPr marL="0" indent="0">
               <a:buNone/>
             </a:pPr>
             <a:r>
@@ -7640,6 +7205,13 @@
           </a:solidFill>
           <a:ln/>
         </p:spPr>
+        <p:txBody>
+          <a:bodyPr/>
+          <a:lstStyle/>
+          <a:p>
+            <a:endParaRPr lang="cs-CZ"/>
+          </a:p>
+        </p:txBody>
       </p:sp>
       <p:sp>
         <p:nvSpPr>
@@ -7660,17 +7232,24 @@
           </a:solidFill>
           <a:ln/>
         </p:spPr>
+        <p:txBody>
+          <a:bodyPr/>
+          <a:lstStyle/>
+          <a:p>
+            <a:endParaRPr lang="cs-CZ"/>
+          </a:p>
+        </p:txBody>
       </p:sp>
       <p:pic>
         <p:nvPicPr>
-          <p:cNvPr id="15" name="Žádné placené nástroje icon" descr="Žádné placené nástroje">    </p:cNvPr>
+          <p:cNvPr id="15" name="Žádné placené nástroje icon" descr="Žádné placené nástroje"/>
           <p:cNvPicPr>
             <a:picLocks noChangeAspect="1"/>
           </p:cNvPicPr>
           <p:nvPr/>
         </p:nvPicPr>
         <p:blipFill>
-          <a:blip r:embed="rId3"/>
+          <a:blip r:embed="rId5"/>
           <a:stretch>
             <a:fillRect/>
           </a:stretch>
@@ -7706,7 +7285,7 @@
           <a:bodyPr wrap="square" lIns="0" tIns="0" rIns="0" bIns="0" rtlCol="0" anchor="b"/>
           <a:lstStyle/>
           <a:p>
-            <a:pPr indent="0" marL="0">
+            <a:pPr marL="0" indent="0">
               <a:buNone/>
             </a:pPr>
             <a:r>
@@ -7742,7 +7321,7 @@
           <a:bodyPr wrap="square" lIns="0" tIns="0" rIns="0" bIns="0" rtlCol="0" anchor="t"/>
           <a:lstStyle/>
           <a:p>
-            <a:pPr indent="0" marL="0">
+            <a:pPr marL="0" indent="0">
               <a:buNone/>
             </a:pPr>
             <a:r>
@@ -7778,6 +7357,13 @@
           </a:solidFill>
           <a:ln/>
         </p:spPr>
+        <p:txBody>
+          <a:bodyPr/>
+          <a:lstStyle/>
+          <a:p>
+            <a:endParaRPr lang="cs-CZ"/>
+          </a:p>
+        </p:txBody>
       </p:sp>
       <p:sp>
         <p:nvSpPr>
@@ -7798,17 +7384,24 @@
           </a:solidFill>
           <a:ln/>
         </p:spPr>
+        <p:txBody>
+          <a:bodyPr/>
+          <a:lstStyle/>
+          <a:p>
+            <a:endParaRPr lang="cs-CZ"/>
+          </a:p>
+        </p:txBody>
       </p:sp>
       <p:pic>
         <p:nvPicPr>
-          <p:cNvPr id="20" name="Klienti chodí přes Instagram icon" descr="Klienti chodí přes Instagram">    </p:cNvPr>
+          <p:cNvPr id="20" name="Klienti chodí přes Instagram icon" descr="Klienti chodí přes Instagram"/>
           <p:cNvPicPr>
             <a:picLocks noChangeAspect="1"/>
           </p:cNvPicPr>
           <p:nvPr/>
         </p:nvPicPr>
         <p:blipFill>
-          <a:blip r:embed="rId4"/>
+          <a:blip r:embed="rId6"/>
           <a:stretch>
             <a:fillRect/>
           </a:stretch>
@@ -7844,7 +7437,7 @@
           <a:bodyPr wrap="square" lIns="0" tIns="0" rIns="0" bIns="0" rtlCol="0" anchor="b"/>
           <a:lstStyle/>
           <a:p>
-            <a:pPr indent="0" marL="0">
+            <a:pPr marL="0" indent="0">
               <a:buNone/>
             </a:pPr>
             <a:r>
@@ -7880,7 +7473,7 @@
           <a:bodyPr wrap="square" lIns="0" tIns="0" rIns="0" bIns="0" rtlCol="0" anchor="t"/>
           <a:lstStyle/>
           <a:p>
-            <a:pPr indent="0" marL="0">
+            <a:pPr marL="0" indent="0">
               <a:buNone/>
             </a:pPr>
             <a:r>
@@ -7915,7 +7508,7 @@
           </a:prstGeom>
           <a:extLst>
             <a:ext uri="{C572A759-6A51-4108-AA02-DFA0A04FC94B}">
-              <ma14:wrappingTextBoxFlag xmlns:ma14="http://schemas.microsoft.com/office/mac/drawingml/2011/main" val="0"/>
+              <ma14:wrappingTextBoxFlag xmlns:ma14="http://schemas.microsoft.com/office/mac/drawingml/2011/main" xmlns="" val="0"/>
             </a:ext>
           </a:extLst>
         </p:spPr>
@@ -7933,7 +7526,7 @@
           <a:p>
             <a:pPr algn="r"/>
             <a:fld id="{F7021451-1387-4CA6-816F-3879F97B5CBC}" type="slidenum">
-              <a:rPr b="0" lang="en-US"/>
+              <a:rPr lang="en-US" b="0"/>
               <a:t>8</a:t>
             </a:fld>
             <a:endParaRPr lang="en-US"/>
@@ -7968,9 +7561,11 @@
       <p:sp>
         <p:nvSpPr>
           <p:cNvPr id="2" name="Text 1"/>
-          <p:cNvSpPr/>
+          <p:cNvSpPr>
+            <a:spLocks noGrp="1"/>
+          </p:cNvSpPr>
           <p:nvPr>
-            <p:ph idx="101" type="title" hasCustomPrompt="1"/>
+            <p:ph type="title" idx="101" hasCustomPrompt="1"/>
           </p:nvPr>
         </p:nvSpPr>
         <p:spPr>
@@ -7988,7 +7583,7 @@
           <a:bodyPr wrap="square" lIns="0" tIns="0" rIns="0" bIns="0" rtlCol="0" anchor="ctr"/>
           <a:lstStyle/>
           <a:p>
-            <a:pPr indent="0" marL="0">
+            <a:pPr marL="0" indent="0">
               <a:buNone/>
             </a:pPr>
             <a:r>
@@ -8023,7 +7618,7 @@
           </a:prstGeom>
           <a:extLst>
             <a:ext uri="{C572A759-6A51-4108-AA02-DFA0A04FC94B}">
-              <ma14:wrappingTextBoxFlag xmlns:ma14="http://schemas.microsoft.com/office/mac/drawingml/2011/main" val="0"/>
+              <ma14:wrappingTextBoxFlag xmlns:ma14="http://schemas.microsoft.com/office/mac/drawingml/2011/main" xmlns="" val="0"/>
             </a:ext>
           </a:extLst>
         </p:spPr>
@@ -8041,7 +7636,7 @@
           <a:p>
             <a:pPr algn="r"/>
             <a:fld id="{F7021451-1387-4CA6-816F-3879F97B5CBC}" type="slidenum">
-              <a:rPr b="0" lang="en-US"/>
+              <a:rPr lang="en-US" b="0"/>
               <a:t>9</a:t>
             </a:fld>
             <a:endParaRPr lang="en-US"/>
@@ -8349,4 +7944,319 @@
     </a:ext>
   </a:extLst>
 </a:theme>
+</file>
+
+<file path=ppt/theme/theme2.xml><?xml version="1.0" encoding="utf-8"?>
+<a:theme xmlns:a="http://schemas.openxmlformats.org/drawingml/2006/main" name="Motiv Office">
+  <a:themeElements>
+    <a:clrScheme name="Office">
+      <a:dk1>
+        <a:sysClr val="windowText" lastClr="000000"/>
+      </a:dk1>
+      <a:lt1>
+        <a:sysClr val="window" lastClr="FFFFFF"/>
+      </a:lt1>
+      <a:dk2>
+        <a:srgbClr val="0E2841"/>
+      </a:dk2>
+      <a:lt2>
+        <a:srgbClr val="E8E8E8"/>
+      </a:lt2>
+      <a:accent1>
+        <a:srgbClr val="156082"/>
+      </a:accent1>
+      <a:accent2>
+        <a:srgbClr val="E97132"/>
+      </a:accent2>
+      <a:accent3>
+        <a:srgbClr val="196B24"/>
+      </a:accent3>
+      <a:accent4>
+        <a:srgbClr val="0F9ED5"/>
+      </a:accent4>
+      <a:accent5>
+        <a:srgbClr val="A02B93"/>
+      </a:accent5>
+      <a:accent6>
+        <a:srgbClr val="4EA72E"/>
+      </a:accent6>
+      <a:hlink>
+        <a:srgbClr val="467886"/>
+      </a:hlink>
+      <a:folHlink>
+        <a:srgbClr val="96607D"/>
+      </a:folHlink>
+    </a:clrScheme>
+    <a:fontScheme name="Office">
+      <a:majorFont>
+        <a:latin typeface="Aptos Display" panose="02110004020202020204"/>
+        <a:ea typeface=""/>
+        <a:cs typeface=""/>
+        <a:font script="Jpan" typeface="游ゴシック Light"/>
+        <a:font script="Hang" typeface="맑은 고딕"/>
+        <a:font script="Hans" typeface="等线 Light"/>
+        <a:font script="Hant" typeface="新細明體"/>
+        <a:font script="Arab" typeface="Times New Roman"/>
+        <a:font script="Hebr" typeface="Times New Roman"/>
+        <a:font script="Thai" typeface="Angsana New"/>
+        <a:font script="Ethi" typeface="Nyala"/>
+        <a:font script="Beng" typeface="Vrinda"/>
+        <a:font script="Gujr" typeface="Shruti"/>
+        <a:font script="Khmr" typeface="MoolBoran"/>
+        <a:font script="Knda" typeface="Tunga"/>
+        <a:font script="Guru" typeface="Raavi"/>
+        <a:font script="Cans" typeface="Euphemia"/>
+        <a:font script="Cher" typeface="Plantagenet Cherokee"/>
+        <a:font script="Yiii" typeface="Microsoft Yi Baiti"/>
+        <a:font script="Tibt" typeface="Microsoft Himalaya"/>
+        <a:font script="Thaa" typeface="MV Boli"/>
+        <a:font script="Deva" typeface="Mangal"/>
+        <a:font script="Telu" typeface="Gautami"/>
+        <a:font script="Taml" typeface="Latha"/>
+        <a:font script="Syrc" typeface="Estrangelo Edessa"/>
+        <a:font script="Orya" typeface="Kalinga"/>
+        <a:font script="Mlym" typeface="Kartika"/>
+        <a:font script="Laoo" typeface="DokChampa"/>
+        <a:font script="Sinh" typeface="Iskoola Pota"/>
+        <a:font script="Mong" typeface="Mongolian Baiti"/>
+        <a:font script="Viet" typeface="Times New Roman"/>
+        <a:font script="Uigh" typeface="Microsoft Uighur"/>
+        <a:font script="Geor" typeface="Sylfaen"/>
+        <a:font script="Armn" typeface="Arial"/>
+        <a:font script="Bugi" typeface="Leelawadee UI"/>
+        <a:font script="Bopo" typeface="Microsoft JhengHei"/>
+        <a:font script="Java" typeface="Javanese Text"/>
+        <a:font script="Lisu" typeface="Segoe UI"/>
+        <a:font script="Mymr" typeface="Myanmar Text"/>
+        <a:font script="Nkoo" typeface="Ebrima"/>
+        <a:font script="Olck" typeface="Nirmala UI"/>
+        <a:font script="Osma" typeface="Ebrima"/>
+        <a:font script="Phag" typeface="Phagspa"/>
+        <a:font script="Syrn" typeface="Estrangelo Edessa"/>
+        <a:font script="Syrj" typeface="Estrangelo Edessa"/>
+        <a:font script="Syre" typeface="Estrangelo Edessa"/>
+        <a:font script="Sora" typeface="Nirmala UI"/>
+        <a:font script="Tale" typeface="Microsoft Tai Le"/>
+        <a:font script="Talu" typeface="Microsoft New Tai Lue"/>
+        <a:font script="Tfng" typeface="Ebrima"/>
+      </a:majorFont>
+      <a:minorFont>
+        <a:latin typeface="Aptos" panose="02110004020202020204"/>
+        <a:ea typeface=""/>
+        <a:cs typeface=""/>
+        <a:font script="Jpan" typeface="游ゴシック"/>
+        <a:font script="Hang" typeface="맑은 고딕"/>
+        <a:font script="Hans" typeface="等线"/>
+        <a:font script="Hant" typeface="新細明體"/>
+        <a:font script="Arab" typeface="Arial"/>
+        <a:font script="Hebr" typeface="Arial"/>
+        <a:font script="Thai" typeface="Cordia New"/>
+        <a:font script="Ethi" typeface="Nyala"/>
+        <a:font script="Beng" typeface="Vrinda"/>
+        <a:font script="Gujr" typeface="Shruti"/>
+        <a:font script="Khmr" typeface="DaunPenh"/>
+        <a:font script="Knda" typeface="Tunga"/>
+        <a:font script="Guru" typeface="Raavi"/>
+        <a:font script="Cans" typeface="Euphemia"/>
+        <a:font script="Cher" typeface="Plantagenet Cherokee"/>
+        <a:font script="Yiii" typeface="Microsoft Yi Baiti"/>
+        <a:font script="Tibt" typeface="Microsoft Himalaya"/>
+        <a:font script="Thaa" typeface="MV Boli"/>
+        <a:font script="Deva" typeface="Mangal"/>
+        <a:font script="Telu" typeface="Gautami"/>
+        <a:font script="Taml" typeface="Latha"/>
+        <a:font script="Syrc" typeface="Estrangelo Edessa"/>
+        <a:font script="Orya" typeface="Kalinga"/>
+        <a:font script="Mlym" typeface="Kartika"/>
+        <a:font script="Laoo" typeface="DokChampa"/>
+        <a:font script="Sinh" typeface="Iskoola Pota"/>
+        <a:font script="Mong" typeface="Mongolian Baiti"/>
+        <a:font script="Viet" typeface="Arial"/>
+        <a:font script="Uigh" typeface="Microsoft Uighur"/>
+        <a:font script="Geor" typeface="Sylfaen"/>
+        <a:font script="Armn" typeface="Arial"/>
+        <a:font script="Bugi" typeface="Leelawadee UI"/>
+        <a:font script="Bopo" typeface="Microsoft JhengHei"/>
+        <a:font script="Java" typeface="Javanese Text"/>
+        <a:font script="Lisu" typeface="Segoe UI"/>
+        <a:font script="Mymr" typeface="Myanmar Text"/>
+        <a:font script="Nkoo" typeface="Ebrima"/>
+        <a:font script="Olck" typeface="Nirmala UI"/>
+        <a:font script="Osma" typeface="Ebrima"/>
+        <a:font script="Phag" typeface="Phagspa"/>
+        <a:font script="Syrn" typeface="Estrangelo Edessa"/>
+        <a:font script="Syrj" typeface="Estrangelo Edessa"/>
+        <a:font script="Syre" typeface="Estrangelo Edessa"/>
+        <a:font script="Sora" typeface="Nirmala UI"/>
+        <a:font script="Tale" typeface="Microsoft Tai Le"/>
+        <a:font script="Talu" typeface="Microsoft New Tai Lue"/>
+        <a:font script="Tfng" typeface="Ebrima"/>
+      </a:minorFont>
+    </a:fontScheme>
+    <a:fmtScheme name="Office">
+      <a:fillStyleLst>
+        <a:solidFill>
+          <a:schemeClr val="phClr"/>
+        </a:solidFill>
+        <a:gradFill rotWithShape="1">
+          <a:gsLst>
+            <a:gs pos="0">
+              <a:schemeClr val="phClr">
+                <a:lumMod val="110000"/>
+                <a:satMod val="105000"/>
+                <a:tint val="67000"/>
+              </a:schemeClr>
+            </a:gs>
+            <a:gs pos="50000">
+              <a:schemeClr val="phClr">
+                <a:lumMod val="105000"/>
+                <a:satMod val="103000"/>
+                <a:tint val="73000"/>
+              </a:schemeClr>
+            </a:gs>
+            <a:gs pos="100000">
+              <a:schemeClr val="phClr">
+                <a:lumMod val="105000"/>
+                <a:satMod val="109000"/>
+                <a:tint val="81000"/>
+              </a:schemeClr>
+            </a:gs>
+          </a:gsLst>
+          <a:lin ang="5400000" scaled="0"/>
+        </a:gradFill>
+        <a:gradFill rotWithShape="1">
+          <a:gsLst>
+            <a:gs pos="0">
+              <a:schemeClr val="phClr">
+                <a:satMod val="103000"/>
+                <a:lumMod val="102000"/>
+                <a:tint val="94000"/>
+              </a:schemeClr>
+            </a:gs>
+            <a:gs pos="50000">
+              <a:schemeClr val="phClr">
+                <a:satMod val="110000"/>
+                <a:lumMod val="100000"/>
+                <a:shade val="100000"/>
+              </a:schemeClr>
+            </a:gs>
+            <a:gs pos="100000">
+              <a:schemeClr val="phClr">
+                <a:lumMod val="99000"/>
+                <a:satMod val="120000"/>
+                <a:shade val="78000"/>
+              </a:schemeClr>
+            </a:gs>
+          </a:gsLst>
+          <a:lin ang="5400000" scaled="0"/>
+        </a:gradFill>
+      </a:fillStyleLst>
+      <a:lnStyleLst>
+        <a:ln w="12700" cap="flat" cmpd="sng" algn="ctr">
+          <a:solidFill>
+            <a:schemeClr val="phClr"/>
+          </a:solidFill>
+          <a:prstDash val="solid"/>
+          <a:miter lim="800000"/>
+        </a:ln>
+        <a:ln w="19050" cap="flat" cmpd="sng" algn="ctr">
+          <a:solidFill>
+            <a:schemeClr val="phClr"/>
+          </a:solidFill>
+          <a:prstDash val="solid"/>
+          <a:miter lim="800000"/>
+        </a:ln>
+        <a:ln w="25400" cap="flat" cmpd="sng" algn="ctr">
+          <a:solidFill>
+            <a:schemeClr val="phClr"/>
+          </a:solidFill>
+          <a:prstDash val="solid"/>
+          <a:miter lim="800000"/>
+        </a:ln>
+      </a:lnStyleLst>
+      <a:effectStyleLst>
+        <a:effectStyle>
+          <a:effectLst/>
+        </a:effectStyle>
+        <a:effectStyle>
+          <a:effectLst/>
+        </a:effectStyle>
+        <a:effectStyle>
+          <a:effectLst>
+            <a:outerShdw blurRad="57150" dist="19050" dir="5400000" algn="ctr" rotWithShape="0">
+              <a:srgbClr val="000000">
+                <a:alpha val="63000"/>
+              </a:srgbClr>
+            </a:outerShdw>
+          </a:effectLst>
+        </a:effectStyle>
+      </a:effectStyleLst>
+      <a:bgFillStyleLst>
+        <a:solidFill>
+          <a:schemeClr val="phClr"/>
+        </a:solidFill>
+        <a:solidFill>
+          <a:schemeClr val="phClr">
+            <a:tint val="95000"/>
+            <a:satMod val="170000"/>
+          </a:schemeClr>
+        </a:solidFill>
+        <a:gradFill rotWithShape="1">
+          <a:gsLst>
+            <a:gs pos="0">
+              <a:schemeClr val="phClr">
+                <a:tint val="93000"/>
+                <a:satMod val="150000"/>
+                <a:shade val="98000"/>
+                <a:lumMod val="102000"/>
+              </a:schemeClr>
+            </a:gs>
+            <a:gs pos="50000">
+              <a:schemeClr val="phClr">
+                <a:tint val="98000"/>
+                <a:satMod val="130000"/>
+                <a:shade val="90000"/>
+                <a:lumMod val="103000"/>
+              </a:schemeClr>
+            </a:gs>
+            <a:gs pos="100000">
+              <a:schemeClr val="phClr">
+                <a:shade val="63000"/>
+                <a:satMod val="120000"/>
+              </a:schemeClr>
+            </a:gs>
+          </a:gsLst>
+          <a:lin ang="5400000" scaled="0"/>
+        </a:gradFill>
+      </a:bgFillStyleLst>
+    </a:fmtScheme>
+  </a:themeElements>
+  <a:objectDefaults>
+    <a:lnDef>
+      <a:spPr/>
+      <a:bodyPr/>
+      <a:lstStyle/>
+      <a:style>
+        <a:lnRef idx="2">
+          <a:schemeClr val="accent1"/>
+        </a:lnRef>
+        <a:fillRef idx="0">
+          <a:schemeClr val="accent1"/>
+        </a:fillRef>
+        <a:effectRef idx="1">
+          <a:schemeClr val="accent1"/>
+        </a:effectRef>
+        <a:fontRef idx="minor">
+          <a:schemeClr val="tx1"/>
+        </a:fontRef>
+      </a:style>
+    </a:lnDef>
+  </a:objectDefaults>
+  <a:extraClrSchemeLst/>
+  <a:extLst>
+    <a:ext uri="{05A4C25C-085E-4340-85A3-A5531E510DB2}">
+      <thm15:themeFamily xmlns:thm15="http://schemas.microsoft.com/office/thememl/2012/main" name="Office Theme" id="{2E142A2C-CD16-42D6-873A-C26D2A0506FA}" vid="{1BDDFF52-6CD6-40A5-AB3C-68EB2F1E4D0A}"/>
+    </a:ext>
+  </a:extLst>
+</a:theme>
 </file>
</xml_diff>

<commit_message>
Upravena prezentace o pdf verze Lean canvasu
</commit_message>
<xml_diff>
--- a/Docs/TrainLoop_prezentace.pptx
+++ b/Docs/TrainLoop_prezentace.pptx
@@ -5,24 +5,25 @@
     <p:sldMasterId id="2147483648" r:id="rId1"/>
   </p:sldMasterIdLst>
   <p:notesMasterIdLst>
-    <p:notesMasterId r:id="rId17"/>
+    <p:notesMasterId r:id="rId18"/>
   </p:notesMasterIdLst>
   <p:sldIdLst>
     <p:sldId id="256" r:id="rId2"/>
     <p:sldId id="257" r:id="rId3"/>
     <p:sldId id="258" r:id="rId4"/>
     <p:sldId id="269" r:id="rId5"/>
-    <p:sldId id="266" r:id="rId6"/>
-    <p:sldId id="267" r:id="rId7"/>
-    <p:sldId id="271" r:id="rId8"/>
-    <p:sldId id="270" r:id="rId9"/>
-    <p:sldId id="268" r:id="rId10"/>
-    <p:sldId id="259" r:id="rId11"/>
-    <p:sldId id="261" r:id="rId12"/>
-    <p:sldId id="262" r:id="rId13"/>
-    <p:sldId id="263" r:id="rId14"/>
-    <p:sldId id="264" r:id="rId15"/>
-    <p:sldId id="265" r:id="rId16"/>
+    <p:sldId id="272" r:id="rId6"/>
+    <p:sldId id="266" r:id="rId7"/>
+    <p:sldId id="267" r:id="rId8"/>
+    <p:sldId id="271" r:id="rId9"/>
+    <p:sldId id="270" r:id="rId10"/>
+    <p:sldId id="268" r:id="rId11"/>
+    <p:sldId id="259" r:id="rId12"/>
+    <p:sldId id="261" r:id="rId13"/>
+    <p:sldId id="262" r:id="rId14"/>
+    <p:sldId id="263" r:id="rId15"/>
+    <p:sldId id="264" r:id="rId16"/>
+    <p:sldId id="265" r:id="rId17"/>
   </p:sldIdLst>
   <p:sldSz cx="9144000" cy="5143500" type="screen16x9"/>
   <p:notesSz cx="5143500" cy="9144000"/>
@@ -131,6 +132,7 @@
           <p14:sldIdLst>
             <p14:sldId id="258"/>
             <p14:sldId id="269"/>
+            <p14:sldId id="272"/>
             <p14:sldId id="266"/>
             <p14:sldId id="267"/>
             <p14:sldId id="271"/>
@@ -611,7 +613,7 @@
           <a:p>
             <a:fld id="{F7021451-1387-4CA6-816F-3879F97B5CBC}" type="slidenum">
               <a:rPr lang="en-US"/>
-              <a:t>10</a:t>
+              <a:t>11</a:t>
             </a:fld>
             <a:endParaRPr lang="en-US"/>
           </a:p>
@@ -695,7 +697,7 @@
           <a:p>
             <a:fld id="{F7021451-1387-4CA6-816F-3879F97B5CBC}" type="slidenum">
               <a:rPr lang="en-US"/>
-              <a:t>11</a:t>
+              <a:t>12</a:t>
             </a:fld>
             <a:endParaRPr lang="en-US"/>
           </a:p>
@@ -779,7 +781,7 @@
           <a:p>
             <a:fld id="{F7021451-1387-4CA6-816F-3879F97B5CBC}" type="slidenum">
               <a:rPr lang="en-US"/>
-              <a:t>12</a:t>
+              <a:t>13</a:t>
             </a:fld>
             <a:endParaRPr lang="en-US"/>
           </a:p>
@@ -863,7 +865,7 @@
           <a:p>
             <a:fld id="{F7021451-1387-4CA6-816F-3879F97B5CBC}" type="slidenum">
               <a:rPr lang="en-US"/>
-              <a:t>13</a:t>
+              <a:t>14</a:t>
             </a:fld>
             <a:endParaRPr lang="en-US"/>
           </a:p>
@@ -947,7 +949,7 @@
           <a:p>
             <a:fld id="{F7021451-1387-4CA6-816F-3879F97B5CBC}" type="slidenum">
               <a:rPr lang="en-US"/>
-              <a:t>14</a:t>
+              <a:t>15</a:t>
             </a:fld>
             <a:endParaRPr lang="en-US"/>
           </a:p>
@@ -1031,7 +1033,7 @@
           <a:p>
             <a:fld id="{F7021451-1387-4CA6-816F-3879F97B5CBC}" type="slidenum">
               <a:rPr lang="en-US"/>
-              <a:t>15</a:t>
+              <a:t>16</a:t>
             </a:fld>
             <a:endParaRPr lang="en-US"/>
           </a:p>
@@ -1317,7 +1319,7 @@
           </a:prstGeom>
           <a:extLst>
             <a:ext uri="{C572A759-6A51-4108-AA02-DFA0A04FC94B}">
-              <ma14:wrappingTextBoxFlag xmlns="" xmlns:ma14="http://schemas.microsoft.com/office/mac/drawingml/2011/main" val="0"/>
+              <ma14:wrappingTextBoxFlag xmlns:ma14="http://schemas.microsoft.com/office/mac/drawingml/2011/main" xmlns="" val="0"/>
             </a:ext>
           </a:extLst>
         </p:spPr>
@@ -1521,7 +1523,7 @@
           </a:prstGeom>
           <a:extLst>
             <a:ext uri="{C572A759-6A51-4108-AA02-DFA0A04FC94B}">
-              <ma14:wrappingTextBoxFlag xmlns="" xmlns:ma14="http://schemas.microsoft.com/office/mac/drawingml/2011/main" val="0"/>
+              <ma14:wrappingTextBoxFlag xmlns:ma14="http://schemas.microsoft.com/office/mac/drawingml/2011/main" xmlns="" val="0"/>
             </a:ext>
           </a:extLst>
         </p:spPr>
@@ -1596,7 +1598,7 @@
           </a:prstGeom>
           <a:extLst>
             <a:ext uri="{C572A759-6A51-4108-AA02-DFA0A04FC94B}">
-              <ma14:wrappingTextBoxFlag xmlns="" xmlns:ma14="http://schemas.microsoft.com/office/mac/drawingml/2011/main" val="0"/>
+              <ma14:wrappingTextBoxFlag xmlns:ma14="http://schemas.microsoft.com/office/mac/drawingml/2011/main" xmlns="" val="0"/>
             </a:ext>
           </a:extLst>
         </p:spPr>
@@ -1991,6 +1993,148 @@
 
 <file path=ppt/slides/slide10.xml><?xml version="1.0" encoding="utf-8"?>
 <p:sld xmlns:a="http://schemas.openxmlformats.org/drawingml/2006/main" xmlns:r="http://schemas.openxmlformats.org/officeDocument/2006/relationships" xmlns:p="http://schemas.openxmlformats.org/presentationml/2006/main">
+  <p:cSld>
+    <p:spTree>
+      <p:nvGrpSpPr>
+        <p:cNvPr id="1" name=""/>
+        <p:cNvGrpSpPr/>
+        <p:nvPr/>
+      </p:nvGrpSpPr>
+      <p:grpSpPr>
+        <a:xfrm>
+          <a:off x="0" y="0"/>
+          <a:ext cx="0" cy="0"/>
+          <a:chOff x="0" y="0"/>
+          <a:chExt cx="0" cy="0"/>
+        </a:xfrm>
+      </p:grpSpPr>
+      <p:sp>
+        <p:nvSpPr>
+          <p:cNvPr id="2" name="Nadpis 1">
+            <a:extLst>
+              <a:ext uri="{FF2B5EF4-FFF2-40B4-BE49-F238E27FC236}">
+                <a16:creationId xmlns:a16="http://schemas.microsoft.com/office/drawing/2014/main" id="{80BA6760-047F-1FB7-BB44-F8164DD7679C}"/>
+              </a:ext>
+            </a:extLst>
+          </p:cNvPr>
+          <p:cNvSpPr>
+            <a:spLocks noGrp="1"/>
+          </p:cNvSpPr>
+          <p:nvPr>
+            <p:ph type="title" idx="101"/>
+          </p:nvPr>
+        </p:nvSpPr>
+        <p:spPr/>
+        <p:txBody>
+          <a:bodyPr/>
+          <a:lstStyle/>
+          <a:p>
+            <a:r>
+              <a:rPr lang="cs-CZ" dirty="0"/>
+              <a:t>Náklady celkem</a:t>
+            </a:r>
+          </a:p>
+        </p:txBody>
+      </p:sp>
+      <p:sp>
+        <p:nvSpPr>
+          <p:cNvPr id="3" name="Zástupný obsah 2">
+            <a:extLst>
+              <a:ext uri="{FF2B5EF4-FFF2-40B4-BE49-F238E27FC236}">
+                <a16:creationId xmlns:a16="http://schemas.microsoft.com/office/drawing/2014/main" id="{8033CCD9-B606-29AF-BDA1-77E2FB18590C}"/>
+              </a:ext>
+            </a:extLst>
+          </p:cNvPr>
+          <p:cNvSpPr>
+            <a:spLocks noGrp="1"/>
+          </p:cNvSpPr>
+          <p:nvPr>
+            <p:ph idx="102"/>
+          </p:nvPr>
+        </p:nvSpPr>
+        <p:spPr/>
+        <p:txBody>
+          <a:bodyPr/>
+          <a:lstStyle/>
+          <a:p>
+            <a:r>
+              <a:rPr lang="cs-CZ" sz="2400" dirty="0"/>
+              <a:t>MVP – 1 189 616 Kč</a:t>
+            </a:r>
+          </a:p>
+          <a:p>
+            <a:r>
+              <a:rPr lang="cs-CZ" sz="2400" dirty="0"/>
+              <a:t>PREMIUM – 347 083 Kč</a:t>
+            </a:r>
+          </a:p>
+          <a:p>
+            <a:endParaRPr lang="cs-CZ" sz="2400" dirty="0"/>
+          </a:p>
+          <a:p>
+            <a:r>
+              <a:rPr lang="cs-CZ" sz="2400" dirty="0"/>
+              <a:t>Provozní náklady CCA 20 892 Kč/</a:t>
+            </a:r>
+            <a:r>
+              <a:rPr lang="cs-CZ" sz="2400" dirty="0" err="1"/>
+              <a:t>měs</a:t>
+            </a:r>
+            <a:endParaRPr lang="cs-CZ" sz="2400" dirty="0"/>
+          </a:p>
+          <a:p>
+            <a:pPr marL="342900" indent="-342900">
+              <a:buFont typeface="Arial" panose="020B0604020202020204" pitchFamily="34" charset="0"/>
+              <a:buChar char="•"/>
+            </a:pPr>
+            <a:r>
+              <a:rPr lang="cs-CZ" sz="2400" dirty="0"/>
+              <a:t>Pro 5250 aktivních uživatelů</a:t>
+            </a:r>
+          </a:p>
+          <a:p>
+            <a:r>
+              <a:rPr lang="cs-CZ" sz="2400" dirty="0"/>
+              <a:t>Výnosy pro 5000 uživatelů tvoří 15 120 Kč/</a:t>
+            </a:r>
+            <a:r>
+              <a:rPr lang="cs-CZ" sz="2400" dirty="0" err="1"/>
+              <a:t>měs</a:t>
+            </a:r>
+            <a:endParaRPr lang="cs-CZ" sz="2400" dirty="0"/>
+          </a:p>
+          <a:p>
+            <a:pPr marL="342900" indent="-342900">
+              <a:buFont typeface="Arial" panose="020B0604020202020204" pitchFamily="34" charset="0"/>
+              <a:buChar char="•"/>
+            </a:pPr>
+            <a:r>
+              <a:rPr lang="cs-CZ" sz="2400" dirty="0"/>
+              <a:t>Od 10 000 aktivních uživatelů 32 470 Kč/</a:t>
+            </a:r>
+            <a:r>
+              <a:rPr lang="cs-CZ" sz="2400" dirty="0" err="1"/>
+              <a:t>měs</a:t>
+            </a:r>
+            <a:endParaRPr lang="cs-CZ" sz="2400" dirty="0"/>
+          </a:p>
+        </p:txBody>
+      </p:sp>
+    </p:spTree>
+    <p:extLst>
+      <p:ext uri="{BB962C8B-B14F-4D97-AF65-F5344CB8AC3E}">
+        <p14:creationId xmlns:p14="http://schemas.microsoft.com/office/powerpoint/2010/main" val="3316525007"/>
+      </p:ext>
+    </p:extLst>
+  </p:cSld>
+  <p:clrMapOvr>
+    <a:masterClrMapping/>
+  </p:clrMapOvr>
+</p:sld>
+</file>
+
+<file path=ppt/slides/slide11.xml><?xml version="1.0" encoding="utf-8"?>
+<p:sld xmlns:a="http://schemas.openxmlformats.org/drawingml/2006/main" xmlns:r="http://schemas.openxmlformats.org/officeDocument/2006/relationships" xmlns:p="http://schemas.openxmlformats.org/presentationml/2006/main">
   <p:cSld name="Slide 4">
     <p:spTree>
       <p:nvGrpSpPr>
@@ -2066,7 +2210,7 @@
           </a:prstGeom>
           <a:extLst>
             <a:ext uri="{C572A759-6A51-4108-AA02-DFA0A04FC94B}">
-              <ma14:wrappingTextBoxFlag xmlns="" xmlns:ma14="http://schemas.microsoft.com/office/mac/drawingml/2011/main" val="0"/>
+              <ma14:wrappingTextBoxFlag xmlns:ma14="http://schemas.microsoft.com/office/mac/drawingml/2011/main" xmlns="" val="0"/>
             </a:ext>
           </a:extLst>
         </p:spPr>
@@ -2085,7 +2229,7 @@
             <a:pPr algn="r"/>
             <a:fld id="{F7021451-1387-4CA6-816F-3879F97B5CBC}" type="slidenum">
               <a:rPr lang="en-US" b="0"/>
-              <a:t>10</a:t>
+              <a:t>11</a:t>
             </a:fld>
             <a:endParaRPr lang="en-US"/>
           </a:p>
@@ -2129,7 +2273,7 @@
 </p:sld>
 </file>
 
-<file path=ppt/slides/slide11.xml><?xml version="1.0" encoding="utf-8"?>
+<file path=ppt/slides/slide12.xml><?xml version="1.0" encoding="utf-8"?>
 <p:sld xmlns:a="http://schemas.openxmlformats.org/drawingml/2006/main" xmlns:r="http://schemas.openxmlformats.org/officeDocument/2006/relationships" xmlns:p="http://schemas.openxmlformats.org/presentationml/2006/main">
   <p:cSld name="Slide 6">
     <p:spTree>
@@ -3487,7 +3631,7 @@
           </a:prstGeom>
           <a:extLst>
             <a:ext uri="{C572A759-6A51-4108-AA02-DFA0A04FC94B}">
-              <ma14:wrappingTextBoxFlag xmlns="" xmlns:ma14="http://schemas.microsoft.com/office/mac/drawingml/2011/main" val="0"/>
+              <ma14:wrappingTextBoxFlag xmlns:ma14="http://schemas.microsoft.com/office/mac/drawingml/2011/main" xmlns="" val="0"/>
             </a:ext>
           </a:extLst>
         </p:spPr>
@@ -3506,7 +3650,7 @@
             <a:pPr algn="r"/>
             <a:fld id="{F7021451-1387-4CA6-816F-3879F97B5CBC}" type="slidenum">
               <a:rPr lang="en-US" b="0"/>
-              <a:t>11</a:t>
+              <a:t>12</a:t>
             </a:fld>
             <a:endParaRPr lang="en-US"/>
           </a:p>
@@ -3520,7 +3664,7 @@
 </p:sld>
 </file>
 
-<file path=ppt/slides/slide12.xml><?xml version="1.0" encoding="utf-8"?>
+<file path=ppt/slides/slide13.xml><?xml version="1.0" encoding="utf-8"?>
 <p:sld xmlns:a="http://schemas.openxmlformats.org/drawingml/2006/main" xmlns:r="http://schemas.openxmlformats.org/officeDocument/2006/relationships" xmlns:p="http://schemas.openxmlformats.org/presentationml/2006/main">
   <p:cSld name="Slide 7">
     <p:spTree>
@@ -5032,7 +5176,7 @@
           </a:prstGeom>
           <a:extLst>
             <a:ext uri="{C572A759-6A51-4108-AA02-DFA0A04FC94B}">
-              <ma14:wrappingTextBoxFlag xmlns="" xmlns:ma14="http://schemas.microsoft.com/office/mac/drawingml/2011/main" val="0"/>
+              <ma14:wrappingTextBoxFlag xmlns:ma14="http://schemas.microsoft.com/office/mac/drawingml/2011/main" xmlns="" val="0"/>
             </a:ext>
           </a:extLst>
         </p:spPr>
@@ -5051,7 +5195,7 @@
             <a:pPr algn="r"/>
             <a:fld id="{F7021451-1387-4CA6-816F-3879F97B5CBC}" type="slidenum">
               <a:rPr lang="en-US" b="0"/>
-              <a:t>12</a:t>
+              <a:t>13</a:t>
             </a:fld>
             <a:endParaRPr lang="en-US"/>
           </a:p>
@@ -5065,7 +5209,7 @@
 </p:sld>
 </file>
 
-<file path=ppt/slides/slide13.xml><?xml version="1.0" encoding="utf-8"?>
+<file path=ppt/slides/slide14.xml><?xml version="1.0" encoding="utf-8"?>
 <p:sld xmlns:a="http://schemas.openxmlformats.org/drawingml/2006/main" xmlns:r="http://schemas.openxmlformats.org/officeDocument/2006/relationships" xmlns:p="http://schemas.openxmlformats.org/presentationml/2006/main">
   <p:cSld name="Slide 8">
     <p:spTree>
@@ -5750,7 +5894,7 @@
           </a:prstGeom>
           <a:extLst>
             <a:ext uri="{C572A759-6A51-4108-AA02-DFA0A04FC94B}">
-              <ma14:wrappingTextBoxFlag xmlns="" xmlns:ma14="http://schemas.microsoft.com/office/mac/drawingml/2011/main" val="0"/>
+              <ma14:wrappingTextBoxFlag xmlns:ma14="http://schemas.microsoft.com/office/mac/drawingml/2011/main" xmlns="" val="0"/>
             </a:ext>
           </a:extLst>
         </p:spPr>
@@ -5769,7 +5913,7 @@
             <a:pPr algn="r"/>
             <a:fld id="{F7021451-1387-4CA6-816F-3879F97B5CBC}" type="slidenum">
               <a:rPr lang="en-US" b="0"/>
-              <a:t>13</a:t>
+              <a:t>14</a:t>
             </a:fld>
             <a:endParaRPr lang="en-US"/>
           </a:p>
@@ -5783,7 +5927,7 @@
 </p:sld>
 </file>
 
-<file path=ppt/slides/slide14.xml><?xml version="1.0" encoding="utf-8"?>
+<file path=ppt/slides/slide15.xml><?xml version="1.0" encoding="utf-8"?>
 <p:sld xmlns:a="http://schemas.openxmlformats.org/drawingml/2006/main" xmlns:r="http://schemas.openxmlformats.org/officeDocument/2006/relationships" xmlns:p="http://schemas.openxmlformats.org/presentationml/2006/main">
   <p:cSld name="Slide 9">
     <p:spTree>
@@ -5860,7 +6004,7 @@
           </a:prstGeom>
           <a:extLst>
             <a:ext uri="{C572A759-6A51-4108-AA02-DFA0A04FC94B}">
-              <ma14:wrappingTextBoxFlag xmlns="" xmlns:ma14="http://schemas.microsoft.com/office/mac/drawingml/2011/main" val="0"/>
+              <ma14:wrappingTextBoxFlag xmlns:ma14="http://schemas.microsoft.com/office/mac/drawingml/2011/main" xmlns="" val="0"/>
             </a:ext>
           </a:extLst>
         </p:spPr>
@@ -5879,7 +6023,7 @@
             <a:pPr algn="r"/>
             <a:fld id="{F7021451-1387-4CA6-816F-3879F97B5CBC}" type="slidenum">
               <a:rPr lang="en-US" b="0"/>
-              <a:t>14</a:t>
+              <a:t>15</a:t>
             </a:fld>
             <a:endParaRPr lang="en-US"/>
           </a:p>
@@ -5893,7 +6037,7 @@
 </p:sld>
 </file>
 
-<file path=ppt/slides/slide15.xml><?xml version="1.0" encoding="utf-8"?>
+<file path=ppt/slides/slide16.xml><?xml version="1.0" encoding="utf-8"?>
 <p:sld xmlns:a="http://schemas.openxmlformats.org/drawingml/2006/main" xmlns:r="http://schemas.openxmlformats.org/officeDocument/2006/relationships" xmlns:p="http://schemas.openxmlformats.org/presentationml/2006/main">
   <p:cSld name="Slide 10">
     <p:spTree>
@@ -5998,7 +6142,7 @@
           </a:prstGeom>
           <a:extLst>
             <a:ext uri="{C572A759-6A51-4108-AA02-DFA0A04FC94B}">
-              <ma14:wrappingTextBoxFlag xmlns="" xmlns:ma14="http://schemas.microsoft.com/office/mac/drawingml/2011/main" val="0"/>
+              <ma14:wrappingTextBoxFlag xmlns:ma14="http://schemas.microsoft.com/office/mac/drawingml/2011/main" xmlns="" val="0"/>
             </a:ext>
           </a:extLst>
         </p:spPr>
@@ -6017,7 +6161,7 @@
             <a:pPr algn="r"/>
             <a:fld id="{F7021451-1387-4CA6-816F-3879F97B5CBC}" type="slidenum">
               <a:rPr lang="en-US" b="0"/>
-              <a:t>15</a:t>
+              <a:t>16</a:t>
             </a:fld>
             <a:endParaRPr lang="en-US"/>
           </a:p>
@@ -6714,7 +6858,7 @@
           </a:prstGeom>
           <a:extLst>
             <a:ext uri="{C572A759-6A51-4108-AA02-DFA0A04FC94B}">
-              <ma14:wrappingTextBoxFlag xmlns="" xmlns:ma14="http://schemas.microsoft.com/office/mac/drawingml/2011/main" val="0"/>
+              <ma14:wrappingTextBoxFlag xmlns:ma14="http://schemas.microsoft.com/office/mac/drawingml/2011/main" xmlns="" val="0"/>
             </a:ext>
           </a:extLst>
         </p:spPr>
@@ -6766,86 +6910,6 @@
       </p:grpSpPr>
       <p:sp>
         <p:nvSpPr>
-          <p:cNvPr id="2" name="Text 1"/>
-          <p:cNvSpPr>
-            <a:spLocks noGrp="1"/>
-          </p:cNvSpPr>
-          <p:nvPr>
-            <p:ph type="title" idx="101" hasCustomPrompt="1"/>
-          </p:nvPr>
-        </p:nvSpPr>
-        <p:spPr>
-          <a:xfrm>
-            <a:off x="548640" y="365760"/>
-            <a:ext cx="8046720" cy="640080"/>
-          </a:xfrm>
-          <a:prstGeom prst="rect">
-            <a:avLst/>
-          </a:prstGeom>
-          <a:noFill/>
-          <a:ln/>
-        </p:spPr>
-        <p:txBody>
-          <a:bodyPr wrap="square" lIns="0" tIns="0" rIns="0" bIns="0" rtlCol="0" anchor="ctr"/>
-          <a:lstStyle/>
-          <a:p>
-            <a:pPr marL="0" indent="0">
-              <a:buNone/>
-            </a:pPr>
-            <a:r>
-              <a:rPr lang="en-US" sz="3200" b="1" dirty="0">
-                <a:solidFill>
-                  <a:schemeClr val="tx1"/>
-                </a:solidFill>
-              </a:rPr>
-              <a:t>Lean Canvas</a:t>
-            </a:r>
-            <a:r>
-              <a:rPr lang="cs-CZ" sz="3200" b="1" dirty="0">
-                <a:solidFill>
-                  <a:schemeClr val="tx1"/>
-                </a:solidFill>
-              </a:rPr>
-              <a:t> MPV</a:t>
-            </a:r>
-            <a:endParaRPr lang="en-US" sz="3200" dirty="0"/>
-          </a:p>
-        </p:txBody>
-      </p:sp>
-      <p:sp>
-        <p:nvSpPr>
-          <p:cNvPr id="3" name="Text 1"/>
-          <p:cNvSpPr>
-            <a:spLocks noGrp="1"/>
-          </p:cNvSpPr>
-          <p:nvPr>
-            <p:ph idx="102" hasCustomPrompt="1"/>
-          </p:nvPr>
-        </p:nvSpPr>
-        <p:spPr>
-          <a:xfrm>
-            <a:off x="548640" y="1188720"/>
-            <a:ext cx="8046720" cy="3291840"/>
-          </a:xfrm>
-          <a:prstGeom prst="rect">
-            <a:avLst/>
-          </a:prstGeom>
-          <a:noFill/>
-          <a:ln/>
-        </p:spPr>
-        <p:txBody>
-          <a:bodyPr wrap="square" rtlCol="0"/>
-          <a:lstStyle/>
-          <a:p>
-            <a:pPr marL="0" indent="0">
-              <a:buNone/>
-            </a:pPr>
-            <a:endParaRPr lang="en-US" sz="1400" dirty="0"/>
-          </a:p>
-        </p:txBody>
-      </p:sp>
-      <p:sp>
-        <p:nvSpPr>
           <p:cNvPr id="25" name="Slide Number Placeholder 0"/>
           <p:cNvSpPr>
             <a:spLocks noGrp="1"/>
@@ -6864,7 +6928,7 @@
           </a:prstGeom>
           <a:extLst>
             <a:ext uri="{C572A759-6A51-4108-AA02-DFA0A04FC94B}">
-              <ma14:wrappingTextBoxFlag xmlns="" xmlns:ma14="http://schemas.microsoft.com/office/mac/drawingml/2011/main" val="0"/>
+              <ma14:wrappingTextBoxFlag xmlns:ma14="http://schemas.microsoft.com/office/mac/drawingml/2011/main" xmlns="" val="0"/>
             </a:ext>
           </a:extLst>
         </p:spPr>
@@ -6889,6 +6953,36 @@
           </a:p>
         </p:txBody>
       </p:sp>
+      <p:pic>
+        <p:nvPicPr>
+          <p:cNvPr id="5" name="Obrázek 4">
+            <a:extLst>
+              <a:ext uri="{FF2B5EF4-FFF2-40B4-BE49-F238E27FC236}">
+                <a16:creationId xmlns:a16="http://schemas.microsoft.com/office/drawing/2014/main" id="{430E3DDA-79C1-4487-DC8C-7E98F7391E27}"/>
+              </a:ext>
+            </a:extLst>
+          </p:cNvPr>
+          <p:cNvPicPr>
+            <a:picLocks noChangeAspect="1"/>
+          </p:cNvPicPr>
+          <p:nvPr/>
+        </p:nvPicPr>
+        <p:blipFill>
+          <a:blip r:embed="rId3"/>
+          <a:stretch>
+            <a:fillRect/>
+          </a:stretch>
+        </p:blipFill>
+        <p:spPr>
+          <a:xfrm>
+            <a:off x="1208314" y="109255"/>
+            <a:ext cx="6588615" cy="4924990"/>
+          </a:xfrm>
+          <a:prstGeom prst="rect">
+            <a:avLst/>
+          </a:prstGeom>
+        </p:spPr>
+      </p:pic>
     </p:spTree>
   </p:cSld>
   <p:clrMapOvr>
@@ -6914,12 +7008,72 @@
           <a:chExt cx="0" cy="0"/>
         </a:xfrm>
       </p:grpSpPr>
+      <p:pic>
+        <p:nvPicPr>
+          <p:cNvPr id="7" name="Obrázek 6">
+            <a:extLst>
+              <a:ext uri="{FF2B5EF4-FFF2-40B4-BE49-F238E27FC236}">
+                <a16:creationId xmlns:a16="http://schemas.microsoft.com/office/drawing/2014/main" id="{14082DD6-0970-83D8-76CD-D09A70F36AD3}"/>
+              </a:ext>
+            </a:extLst>
+          </p:cNvPr>
+          <p:cNvPicPr>
+            <a:picLocks noChangeAspect="1"/>
+          </p:cNvPicPr>
+          <p:nvPr/>
+        </p:nvPicPr>
+        <p:blipFill>
+          <a:blip r:embed="rId2"/>
+          <a:stretch>
+            <a:fillRect/>
+          </a:stretch>
+        </p:blipFill>
+        <p:spPr>
+          <a:xfrm>
+            <a:off x="1152358" y="0"/>
+            <a:ext cx="6839283" cy="5143500"/>
+          </a:xfrm>
+          <a:prstGeom prst="rect">
+            <a:avLst/>
+          </a:prstGeom>
+        </p:spPr>
+      </p:pic>
+    </p:spTree>
+    <p:extLst>
+      <p:ext uri="{BB962C8B-B14F-4D97-AF65-F5344CB8AC3E}">
+        <p14:creationId xmlns:p14="http://schemas.microsoft.com/office/powerpoint/2010/main" val="1460249347"/>
+      </p:ext>
+    </p:extLst>
+  </p:cSld>
+  <p:clrMapOvr>
+    <a:masterClrMapping/>
+  </p:clrMapOvr>
+</p:sld>
+</file>
+
+<file path=ppt/slides/slide5.xml><?xml version="1.0" encoding="utf-8"?>
+<p:sld xmlns:a="http://schemas.openxmlformats.org/drawingml/2006/main" xmlns:r="http://schemas.openxmlformats.org/officeDocument/2006/relationships" xmlns:p="http://schemas.openxmlformats.org/presentationml/2006/main">
+  <p:cSld>
+    <p:spTree>
+      <p:nvGrpSpPr>
+        <p:cNvPr id="1" name=""/>
+        <p:cNvGrpSpPr/>
+        <p:nvPr/>
+      </p:nvGrpSpPr>
+      <p:grpSpPr>
+        <a:xfrm>
+          <a:off x="0" y="0"/>
+          <a:ext cx="0" cy="0"/>
+          <a:chOff x="0" y="0"/>
+          <a:chExt cx="0" cy="0"/>
+        </a:xfrm>
+      </p:grpSpPr>
       <p:sp>
         <p:nvSpPr>
           <p:cNvPr id="2" name="Nadpis 1">
             <a:extLst>
               <a:ext uri="{FF2B5EF4-FFF2-40B4-BE49-F238E27FC236}">
-                <a16:creationId xmlns:a16="http://schemas.microsoft.com/office/drawing/2014/main" id="{1E51667B-E99C-1F49-4519-E6EF5869555A}"/>
+                <a16:creationId xmlns:a16="http://schemas.microsoft.com/office/drawing/2014/main" id="{BE6F4EF9-34CC-9D80-8FC2-E688DA9CC21C}"/>
               </a:ext>
             </a:extLst>
           </p:cNvPr>
@@ -6945,11 +7099,11 @@
             </a:r>
             <a:r>
               <a:rPr lang="cs-CZ" dirty="0" err="1"/>
-              <a:t>Canvas</a:t>
+              <a:t>canvas</a:t>
             </a:r>
             <a:r>
               <a:rPr lang="cs-CZ" dirty="0"/>
-              <a:t> PREMIUM</a:t>
+              <a:t> shrnutí</a:t>
             </a:r>
           </a:p>
         </p:txBody>
@@ -6959,7 +7113,7 @@
           <p:cNvPr id="3" name="Zástupný obsah 2">
             <a:extLst>
               <a:ext uri="{FF2B5EF4-FFF2-40B4-BE49-F238E27FC236}">
-                <a16:creationId xmlns:a16="http://schemas.microsoft.com/office/drawing/2014/main" id="{73875AB3-0BBF-CF43-5C6B-423BD00606FC}"/>
+                <a16:creationId xmlns:a16="http://schemas.microsoft.com/office/drawing/2014/main" id="{E0ADB9DC-55B5-83F1-D892-38D2DF8AD5E1}"/>
               </a:ext>
             </a:extLst>
           </p:cNvPr>
@@ -6975,14 +7129,41 @@
           <a:bodyPr/>
           <a:lstStyle/>
           <a:p>
-            <a:endParaRPr lang="cs-CZ" dirty="0"/>
+            <a:r>
+              <a:rPr lang="cs-CZ" sz="2000" dirty="0"/>
+              <a:t>MVP je čistě ztrátové</a:t>
+            </a:r>
+          </a:p>
+          <a:p>
+            <a:r>
+              <a:rPr lang="cs-CZ" sz="2000" dirty="0"/>
+              <a:t>Až verze s monetizačními prvky začíná vydělávat peníze</a:t>
+            </a:r>
+          </a:p>
+          <a:p>
+            <a:r>
+              <a:rPr lang="cs-CZ" sz="2000" dirty="0"/>
+              <a:t>Aplikace počítá s trenérem</a:t>
+            </a:r>
+          </a:p>
+          <a:p>
+            <a:r>
+              <a:rPr lang="cs-CZ" sz="2000" dirty="0"/>
+              <a:t>Síťový efekt: trenér přivede klienty, ti zůstávají kvůli němu</a:t>
+            </a:r>
+          </a:p>
+          <a:p>
+            <a:r>
+              <a:rPr lang="cs-CZ" sz="2000" dirty="0"/>
+              <a:t>Aplikace nabízí uživatelům větší svobodu než konkurence</a:t>
+            </a:r>
           </a:p>
         </p:txBody>
       </p:sp>
     </p:spTree>
     <p:extLst>
       <p:ext uri="{BB962C8B-B14F-4D97-AF65-F5344CB8AC3E}">
-        <p14:creationId xmlns:p14="http://schemas.microsoft.com/office/powerpoint/2010/main" val="1460249347"/>
+        <p14:creationId xmlns:p14="http://schemas.microsoft.com/office/powerpoint/2010/main" val="2417321102"/>
       </p:ext>
     </p:extLst>
   </p:cSld>
@@ -6992,7 +7173,7 @@
 </p:sld>
 </file>
 
-<file path=ppt/slides/slide5.xml><?xml version="1.0" encoding="utf-8"?>
+<file path=ppt/slides/slide6.xml><?xml version="1.0" encoding="utf-8"?>
 <p:sld xmlns:a="http://schemas.openxmlformats.org/drawingml/2006/main" xmlns:r="http://schemas.openxmlformats.org/officeDocument/2006/relationships" xmlns:p="http://schemas.openxmlformats.org/presentationml/2006/main">
   <p:cSld>
     <p:spTree>
@@ -7105,7 +7286,7 @@
 </p:sld>
 </file>
 
-<file path=ppt/slides/slide6.xml><?xml version="1.0" encoding="utf-8"?>
+<file path=ppt/slides/slide7.xml><?xml version="1.0" encoding="utf-8"?>
 <p:sld xmlns:a="http://schemas.openxmlformats.org/drawingml/2006/main" xmlns:r="http://schemas.openxmlformats.org/officeDocument/2006/relationships" xmlns:p="http://schemas.openxmlformats.org/presentationml/2006/main">
   <p:cSld>
     <p:spTree>
@@ -7218,7 +7399,7 @@
 </p:sld>
 </file>
 
-<file path=ppt/slides/slide7.xml><?xml version="1.0" encoding="utf-8"?>
+<file path=ppt/slides/slide8.xml><?xml version="1.0" encoding="utf-8"?>
 <p:sld xmlns:a="http://schemas.openxmlformats.org/drawingml/2006/main" xmlns:r="http://schemas.openxmlformats.org/officeDocument/2006/relationships" xmlns:p="http://schemas.openxmlformats.org/presentationml/2006/main">
   <p:cSld>
     <p:spTree>
@@ -8976,7 +9157,7 @@
 </p:sld>
 </file>
 
-<file path=ppt/slides/slide8.xml><?xml version="1.0" encoding="utf-8"?>
+<file path=ppt/slides/slide9.xml><?xml version="1.0" encoding="utf-8"?>
 <p:sld xmlns:a="http://schemas.openxmlformats.org/drawingml/2006/main" xmlns:r="http://schemas.openxmlformats.org/officeDocument/2006/relationships" xmlns:p="http://schemas.openxmlformats.org/presentationml/2006/main">
   <p:cSld>
     <p:spTree>
@@ -9763,148 +9944,6 @@
     <p:extLst>
       <p:ext uri="{BB962C8B-B14F-4D97-AF65-F5344CB8AC3E}">
         <p14:creationId xmlns:p14="http://schemas.microsoft.com/office/powerpoint/2010/main" val="2468177969"/>
-      </p:ext>
-    </p:extLst>
-  </p:cSld>
-  <p:clrMapOvr>
-    <a:masterClrMapping/>
-  </p:clrMapOvr>
-</p:sld>
-</file>
-
-<file path=ppt/slides/slide9.xml><?xml version="1.0" encoding="utf-8"?>
-<p:sld xmlns:a="http://schemas.openxmlformats.org/drawingml/2006/main" xmlns:r="http://schemas.openxmlformats.org/officeDocument/2006/relationships" xmlns:p="http://schemas.openxmlformats.org/presentationml/2006/main">
-  <p:cSld>
-    <p:spTree>
-      <p:nvGrpSpPr>
-        <p:cNvPr id="1" name=""/>
-        <p:cNvGrpSpPr/>
-        <p:nvPr/>
-      </p:nvGrpSpPr>
-      <p:grpSpPr>
-        <a:xfrm>
-          <a:off x="0" y="0"/>
-          <a:ext cx="0" cy="0"/>
-          <a:chOff x="0" y="0"/>
-          <a:chExt cx="0" cy="0"/>
-        </a:xfrm>
-      </p:grpSpPr>
-      <p:sp>
-        <p:nvSpPr>
-          <p:cNvPr id="2" name="Nadpis 1">
-            <a:extLst>
-              <a:ext uri="{FF2B5EF4-FFF2-40B4-BE49-F238E27FC236}">
-                <a16:creationId xmlns:a16="http://schemas.microsoft.com/office/drawing/2014/main" id="{80BA6760-047F-1FB7-BB44-F8164DD7679C}"/>
-              </a:ext>
-            </a:extLst>
-          </p:cNvPr>
-          <p:cNvSpPr>
-            <a:spLocks noGrp="1"/>
-          </p:cNvSpPr>
-          <p:nvPr>
-            <p:ph type="title" idx="101"/>
-          </p:nvPr>
-        </p:nvSpPr>
-        <p:spPr/>
-        <p:txBody>
-          <a:bodyPr/>
-          <a:lstStyle/>
-          <a:p>
-            <a:r>
-              <a:rPr lang="cs-CZ" dirty="0"/>
-              <a:t>Náklady celkem</a:t>
-            </a:r>
-          </a:p>
-        </p:txBody>
-      </p:sp>
-      <p:sp>
-        <p:nvSpPr>
-          <p:cNvPr id="3" name="Zástupný obsah 2">
-            <a:extLst>
-              <a:ext uri="{FF2B5EF4-FFF2-40B4-BE49-F238E27FC236}">
-                <a16:creationId xmlns:a16="http://schemas.microsoft.com/office/drawing/2014/main" id="{8033CCD9-B606-29AF-BDA1-77E2FB18590C}"/>
-              </a:ext>
-            </a:extLst>
-          </p:cNvPr>
-          <p:cNvSpPr>
-            <a:spLocks noGrp="1"/>
-          </p:cNvSpPr>
-          <p:nvPr>
-            <p:ph idx="102"/>
-          </p:nvPr>
-        </p:nvSpPr>
-        <p:spPr/>
-        <p:txBody>
-          <a:bodyPr/>
-          <a:lstStyle/>
-          <a:p>
-            <a:r>
-              <a:rPr lang="cs-CZ" sz="2400" dirty="0"/>
-              <a:t>MVP – 1 189 616 Kč</a:t>
-            </a:r>
-          </a:p>
-          <a:p>
-            <a:r>
-              <a:rPr lang="cs-CZ" sz="2400" dirty="0"/>
-              <a:t>PREMIUM – 347 083 Kč</a:t>
-            </a:r>
-          </a:p>
-          <a:p>
-            <a:endParaRPr lang="cs-CZ" sz="2400" dirty="0"/>
-          </a:p>
-          <a:p>
-            <a:r>
-              <a:rPr lang="cs-CZ" sz="2400" dirty="0"/>
-              <a:t>Provozní náklady CCA 20 892 Kč/</a:t>
-            </a:r>
-            <a:r>
-              <a:rPr lang="cs-CZ" sz="2400" dirty="0" err="1"/>
-              <a:t>měs</a:t>
-            </a:r>
-            <a:endParaRPr lang="cs-CZ" sz="2400" dirty="0"/>
-          </a:p>
-          <a:p>
-            <a:pPr marL="342900" indent="-342900">
-              <a:buFont typeface="Arial" panose="020B0604020202020204" pitchFamily="34" charset="0"/>
-              <a:buChar char="•"/>
-            </a:pPr>
-            <a:r>
-              <a:rPr lang="cs-CZ" sz="2400" dirty="0"/>
-              <a:t>Pro 5250 aktivních uživatelů</a:t>
-            </a:r>
-          </a:p>
-          <a:p>
-            <a:r>
-              <a:rPr lang="cs-CZ" sz="2400" dirty="0"/>
-              <a:t>Výnosy pro 5000 uživatelů tvoří 15 120 Kč/</a:t>
-            </a:r>
-            <a:r>
-              <a:rPr lang="cs-CZ" sz="2400" dirty="0" err="1"/>
-              <a:t>měs</a:t>
-            </a:r>
-            <a:endParaRPr lang="cs-CZ" sz="2400" dirty="0"/>
-          </a:p>
-          <a:p>
-            <a:pPr marL="342900" indent="-342900">
-              <a:buFont typeface="Arial" panose="020B0604020202020204" pitchFamily="34" charset="0"/>
-              <a:buChar char="•"/>
-            </a:pPr>
-            <a:r>
-              <a:rPr lang="cs-CZ" sz="2400" dirty="0"/>
-              <a:t>Od 10 000 aktivních uživatelů 32 470 Kč/</a:t>
-            </a:r>
-            <a:r>
-              <a:rPr lang="cs-CZ" sz="2400" dirty="0" err="1"/>
-              <a:t>měs</a:t>
-            </a:r>
-            <a:endParaRPr lang="cs-CZ" sz="2400" dirty="0"/>
-          </a:p>
-        </p:txBody>
-      </p:sp>
-    </p:spTree>
-    <p:extLst>
-      <p:ext uri="{BB962C8B-B14F-4D97-AF65-F5344CB8AC3E}">
-        <p14:creationId xmlns:p14="http://schemas.microsoft.com/office/powerpoint/2010/main" val="3316525007"/>
       </p:ext>
     </p:extLst>
   </p:cSld>

</xml_diff>

<commit_message>
Pridany linky do prezentace
</commit_message>
<xml_diff>
--- a/Docs/TrainLoop_prezentace.pptx
+++ b/Docs/TrainLoop_prezentace.pptx
@@ -1319,7 +1319,7 @@
           </a:prstGeom>
           <a:extLst>
             <a:ext uri="{C572A759-6A51-4108-AA02-DFA0A04FC94B}">
-              <ma14:wrappingTextBoxFlag xmlns:ma14="http://schemas.microsoft.com/office/mac/drawingml/2011/main" xmlns="" val="0"/>
+              <ma14:wrappingTextBoxFlag xmlns="" xmlns:ma14="http://schemas.microsoft.com/office/mac/drawingml/2011/main" val="0"/>
             </a:ext>
           </a:extLst>
         </p:spPr>
@@ -1523,7 +1523,7 @@
           </a:prstGeom>
           <a:extLst>
             <a:ext uri="{C572A759-6A51-4108-AA02-DFA0A04FC94B}">
-              <ma14:wrappingTextBoxFlag xmlns:ma14="http://schemas.microsoft.com/office/mac/drawingml/2011/main" xmlns="" val="0"/>
+              <ma14:wrappingTextBoxFlag xmlns="" xmlns:ma14="http://schemas.microsoft.com/office/mac/drawingml/2011/main" val="0"/>
             </a:ext>
           </a:extLst>
         </p:spPr>
@@ -1598,7 +1598,7 @@
           </a:prstGeom>
           <a:extLst>
             <a:ext uri="{C572A759-6A51-4108-AA02-DFA0A04FC94B}">
-              <ma14:wrappingTextBoxFlag xmlns:ma14="http://schemas.microsoft.com/office/mac/drawingml/2011/main" xmlns="" val="0"/>
+              <ma14:wrappingTextBoxFlag xmlns="" xmlns:ma14="http://schemas.microsoft.com/office/mac/drawingml/2011/main" val="0"/>
             </a:ext>
           </a:extLst>
         </p:spPr>
@@ -1971,14 +1971,6 @@
             <a:pPr marL="0" indent="0">
               <a:buNone/>
             </a:pPr>
-            <a:r>
-              <a:rPr lang="en-US" sz="2000" dirty="0">
-                <a:solidFill>
-                  <a:schemeClr val="bg2"/>
-                </a:solidFill>
-              </a:rPr>
-              <a:t>Plánovač a tréninkový deník pro psa · Tým 7</a:t>
-            </a:r>
             <a:endParaRPr lang="en-US" sz="2000" dirty="0"/>
           </a:p>
         </p:txBody>
@@ -2210,7 +2202,7 @@
           </a:prstGeom>
           <a:extLst>
             <a:ext uri="{C572A759-6A51-4108-AA02-DFA0A04FC94B}">
-              <ma14:wrappingTextBoxFlag xmlns:ma14="http://schemas.microsoft.com/office/mac/drawingml/2011/main" xmlns="" val="0"/>
+              <ma14:wrappingTextBoxFlag xmlns="" xmlns:ma14="http://schemas.microsoft.com/office/mac/drawingml/2011/main" val="0"/>
             </a:ext>
           </a:extLst>
         </p:spPr>
@@ -3631,7 +3623,7 @@
           </a:prstGeom>
           <a:extLst>
             <a:ext uri="{C572A759-6A51-4108-AA02-DFA0A04FC94B}">
-              <ma14:wrappingTextBoxFlag xmlns:ma14="http://schemas.microsoft.com/office/mac/drawingml/2011/main" xmlns="" val="0"/>
+              <ma14:wrappingTextBoxFlag xmlns="" xmlns:ma14="http://schemas.microsoft.com/office/mac/drawingml/2011/main" val="0"/>
             </a:ext>
           </a:extLst>
         </p:spPr>
@@ -5176,7 +5168,7 @@
           </a:prstGeom>
           <a:extLst>
             <a:ext uri="{C572A759-6A51-4108-AA02-DFA0A04FC94B}">
-              <ma14:wrappingTextBoxFlag xmlns:ma14="http://schemas.microsoft.com/office/mac/drawingml/2011/main" xmlns="" val="0"/>
+              <ma14:wrappingTextBoxFlag xmlns="" xmlns:ma14="http://schemas.microsoft.com/office/mac/drawingml/2011/main" val="0"/>
             </a:ext>
           </a:extLst>
         </p:spPr>
@@ -5894,7 +5886,7 @@
           </a:prstGeom>
           <a:extLst>
             <a:ext uri="{C572A759-6A51-4108-AA02-DFA0A04FC94B}">
-              <ma14:wrappingTextBoxFlag xmlns:ma14="http://schemas.microsoft.com/office/mac/drawingml/2011/main" xmlns="" val="0"/>
+              <ma14:wrappingTextBoxFlag xmlns="" xmlns:ma14="http://schemas.microsoft.com/office/mac/drawingml/2011/main" val="0"/>
             </a:ext>
           </a:extLst>
         </p:spPr>
@@ -6004,7 +5996,7 @@
           </a:prstGeom>
           <a:extLst>
             <a:ext uri="{C572A759-6A51-4108-AA02-DFA0A04FC94B}">
-              <ma14:wrappingTextBoxFlag xmlns:ma14="http://schemas.microsoft.com/office/mac/drawingml/2011/main" xmlns="" val="0"/>
+              <ma14:wrappingTextBoxFlag xmlns="" xmlns:ma14="http://schemas.microsoft.com/office/mac/drawingml/2011/main" val="0"/>
             </a:ext>
           </a:extLst>
         </p:spPr>
@@ -6026,6 +6018,41 @@
               <a:t>15</a:t>
             </a:fld>
             <a:endParaRPr lang="en-US"/>
+          </a:p>
+        </p:txBody>
+      </p:sp>
+      <p:sp>
+        <p:nvSpPr>
+          <p:cNvPr id="3" name="TextBox 2">
+            <a:extLst>
+              <a:ext uri="{FF2B5EF4-FFF2-40B4-BE49-F238E27FC236}">
+                <a16:creationId xmlns:a16="http://schemas.microsoft.com/office/drawing/2014/main" id="{59DDDCD6-F0DF-3A0B-5D2A-A2659601B8B3}"/>
+              </a:ext>
+            </a:extLst>
+          </p:cNvPr>
+          <p:cNvSpPr txBox="1"/>
+          <p:nvPr/>
+        </p:nvSpPr>
+        <p:spPr>
+          <a:xfrm>
+            <a:off x="2426677" y="1448972"/>
+            <a:ext cx="5352757" cy="646331"/>
+          </a:xfrm>
+          <a:prstGeom prst="rect">
+            <a:avLst/>
+          </a:prstGeom>
+          <a:noFill/>
+        </p:spPr>
+        <p:txBody>
+          <a:bodyPr wrap="square" rtlCol="0">
+            <a:spAutoFit/>
+          </a:bodyPr>
+          <a:lstStyle/>
+          <a:p>
+            <a:r>
+              <a:rPr lang="cs-CZ" dirty="0"/>
+              <a:t>https://github.com/orgs/applifting-vsecourse/projects/17</a:t>
+            </a:r>
           </a:p>
         </p:txBody>
       </p:sp>
@@ -6115,9 +6142,24 @@
           <a:bodyPr wrap="square" rtlCol="0"/>
           <a:lstStyle/>
           <a:p>
-            <a:pPr marL="0" indent="0">
-              <a:buNone/>
-            </a:pPr>
+            <a:r>
+              <a:rPr lang="cs-CZ" dirty="0">
+                <a:hlinkClick r:id="rId3"/>
+              </a:rPr>
+              <a:t>Sitemap</a:t>
+            </a:r>
+            <a:endParaRPr lang="cs-CZ" dirty="0"/>
+          </a:p>
+          <a:p>
+            <a:endParaRPr lang="cs-CZ" sz="1400" dirty="0"/>
+          </a:p>
+          <a:p>
+            <a:r>
+              <a:rPr lang="cs-CZ" dirty="0">
+                <a:hlinkClick r:id="rId4"/>
+              </a:rPr>
+              <a:t>První high fidelity obrazovky</a:t>
+            </a:r>
             <a:endParaRPr lang="en-US" sz="1400" dirty="0"/>
           </a:p>
         </p:txBody>
@@ -6142,7 +6184,7 @@
           </a:prstGeom>
           <a:extLst>
             <a:ext uri="{C572A759-6A51-4108-AA02-DFA0A04FC94B}">
-              <ma14:wrappingTextBoxFlag xmlns:ma14="http://schemas.microsoft.com/office/mac/drawingml/2011/main" xmlns="" val="0"/>
+              <ma14:wrappingTextBoxFlag xmlns="" xmlns:ma14="http://schemas.microsoft.com/office/mac/drawingml/2011/main" val="0"/>
             </a:ext>
           </a:extLst>
         </p:spPr>
@@ -6858,7 +6900,7 @@
           </a:prstGeom>
           <a:extLst>
             <a:ext uri="{C572A759-6A51-4108-AA02-DFA0A04FC94B}">
-              <ma14:wrappingTextBoxFlag xmlns:ma14="http://schemas.microsoft.com/office/mac/drawingml/2011/main" xmlns="" val="0"/>
+              <ma14:wrappingTextBoxFlag xmlns="" xmlns:ma14="http://schemas.microsoft.com/office/mac/drawingml/2011/main" val="0"/>
             </a:ext>
           </a:extLst>
         </p:spPr>
@@ -6928,7 +6970,7 @@
           </a:prstGeom>
           <a:extLst>
             <a:ext uri="{C572A759-6A51-4108-AA02-DFA0A04FC94B}">
-              <ma14:wrappingTextBoxFlag xmlns:ma14="http://schemas.microsoft.com/office/mac/drawingml/2011/main" xmlns="" val="0"/>
+              <ma14:wrappingTextBoxFlag xmlns="" xmlns:ma14="http://schemas.microsoft.com/office/mac/drawingml/2011/main" val="0"/>
             </a:ext>
           </a:extLst>
         </p:spPr>

</xml_diff>